<commit_message>
Deck: show full repo paths for every file mentioned
Co-authored-by: Cursor <cursoragent@cursor.com>
</commit_message>
<xml_diff>
--- a/docs/training-standards.pptx
+++ b/docs/training-standards.pptx
@@ -120,19 +120,19 @@
   <p:extLst>
     <p:ext uri="{521415D9-36F7-43E2-AB2F-B90AF26B5E84}">
       <p14:sectionLst xmlns:p14="http://schemas.microsoft.com/office/powerpoint/2010/main">
-        <p14:section name="Intro" id="{50668ef0-ec5a-3f68-c9b6-132ce37234d9}">
+        <p14:section name="Intro" id="{f446ceb9-4852-00d8-b4c0-3239a4d48b1f}">
           <p14:sldIdLst>
             <p14:sldId id="256"/>
             <p14:sldId id="257"/>
           </p14:sldIdLst>
         </p14:section>
-        <p14:section name="Backend" id="{4920caf5-215d-e756-d001-a65d2b6a627e}">
+        <p14:section name="Backend" id="{104c24d1-bd61-03a7-12fd-0217eee9d8d4}">
           <p14:sldIdLst>
             <p14:sldId id="258"/>
             <p14:sldId id="259"/>
           </p14:sldIdLst>
         </p14:section>
-        <p14:section name="Frontend" id="{d27a7d6e-6c7f-f2d8-9458-c0912230db4a}">
+        <p14:section name="Frontend" id="{0a61b297-b4af-10a1-8125-2fca5312b195}">
           <p14:sldIdLst>
             <p14:sldId id="260"/>
             <p14:sldId id="261"/>
@@ -142,13 +142,13 @@
             <p14:sldId id="265"/>
           </p14:sldIdLst>
         </p14:section>
-        <p14:section name="Pages" id="{984731e0-2748-dae2-f7a6-41310938e948}">
+        <p14:section name="Pages" id="{ee645d21-89f9-9ab7-9602-7cfae371cedf}">
           <p14:sldIdLst>
             <p14:sldId id="266"/>
             <p14:sldId id="267"/>
           </p14:sldIdLst>
         </p14:section>
-        <p14:section name="Checklist" id="{c7229ff4-e53d-4b81-4e43-d90a3c864bb6}">
+        <p14:section name="Checklist" id="{1cde8afa-f3e6-c4fb-cb0c-8e0b9e51e943}">
           <p14:sldIdLst>
             <p14:sldId id="268"/>
             <p14:sldId id="269"/>
@@ -734,7 +734,7 @@
           <a:p>
             <a:r>
               <a:rPr lang="en-US" dirty="0"/>
-              <a:t>Copy an existing list (users, custom notifications, notification transactions) rather than inventing a pager. core/ui has table-pager and paged-list ready to use.</a:t>
+              <a:t>Copy an existing list (users, custom notifications, notification transactions) rather than inventing a pager. TrainingModule/src/app/core/ui has table-pager and paged-list ready to use. The showcase list (/admin/showcase) is the reference.</a:t>
             </a:r>
             <a:endParaRPr lang="en-US" dirty="0"/>
           </a:p>
@@ -1174,7 +1174,7 @@
           <a:p>
             <a:r>
               <a:rPr lang="en-US" dirty="0"/>
-              <a:t>Controllers never talk to CHDBContext directly. Register new services in Common/ServiceExtensions.cs. Keep controllers thin so rules can be unit-tested in Bidding_Core.Tests.</a:t>
+              <a:t>Controllers never talk to CHDBContext directly. Register new services in Bidding_API/Common/ServiceExtensions.cs. Keep controllers thin so rules can be unit-tested in Bidding_Core.Tests.</a:t>
             </a:r>
             <a:endParaRPr lang="en-US" dirty="0"/>
           </a:p>
@@ -1526,7 +1526,7 @@
           <a:p>
             <a:r>
               <a:rPr lang="en-US" dirty="0"/>
-              <a:t>The pipeline lives in core/ui/form-pipeline.service.ts. The page never calls markAllAsTouched, never sets a loading flag and never shows a toast itself. Each stop returns a reason so the page can react if it needs to, but most pages just return.</a:t>
+              <a:t>The pipeline lives in TrainingModule/src/app/core/ui/form-pipeline.service.ts. The page never calls markAllAsTouched, never sets a loading flag and never shows a toast itself. Each stop returns a reason so the page can react if it needs to, but most pages just return.</a:t>
             </a:r>
             <a:endParaRPr lang="en-US" dirty="0"/>
           </a:p>
@@ -2577,11 +2577,11 @@
         <p:spPr>
           <a:xfrm>
             <a:off x="548640" y="1463040"/>
-            <a:ext cx="3566160" cy="3566160"/>
+            <a:ext cx="3566160" cy="3108960"/>
           </a:xfrm>
           <a:prstGeom prst="roundRect">
             <a:avLst>
-              <a:gd name="adj" fmla="val 3077"/>
+              <a:gd name="adj" fmla="val 3529"/>
             </a:avLst>
           </a:prstGeom>
           <a:solidFill>
@@ -2701,7 +2701,7 @@
         <p:spPr>
           <a:xfrm>
             <a:off x="822960" y="2377440"/>
-            <a:ext cx="3063240" cy="2468880"/>
+            <a:ext cx="3063240" cy="2011680"/>
           </a:xfrm>
           <a:prstGeom prst="rect">
             <a:avLst/>
@@ -2777,11 +2777,11 @@
         <p:spPr>
           <a:xfrm>
             <a:off x="4297680" y="1463040"/>
-            <a:ext cx="3566160" cy="3566160"/>
+            <a:ext cx="3566160" cy="3108960"/>
           </a:xfrm>
           <a:prstGeom prst="roundRect">
             <a:avLst>
-              <a:gd name="adj" fmla="val 3077"/>
+              <a:gd name="adj" fmla="val 3529"/>
             </a:avLst>
           </a:prstGeom>
           <a:solidFill>
@@ -2901,7 +2901,7 @@
         <p:spPr>
           <a:xfrm>
             <a:off x="4572000" y="2377440"/>
-            <a:ext cx="3063240" cy="2468880"/>
+            <a:ext cx="3063240" cy="2011680"/>
           </a:xfrm>
           <a:prstGeom prst="rect">
             <a:avLst/>
@@ -2977,11 +2977,11 @@
         <p:spPr>
           <a:xfrm>
             <a:off x="8046720" y="1463040"/>
-            <a:ext cx="3566160" cy="3566160"/>
+            <a:ext cx="3566160" cy="3108960"/>
           </a:xfrm>
           <a:prstGeom prst="roundRect">
             <a:avLst>
-              <a:gd name="adj" fmla="val 3077"/>
+              <a:gd name="adj" fmla="val 3529"/>
             </a:avLst>
           </a:prstGeom>
           <a:solidFill>
@@ -3101,7 +3101,7 @@
         <p:spPr>
           <a:xfrm>
             <a:off x="8321040" y="2377440"/>
-            <a:ext cx="3063240" cy="2468880"/>
+            <a:ext cx="3063240" cy="2011680"/>
           </a:xfrm>
           <a:prstGeom prst="rect">
             <a:avLst/>
@@ -3183,6 +3183,233 @@
               <a:t>RTL / LTR set by LocaleService</a:t>
             </a:r>
             <a:endParaRPr lang="en-US" sz="1500" dirty="0"/>
+          </a:p>
+        </p:txBody>
+      </p:sp>
+      <p:sp>
+        <p:nvSpPr>
+          <p:cNvPr id="18" name="state-files"/>
+          <p:cNvSpPr/>
+          <p:nvPr/>
+        </p:nvSpPr>
+        <p:spPr>
+          <a:xfrm>
+            <a:off x="548640" y="4754880"/>
+            <a:ext cx="11064240" cy="1463040"/>
+          </a:xfrm>
+          <a:prstGeom prst="roundRect">
+            <a:avLst>
+              <a:gd name="adj" fmla="val 6250"/>
+            </a:avLst>
+          </a:prstGeom>
+          <a:solidFill>
+            <a:schemeClr val="bg2"/>
+          </a:solidFill>
+          <a:ln w="12700">
+            <a:solidFill>
+              <a:schemeClr val="bg2"/>
+            </a:solidFill>
+            <a:prstDash val="solid"/>
+          </a:ln>
+        </p:spPr>
+      </p:sp>
+      <p:sp>
+        <p:nvSpPr>
+          <p:cNvPr id="19" name="state-files-label"/>
+          <p:cNvSpPr txBox="1"/>
+          <p:nvPr/>
+        </p:nvSpPr>
+        <p:spPr>
+          <a:xfrm>
+            <a:off x="777240" y="4864608"/>
+            <a:ext cx="914400" cy="274320"/>
+          </a:xfrm>
+          <a:prstGeom prst="rect">
+            <a:avLst/>
+          </a:prstGeom>
+          <a:noFill/>
+          <a:ln/>
+        </p:spPr>
+        <p:txBody>
+          <a:bodyPr wrap="square" lIns="0" tIns="0" rIns="0" bIns="0" rtlCol="0" anchor="ctr"/>
+          <a:lstStyle/>
+          <a:p>
+            <a:pPr indent="0" marL="0">
+              <a:buNone/>
+            </a:pPr>
+            <a:r>
+              <a:rPr lang="en-US" sz="1200" b="1" dirty="0">
+                <a:solidFill>
+                  <a:schemeClr val="accent2"/>
+                </a:solidFill>
+              </a:rPr>
+              <a:t>Files</a:t>
+            </a:r>
+            <a:endParaRPr lang="en-US" sz="1200" dirty="0"/>
+          </a:p>
+        </p:txBody>
+      </p:sp>
+      <p:sp>
+        <p:nvSpPr>
+          <p:cNvPr id="20" name="state-files-0"/>
+          <p:cNvSpPr txBox="1"/>
+          <p:nvPr/>
+        </p:nvSpPr>
+        <p:spPr>
+          <a:xfrm>
+            <a:off x="777240" y="5166360"/>
+            <a:ext cx="5212080" cy="960120"/>
+          </a:xfrm>
+          <a:prstGeom prst="rect">
+            <a:avLst/>
+          </a:prstGeom>
+          <a:noFill/>
+          <a:ln/>
+        </p:spPr>
+        <p:txBody>
+          <a:bodyPr wrap="square" lIns="0" tIns="0" rIns="0" bIns="0" rtlCol="0" anchor="t"/>
+          <a:lstStyle/>
+          <a:p>
+            <a:pPr indent="0" marL="0">
+              <a:spcAft>
+                <a:spcPts val="300"/>
+              </a:spcAft>
+              <a:buNone/>
+            </a:pPr>
+            <a:r>
+              <a:rPr lang="en-US" sz="950" dirty="0">
+                <a:solidFill>
+                  <a:schemeClr val="tx2"/>
+                </a:solidFill>
+                <a:latin typeface="Courier New" pitchFamily="34" charset="0"/>
+                <a:ea typeface="Courier New" pitchFamily="34" charset="-122"/>
+                <a:cs typeface="Courier New" pitchFamily="34" charset="-120"/>
+              </a:rPr>
+              <a:t>TrainingModule/src/app/core/store/&lt;feature&gt;/</a:t>
+            </a:r>
+            <a:endParaRPr lang="en-US" sz="950" dirty="0"/>
+          </a:p>
+          <a:p>
+            <a:pPr indent="0" marL="0">
+              <a:spcAft>
+                <a:spcPts val="300"/>
+              </a:spcAft>
+              <a:buNone/>
+            </a:pPr>
+            <a:r>
+              <a:rPr lang="en-US" sz="950" dirty="0">
+                <a:solidFill>
+                  <a:schemeClr val="tx2"/>
+                </a:solidFill>
+                <a:latin typeface="Courier New" pitchFamily="34" charset="0"/>
+                <a:ea typeface="Courier New" pitchFamily="34" charset="-122"/>
+                <a:cs typeface="Courier New" pitchFamily="34" charset="-120"/>
+              </a:rPr>
+              <a:t>TrainingModule/src/app/app.config.ts  (provideState)</a:t>
+            </a:r>
+            <a:endParaRPr lang="en-US" sz="950" dirty="0"/>
+          </a:p>
+          <a:p>
+            <a:pPr indent="0" marL="0">
+              <a:spcAft>
+                <a:spcPts val="300"/>
+              </a:spcAft>
+              <a:buNone/>
+            </a:pPr>
+            <a:r>
+              <a:rPr lang="en-US" sz="950" dirty="0">
+                <a:solidFill>
+                  <a:schemeClr val="tx2"/>
+                </a:solidFill>
+                <a:latin typeface="Courier New" pitchFamily="34" charset="0"/>
+                <a:ea typeface="Courier New" pitchFamily="34" charset="-122"/>
+                <a:cs typeface="Courier New" pitchFamily="34" charset="-120"/>
+              </a:rPr>
+              <a:t>TrainingModule/src/app/core/auth/auth.service.ts  (logout clears)</a:t>
+            </a:r>
+            <a:endParaRPr lang="en-US" sz="950" dirty="0"/>
+          </a:p>
+        </p:txBody>
+      </p:sp>
+      <p:sp>
+        <p:nvSpPr>
+          <p:cNvPr id="21" name="state-files-1"/>
+          <p:cNvSpPr txBox="1"/>
+          <p:nvPr/>
+        </p:nvSpPr>
+        <p:spPr>
+          <a:xfrm>
+            <a:off x="6080760" y="5166360"/>
+            <a:ext cx="5212080" cy="960120"/>
+          </a:xfrm>
+          <a:prstGeom prst="rect">
+            <a:avLst/>
+          </a:prstGeom>
+          <a:noFill/>
+          <a:ln/>
+        </p:spPr>
+        <p:txBody>
+          <a:bodyPr wrap="square" lIns="0" tIns="0" rIns="0" bIns="0" rtlCol="0" anchor="t"/>
+          <a:lstStyle/>
+          <a:p>
+            <a:pPr indent="0" marL="0">
+              <a:spcAft>
+                <a:spcPts val="300"/>
+              </a:spcAft>
+              <a:buNone/>
+            </a:pPr>
+            <a:r>
+              <a:rPr lang="en-US" sz="950" dirty="0">
+                <a:solidFill>
+                  <a:schemeClr val="tx2"/>
+                </a:solidFill>
+                <a:latin typeface="Courier New" pitchFamily="34" charset="0"/>
+                <a:ea typeface="Courier New" pitchFamily="34" charset="-122"/>
+                <a:cs typeface="Courier New" pitchFamily="34" charset="-120"/>
+              </a:rPr>
+              <a:t>TrainingModule/src/app/core/translations/&lt;area&gt;/messages.ar.json</a:t>
+            </a:r>
+            <a:endParaRPr lang="en-US" sz="950" dirty="0"/>
+          </a:p>
+          <a:p>
+            <a:pPr indent="0" marL="0">
+              <a:spcAft>
+                <a:spcPts val="300"/>
+              </a:spcAft>
+              <a:buNone/>
+            </a:pPr>
+            <a:r>
+              <a:rPr lang="en-US" sz="950" dirty="0">
+                <a:solidFill>
+                  <a:schemeClr val="tx2"/>
+                </a:solidFill>
+                <a:latin typeface="Courier New" pitchFamily="34" charset="0"/>
+                <a:ea typeface="Courier New" pitchFamily="34" charset="-122"/>
+                <a:cs typeface="Courier New" pitchFamily="34" charset="-120"/>
+              </a:rPr>
+              <a:t>TrainingModule/src/app/core/translations/merge-ar-translations.ts</a:t>
+            </a:r>
+            <a:endParaRPr lang="en-US" sz="950" dirty="0"/>
+          </a:p>
+          <a:p>
+            <a:pPr indent="0" marL="0">
+              <a:spcAft>
+                <a:spcPts val="300"/>
+              </a:spcAft>
+              <a:buNone/>
+            </a:pPr>
+            <a:r>
+              <a:rPr lang="en-US" sz="950" dirty="0">
+                <a:solidFill>
+                  <a:schemeClr val="tx2"/>
+                </a:solidFill>
+                <a:latin typeface="Courier New" pitchFamily="34" charset="0"/>
+                <a:ea typeface="Courier New" pitchFamily="34" charset="-122"/>
+                <a:cs typeface="Courier New" pitchFamily="34" charset="-120"/>
+              </a:rPr>
+              <a:t>TrainingModule/src/app/core/locale/locale.service.ts</a:t>
+            </a:r>
+            <a:endParaRPr lang="en-US" sz="950" dirty="0"/>
           </a:p>
         </p:txBody>
       </p:sp>
@@ -3887,7 +4114,7 @@
         <p:spPr>
           <a:xfrm>
             <a:off x="7498080" y="1463040"/>
-            <a:ext cx="4114800" cy="4480560"/>
+            <a:ext cx="4114800" cy="3108960"/>
           </a:xfrm>
           <a:prstGeom prst="rect">
             <a:avLst/>
@@ -3901,110 +4128,255 @@
           <a:p>
             <a:pPr marL="342900" indent="-342900">
               <a:spcAft>
-                <a:spcPts val="1000"/>
+                <a:spcPts val="600"/>
               </a:spcAft>
               <a:buSzPct val="100000"/>
               <a:buChar char="•"/>
             </a:pPr>
             <a:r>
-              <a:rPr lang="en-US" sz="1600" dirty="0">
+              <a:rPr lang="en-US" sz="1500" dirty="0">
                 <a:solidFill>
                   <a:schemeClr val="tx1"/>
                 </a:solidFill>
               </a:rPr>
               <a:t>Server-side paging: pageIndex, pageSize and query go to the API</a:t>
             </a:r>
-            <a:endParaRPr lang="en-US" sz="1600" dirty="0"/>
+            <a:endParaRPr lang="en-US" sz="1500" dirty="0"/>
           </a:p>
           <a:p>
             <a:pPr marL="342900" indent="-342900">
               <a:spcAft>
-                <a:spcPts val="1000"/>
+                <a:spcPts val="600"/>
               </a:spcAft>
               <a:buSzPct val="100000"/>
               <a:buChar char="•"/>
             </a:pPr>
             <a:r>
-              <a:rPr lang="en-US" sz="1600" dirty="0">
+              <a:rPr lang="en-US" sz="1500" dirty="0">
                 <a:solidFill>
                   <a:schemeClr val="tx1"/>
                 </a:solidFill>
               </a:rPr>
               <a:t>Page sizes 5 / 10 / 15, default 5</a:t>
             </a:r>
-            <a:endParaRPr lang="en-US" sz="1600" dirty="0"/>
+            <a:endParaRPr lang="en-US" sz="1500" dirty="0"/>
           </a:p>
           <a:p>
             <a:pPr marL="342900" indent="-342900">
               <a:spcAft>
-                <a:spcPts val="1000"/>
+                <a:spcPts val="600"/>
               </a:spcAft>
               <a:buSzPct val="100000"/>
               <a:buChar char="•"/>
             </a:pPr>
             <a:r>
-              <a:rPr lang="en-US" sz="1600" dirty="0">
+              <a:rPr lang="en-US" sz="1500" dirty="0">
                 <a:solidFill>
                   <a:schemeClr val="tx1"/>
                 </a:solidFill>
               </a:rPr>
               <a:t>First column # is page-aware</a:t>
             </a:r>
-            <a:endParaRPr lang="en-US" sz="1600" dirty="0"/>
+            <a:endParaRPr lang="en-US" sz="1500" dirty="0"/>
           </a:p>
           <a:p>
             <a:pPr marL="342900" indent="-342900">
               <a:spcAft>
-                <a:spcPts val="1000"/>
+                <a:spcPts val="600"/>
               </a:spcAft>
               <a:buSzPct val="100000"/>
               <a:buChar char="•"/>
             </a:pPr>
             <a:r>
-              <a:rPr lang="en-US" sz="1600" dirty="0">
+              <a:rPr lang="en-US" sz="1500" dirty="0">
                 <a:solidFill>
                   <a:schemeClr val="tx1"/>
                 </a:solidFill>
               </a:rPr>
               <a:t>Search on change (≈300 ms), no Search button</a:t>
             </a:r>
-            <a:endParaRPr lang="en-US" sz="1600" dirty="0"/>
+            <a:endParaRPr lang="en-US" sz="1500" dirty="0"/>
           </a:p>
           <a:p>
             <a:pPr marL="342900" indent="-342900">
               <a:spcAft>
-                <a:spcPts val="1000"/>
+                <a:spcPts val="600"/>
               </a:spcAft>
               <a:buSzPct val="100000"/>
               <a:buChar char="•"/>
             </a:pPr>
             <a:r>
-              <a:rPr lang="en-US" sz="1600" dirty="0">
+              <a:rPr lang="en-US" sz="1500" dirty="0">
                 <a:solidFill>
                   <a:schemeClr val="tx1"/>
                 </a:solidFill>
               </a:rPr>
               <a:t>Filter drawer on mobile, table becomes cards below lg</a:t>
             </a:r>
-            <a:endParaRPr lang="en-US" sz="1600" dirty="0"/>
+            <a:endParaRPr lang="en-US" sz="1500" dirty="0"/>
           </a:p>
           <a:p>
             <a:pPr marL="342900" indent="-342900">
               <a:spcAft>
-                <a:spcPts val="1000"/>
+                <a:spcPts val="600"/>
               </a:spcAft>
               <a:buSzPct val="100000"/>
               <a:buChar char="•"/>
             </a:pPr>
             <a:r>
-              <a:rPr lang="en-US" sz="1600" dirty="0">
+              <a:rPr lang="en-US" sz="1500" dirty="0">
                 <a:solidFill>
                   <a:schemeClr val="tx1"/>
                 </a:solidFill>
               </a:rPr>
               <a:t>Reset to page 1 when filters change</a:t>
             </a:r>
-            <a:endParaRPr lang="en-US" sz="1600" dirty="0"/>
+            <a:endParaRPr lang="en-US" sz="1500" dirty="0"/>
+          </a:p>
+        </p:txBody>
+      </p:sp>
+      <p:sp>
+        <p:nvSpPr>
+          <p:cNvPr id="23" name="list-files"/>
+          <p:cNvSpPr/>
+          <p:nvPr/>
+        </p:nvSpPr>
+        <p:spPr>
+          <a:xfrm>
+            <a:off x="7498080" y="4617720"/>
+            <a:ext cx="4114800" cy="1325880"/>
+          </a:xfrm>
+          <a:prstGeom prst="roundRect">
+            <a:avLst>
+              <a:gd name="adj" fmla="val 6897"/>
+            </a:avLst>
+          </a:prstGeom>
+          <a:solidFill>
+            <a:schemeClr val="bg2"/>
+          </a:solidFill>
+          <a:ln w="12700">
+            <a:solidFill>
+              <a:schemeClr val="bg2"/>
+            </a:solidFill>
+            <a:prstDash val="solid"/>
+          </a:ln>
+        </p:spPr>
+      </p:sp>
+      <p:sp>
+        <p:nvSpPr>
+          <p:cNvPr id="24" name="list-files-label"/>
+          <p:cNvSpPr txBox="1"/>
+          <p:nvPr/>
+        </p:nvSpPr>
+        <p:spPr>
+          <a:xfrm>
+            <a:off x="7726680" y="4727448"/>
+            <a:ext cx="914400" cy="274320"/>
+          </a:xfrm>
+          <a:prstGeom prst="rect">
+            <a:avLst/>
+          </a:prstGeom>
+          <a:noFill/>
+          <a:ln/>
+        </p:spPr>
+        <p:txBody>
+          <a:bodyPr wrap="square" lIns="0" tIns="0" rIns="0" bIns="0" rtlCol="0" anchor="ctr"/>
+          <a:lstStyle/>
+          <a:p>
+            <a:pPr indent="0" marL="0">
+              <a:buNone/>
+            </a:pPr>
+            <a:r>
+              <a:rPr lang="en-US" sz="1200" b="1" dirty="0">
+                <a:solidFill>
+                  <a:schemeClr val="accent2"/>
+                </a:solidFill>
+              </a:rPr>
+              <a:t>Files</a:t>
+            </a:r>
+            <a:endParaRPr lang="en-US" sz="1200" dirty="0"/>
+          </a:p>
+        </p:txBody>
+      </p:sp>
+      <p:sp>
+        <p:nvSpPr>
+          <p:cNvPr id="25" name="list-files-0"/>
+          <p:cNvSpPr txBox="1"/>
+          <p:nvPr/>
+        </p:nvSpPr>
+        <p:spPr>
+          <a:xfrm>
+            <a:off x="7726680" y="5029200"/>
+            <a:ext cx="3566160" cy="822960"/>
+          </a:xfrm>
+          <a:prstGeom prst="rect">
+            <a:avLst/>
+          </a:prstGeom>
+          <a:noFill/>
+          <a:ln/>
+        </p:spPr>
+        <p:txBody>
+          <a:bodyPr wrap="square" lIns="0" tIns="0" rIns="0" bIns="0" rtlCol="0" anchor="t"/>
+          <a:lstStyle/>
+          <a:p>
+            <a:pPr indent="0" marL="0">
+              <a:spcAft>
+                <a:spcPts val="300"/>
+              </a:spcAft>
+              <a:buNone/>
+            </a:pPr>
+            <a:r>
+              <a:rPr lang="en-US" sz="900" dirty="0">
+                <a:solidFill>
+                  <a:schemeClr val="tx2"/>
+                </a:solidFill>
+                <a:latin typeface="Courier New" pitchFamily="34" charset="0"/>
+                <a:ea typeface="Courier New" pitchFamily="34" charset="-122"/>
+                <a:cs typeface="Courier New" pitchFamily="34" charset="-120"/>
+              </a:rPr>
+              <a:t>TrainingModule/src/app/features/admin/showcase/</a:t>
+            </a:r>
+            <a:endParaRPr lang="en-US" sz="900" dirty="0"/>
+          </a:p>
+          <a:p>
+            <a:pPr indent="0" marL="0">
+              <a:spcAft>
+                <a:spcPts val="300"/>
+              </a:spcAft>
+              <a:buNone/>
+            </a:pPr>
+            <a:r>
+              <a:rPr lang="en-US" sz="900" dirty="0">
+                <a:solidFill>
+                  <a:schemeClr val="tx2"/>
+                </a:solidFill>
+                <a:latin typeface="Courier New" pitchFamily="34" charset="0"/>
+                <a:ea typeface="Courier New" pitchFamily="34" charset="-122"/>
+                <a:cs typeface="Courier New" pitchFamily="34" charset="-120"/>
+              </a:rPr>
+              <a:t>TrainingModule/src/app/core/ui/table-pager/</a:t>
+            </a:r>
+            <a:endParaRPr lang="en-US" sz="900" dirty="0"/>
+          </a:p>
+          <a:p>
+            <a:pPr indent="0" marL="0">
+              <a:spcAft>
+                <a:spcPts val="300"/>
+              </a:spcAft>
+              <a:buNone/>
+            </a:pPr>
+            <a:r>
+              <a:rPr lang="en-US" sz="900" dirty="0">
+                <a:solidFill>
+                  <a:schemeClr val="tx2"/>
+                </a:solidFill>
+                <a:latin typeface="Courier New" pitchFamily="34" charset="0"/>
+                <a:ea typeface="Courier New" pitchFamily="34" charset="-122"/>
+                <a:cs typeface="Courier New" pitchFamily="34" charset="-120"/>
+              </a:rPr>
+              <a:t>TrainingModule/src/app/core/ui/paged-list/</a:t>
+            </a:r>
+            <a:endParaRPr lang="en-US" sz="900" dirty="0"/>
           </a:p>
         </p:txBody>
       </p:sp>
@@ -4852,7 +5224,7 @@
                   <a:schemeClr val="tx1"/>
                 </a:solidFill>
               </a:rPr>
-              <a:t>Downloads always use the attachment chips component</a:t>
+              <a:t>Downloads use the attachment chips component (not in this branch yet)</a:t>
             </a:r>
             <a:endParaRPr lang="en-US" sz="1600" dirty="0"/>
           </a:p>
@@ -5091,6 +5463,131 @@
               <a:t>Empty states and errors are fine</a:t>
             </a:r>
             <a:endParaRPr lang="en-US" sz="1500" dirty="0"/>
+          </a:p>
+        </p:txBody>
+      </p:sp>
+      <p:sp>
+        <p:nvSpPr>
+          <p:cNvPr id="30" name="detail-files"/>
+          <p:cNvSpPr/>
+          <p:nvPr/>
+        </p:nvSpPr>
+        <p:spPr>
+          <a:xfrm>
+            <a:off x="7680960" y="4754880"/>
+            <a:ext cx="3931920" cy="1188720"/>
+          </a:xfrm>
+          <a:prstGeom prst="roundRect">
+            <a:avLst>
+              <a:gd name="adj" fmla="val 7692"/>
+            </a:avLst>
+          </a:prstGeom>
+          <a:solidFill>
+            <a:schemeClr val="bg2"/>
+          </a:solidFill>
+          <a:ln w="12700">
+            <a:solidFill>
+              <a:schemeClr val="bg2"/>
+            </a:solidFill>
+            <a:prstDash val="solid"/>
+          </a:ln>
+        </p:spPr>
+      </p:sp>
+      <p:sp>
+        <p:nvSpPr>
+          <p:cNvPr id="31" name="detail-files-label"/>
+          <p:cNvSpPr txBox="1"/>
+          <p:nvPr/>
+        </p:nvSpPr>
+        <p:spPr>
+          <a:xfrm>
+            <a:off x="7909560" y="4864608"/>
+            <a:ext cx="914400" cy="274320"/>
+          </a:xfrm>
+          <a:prstGeom prst="rect">
+            <a:avLst/>
+          </a:prstGeom>
+          <a:noFill/>
+          <a:ln/>
+        </p:spPr>
+        <p:txBody>
+          <a:bodyPr wrap="square" lIns="0" tIns="0" rIns="0" bIns="0" rtlCol="0" anchor="ctr"/>
+          <a:lstStyle/>
+          <a:p>
+            <a:pPr indent="0" marL="0">
+              <a:buNone/>
+            </a:pPr>
+            <a:r>
+              <a:rPr lang="en-US" sz="1200" b="1" dirty="0">
+                <a:solidFill>
+                  <a:schemeClr val="accent2"/>
+                </a:solidFill>
+              </a:rPr>
+              <a:t>Files</a:t>
+            </a:r>
+            <a:endParaRPr lang="en-US" sz="1200" dirty="0"/>
+          </a:p>
+        </p:txBody>
+      </p:sp>
+      <p:sp>
+        <p:nvSpPr>
+          <p:cNvPr id="32" name="detail-files-0"/>
+          <p:cNvSpPr txBox="1"/>
+          <p:nvPr/>
+        </p:nvSpPr>
+        <p:spPr>
+          <a:xfrm>
+            <a:off x="7909560" y="5166360"/>
+            <a:ext cx="3383280" cy="685800"/>
+          </a:xfrm>
+          <a:prstGeom prst="rect">
+            <a:avLst/>
+          </a:prstGeom>
+          <a:noFill/>
+          <a:ln/>
+        </p:spPr>
+        <p:txBody>
+          <a:bodyPr wrap="square" lIns="0" tIns="0" rIns="0" bIns="0" rtlCol="0" anchor="t"/>
+          <a:lstStyle/>
+          <a:p>
+            <a:pPr indent="0" marL="0">
+              <a:spcAft>
+                <a:spcPts val="300"/>
+              </a:spcAft>
+              <a:buNone/>
+            </a:pPr>
+            <a:r>
+              <a:rPr lang="en-US" sz="900" dirty="0">
+                <a:solidFill>
+                  <a:schemeClr val="tx2"/>
+                </a:solidFill>
+                <a:latin typeface="Courier New" pitchFamily="34" charset="0"/>
+                <a:ea typeface="Courier New" pitchFamily="34" charset="-122"/>
+                <a:cs typeface="Courier New" pitchFamily="34" charset="-120"/>
+              </a:rPr>
+              <a:t>TrainingModule/src/app/features/admin/showcase/</a:t>
+            </a:r>
+            <a:endParaRPr lang="en-US" sz="900" dirty="0"/>
+          </a:p>
+          <a:p>
+            <a:pPr indent="0" marL="0">
+              <a:spcAft>
+                <a:spcPts val="300"/>
+              </a:spcAft>
+              <a:buNone/>
+            </a:pPr>
+            <a:r>
+              <a:rPr lang="en-US" sz="900" dirty="0">
+                <a:solidFill>
+                  <a:schemeClr val="tx2"/>
+                </a:solidFill>
+                <a:latin typeface="Courier New" pitchFamily="34" charset="0"/>
+                <a:ea typeface="Courier New" pitchFamily="34" charset="-122"/>
+                <a:cs typeface="Courier New" pitchFamily="34" charset="-120"/>
+              </a:rPr>
+              <a:t>(View popup: showcase-list-page.component.html)</a:t>
+            </a:r>
+            <a:endParaRPr lang="en-US" sz="900" dirty="0"/>
           </a:p>
         </p:txBody>
       </p:sp>
@@ -5271,8 +5768,8 @@
         </p:nvSpPr>
         <p:spPr>
           <a:xfrm>
-            <a:off x="1280160" y="1463040"/>
-            <a:ext cx="4663440" cy="731520"/>
+            <a:off x="1280160" y="1417320"/>
+            <a:ext cx="4754880" cy="822960"/>
           </a:xfrm>
           <a:prstGeom prst="rect">
             <a:avLst/>
@@ -5285,17 +5782,40 @@
           <a:lstStyle/>
           <a:p>
             <a:pPr indent="0" marL="0">
-              <a:buNone/>
-            </a:pPr>
-            <a:r>
-              <a:rPr lang="en-US" sz="1800" dirty="0">
+              <a:spcAft>
+                <a:spcPts val="200"/>
+              </a:spcAft>
+              <a:buNone/>
+            </a:pPr>
+            <a:r>
+              <a:rPr lang="en-US" sz="1700" dirty="0">
                 <a:solidFill>
                   <a:schemeClr val="tx1"/>
                 </a:solidFill>
               </a:rPr>
-              <a:t>Route in app.routes.ts and sidebar link</a:t>
-            </a:r>
-            <a:endParaRPr lang="en-US" sz="1800" dirty="0"/>
+              <a:t>Route and sidebar link</a:t>
+            </a:r>
+            <a:endParaRPr lang="en-US" sz="1700" dirty="0"/>
+          </a:p>
+          <a:p>
+            <a:pPr indent="0" marL="0">
+              <a:spcAft>
+                <a:spcPts val="200"/>
+              </a:spcAft>
+              <a:buNone/>
+            </a:pPr>
+            <a:r>
+              <a:rPr lang="en-US" sz="1050" dirty="0">
+                <a:solidFill>
+                  <a:schemeClr val="tx2"/>
+                </a:solidFill>
+                <a:latin typeface="Courier New" pitchFamily="34" charset="0"/>
+                <a:ea typeface="Courier New" pitchFamily="34" charset="-122"/>
+                <a:cs typeface="Courier New" pitchFamily="34" charset="-120"/>
+              </a:rPr>
+              <a:t>TrainingModule/src/app/app.routes.ts</a:t>
+            </a:r>
+            <a:endParaRPr lang="en-US" sz="1700" dirty="0"/>
           </a:p>
         </p:txBody>
       </p:sp>
@@ -5368,8 +5888,8 @@
         </p:nvSpPr>
         <p:spPr>
           <a:xfrm>
-            <a:off x="1280160" y="2560320"/>
-            <a:ext cx="4663440" cy="731520"/>
+            <a:off x="1280160" y="2514600"/>
+            <a:ext cx="4754880" cy="822960"/>
           </a:xfrm>
           <a:prstGeom prst="rect">
             <a:avLst/>
@@ -5382,17 +5902,40 @@
           <a:lstStyle/>
           <a:p>
             <a:pPr indent="0" marL="0">
-              <a:buNone/>
-            </a:pPr>
-            <a:r>
-              <a:rPr lang="en-US" sz="1800" dirty="0">
+              <a:spcAft>
+                <a:spcPts val="200"/>
+              </a:spcAft>
+              <a:buNone/>
+            </a:pPr>
+            <a:r>
+              <a:rPr lang="en-US" sz="1700" dirty="0">
                 <a:solidFill>
                   <a:schemeClr val="tx1"/>
                 </a:solidFill>
               </a:rPr>
               <a:t>AppPage seed entry with the same URL</a:t>
             </a:r>
-            <a:endParaRPr lang="en-US" sz="1800" dirty="0"/>
+            <a:endParaRPr lang="en-US" sz="1700" dirty="0"/>
+          </a:p>
+          <a:p>
+            <a:pPr indent="0" marL="0">
+              <a:spcAft>
+                <a:spcPts val="200"/>
+              </a:spcAft>
+              <a:buNone/>
+            </a:pPr>
+            <a:r>
+              <a:rPr lang="en-US" sz="1050" dirty="0">
+                <a:solidFill>
+                  <a:schemeClr val="tx2"/>
+                </a:solidFill>
+                <a:latin typeface="Courier New" pitchFamily="34" charset="0"/>
+                <a:ea typeface="Courier New" pitchFamily="34" charset="-122"/>
+                <a:cs typeface="Courier New" pitchFamily="34" charset="-120"/>
+              </a:rPr>
+              <a:t>Bidding_DLL/Seeding/IdentityAccessAppPagesSeedData.cs</a:t>
+            </a:r>
+            <a:endParaRPr lang="en-US" sz="1700" dirty="0"/>
           </a:p>
         </p:txBody>
       </p:sp>
@@ -5465,8 +6008,8 @@
         </p:nvSpPr>
         <p:spPr>
           <a:xfrm>
-            <a:off x="1280160" y="3657600"/>
-            <a:ext cx="4663440" cy="731520"/>
+            <a:off x="1280160" y="3611880"/>
+            <a:ext cx="4754880" cy="822960"/>
           </a:xfrm>
           <a:prstGeom prst="rect">
             <a:avLst/>
@@ -5479,17 +6022,40 @@
           <a:lstStyle/>
           <a:p>
             <a:pPr indent="0" marL="0">
-              <a:buNone/>
-            </a:pPr>
-            <a:r>
-              <a:rPr lang="en-US" sz="1800" dirty="0">
+              <a:spcAft>
+                <a:spcPts val="200"/>
+              </a:spcAft>
+              <a:buNone/>
+            </a:pPr>
+            <a:r>
+              <a:rPr lang="en-US" sz="1700" dirty="0">
                 <a:solidFill>
                   <a:schemeClr val="tx1"/>
                 </a:solidFill>
               </a:rPr>
               <a:t>API endpoint + service rule + DTOs</a:t>
             </a:r>
-            <a:endParaRPr lang="en-US" sz="1800" dirty="0"/>
+            <a:endParaRPr lang="en-US" sz="1700" dirty="0"/>
+          </a:p>
+          <a:p>
+            <a:pPr indent="0" marL="0">
+              <a:spcAft>
+                <a:spcPts val="200"/>
+              </a:spcAft>
+              <a:buNone/>
+            </a:pPr>
+            <a:r>
+              <a:rPr lang="en-US" sz="1050" dirty="0">
+                <a:solidFill>
+                  <a:schemeClr val="tx2"/>
+                </a:solidFill>
+                <a:latin typeface="Courier New" pitchFamily="34" charset="0"/>
+                <a:ea typeface="Courier New" pitchFamily="34" charset="-122"/>
+                <a:cs typeface="Courier New" pitchFamily="34" charset="-120"/>
+              </a:rPr>
+              <a:t>Bidding_API/Controllers/V2/ · Bidding_Core/Services/</a:t>
+            </a:r>
+            <a:endParaRPr lang="en-US" sz="1700" dirty="0"/>
           </a:p>
         </p:txBody>
       </p:sp>
@@ -5562,8 +6128,8 @@
         </p:nvSpPr>
         <p:spPr>
           <a:xfrm>
-            <a:off x="1280160" y="4754880"/>
-            <a:ext cx="4663440" cy="731520"/>
+            <a:off x="1280160" y="4709160"/>
+            <a:ext cx="4754880" cy="822960"/>
           </a:xfrm>
           <a:prstGeom prst="rect">
             <a:avLst/>
@@ -5576,17 +6142,40 @@
           <a:lstStyle/>
           <a:p>
             <a:pPr indent="0" marL="0">
-              <a:buNone/>
-            </a:pPr>
-            <a:r>
-              <a:rPr lang="en-US" sz="1800" dirty="0">
+              <a:spcAft>
+                <a:spcPts val="200"/>
+              </a:spcAft>
+              <a:buNone/>
+            </a:pPr>
+            <a:r>
+              <a:rPr lang="en-US" sz="1700" dirty="0">
                 <a:solidFill>
                   <a:schemeClr val="tx1"/>
                 </a:solidFill>
               </a:rPr>
               <a:t>Data service, then NgRx slice if shared</a:t>
             </a:r>
-            <a:endParaRPr lang="en-US" sz="1800" dirty="0"/>
+            <a:endParaRPr lang="en-US" sz="1700" dirty="0"/>
+          </a:p>
+          <a:p>
+            <a:pPr indent="0" marL="0">
+              <a:spcAft>
+                <a:spcPts val="200"/>
+              </a:spcAft>
+              <a:buNone/>
+            </a:pPr>
+            <a:r>
+              <a:rPr lang="en-US" sz="1050" dirty="0">
+                <a:solidFill>
+                  <a:schemeClr val="tx2"/>
+                </a:solidFill>
+                <a:latin typeface="Courier New" pitchFamily="34" charset="0"/>
+                <a:ea typeface="Courier New" pitchFamily="34" charset="-122"/>
+                <a:cs typeface="Courier New" pitchFamily="34" charset="-120"/>
+              </a:rPr>
+              <a:t>TrainingModule/src/app/core/store/&lt;feature&gt;/</a:t>
+            </a:r>
+            <a:endParaRPr lang="en-US" sz="1700" dirty="0"/>
           </a:p>
         </p:txBody>
       </p:sp>
@@ -5659,8 +6248,8 @@
         </p:nvSpPr>
         <p:spPr>
           <a:xfrm>
-            <a:off x="6903720" y="1463040"/>
-            <a:ext cx="4663440" cy="731520"/>
+            <a:off x="6903720" y="1417320"/>
+            <a:ext cx="4754880" cy="822960"/>
           </a:xfrm>
           <a:prstGeom prst="rect">
             <a:avLst/>
@@ -5673,17 +6262,40 @@
           <a:lstStyle/>
           <a:p>
             <a:pPr indent="0" marL="0">
-              <a:buNone/>
-            </a:pPr>
-            <a:r>
-              <a:rPr lang="en-US" sz="1800" dirty="0">
+              <a:spcAft>
+                <a:spcPts val="200"/>
+              </a:spcAft>
+              <a:buNone/>
+            </a:pPr>
+            <a:r>
+              <a:rPr lang="en-US" sz="1700" dirty="0">
                 <a:solidFill>
                   <a:schemeClr val="tx1"/>
                 </a:solidFill>
               </a:rPr>
               <a:t>Form pipeline, executor, validators</a:t>
             </a:r>
-            <a:endParaRPr lang="en-US" sz="1800" dirty="0"/>
+            <a:endParaRPr lang="en-US" sz="1700" dirty="0"/>
+          </a:p>
+          <a:p>
+            <a:pPr indent="0" marL="0">
+              <a:spcAft>
+                <a:spcPts val="200"/>
+              </a:spcAft>
+              <a:buNone/>
+            </a:pPr>
+            <a:r>
+              <a:rPr lang="en-US" sz="1050" dirty="0">
+                <a:solidFill>
+                  <a:schemeClr val="tx2"/>
+                </a:solidFill>
+                <a:latin typeface="Courier New" pitchFamily="34" charset="0"/>
+                <a:ea typeface="Courier New" pitchFamily="34" charset="-122"/>
+                <a:cs typeface="Courier New" pitchFamily="34" charset="-120"/>
+              </a:rPr>
+              <a:t>TrainingModule/src/app/core/ui/form-pipeline.service.ts</a:t>
+            </a:r>
+            <a:endParaRPr lang="en-US" sz="1700" dirty="0"/>
           </a:p>
         </p:txBody>
       </p:sp>
@@ -5756,8 +6368,8 @@
         </p:nvSpPr>
         <p:spPr>
           <a:xfrm>
-            <a:off x="6903720" y="2560320"/>
-            <a:ext cx="4663440" cy="731520"/>
+            <a:off x="6903720" y="2514600"/>
+            <a:ext cx="4754880" cy="822960"/>
           </a:xfrm>
           <a:prstGeom prst="rect">
             <a:avLst/>
@@ -5770,17 +6382,40 @@
           <a:lstStyle/>
           <a:p>
             <a:pPr indent="0" marL="0">
-              <a:buNone/>
-            </a:pPr>
-            <a:r>
-              <a:rPr lang="en-US" sz="1800" dirty="0">
+              <a:spcAft>
+                <a:spcPts val="200"/>
+              </a:spcAft>
+              <a:buNone/>
+            </a:pPr>
+            <a:r>
+              <a:rPr lang="en-US" sz="1700" dirty="0">
                 <a:solidFill>
                   <a:schemeClr val="tx1"/>
                 </a:solidFill>
               </a:rPr>
-              <a:t>English in templates, Arabic in messages.ar.json</a:t>
-            </a:r>
-            <a:endParaRPr lang="en-US" sz="1800" dirty="0"/>
+              <a:t>English in templates, Arabic translations</a:t>
+            </a:r>
+            <a:endParaRPr lang="en-US" sz="1700" dirty="0"/>
+          </a:p>
+          <a:p>
+            <a:pPr indent="0" marL="0">
+              <a:spcAft>
+                <a:spcPts val="200"/>
+              </a:spcAft>
+              <a:buNone/>
+            </a:pPr>
+            <a:r>
+              <a:rPr lang="en-US" sz="1050" dirty="0">
+                <a:solidFill>
+                  <a:schemeClr val="tx2"/>
+                </a:solidFill>
+                <a:latin typeface="Courier New" pitchFamily="34" charset="0"/>
+                <a:ea typeface="Courier New" pitchFamily="34" charset="-122"/>
+                <a:cs typeface="Courier New" pitchFamily="34" charset="-120"/>
+              </a:rPr>
+              <a:t>TrainingModule/src/app/core/translations/&lt;area&gt;/</a:t>
+            </a:r>
+            <a:endParaRPr lang="en-US" sz="1700" dirty="0"/>
           </a:p>
         </p:txBody>
       </p:sp>
@@ -5853,8 +6488,8 @@
         </p:nvSpPr>
         <p:spPr>
           <a:xfrm>
-            <a:off x="6903720" y="3657600"/>
-            <a:ext cx="4663440" cy="731520"/>
+            <a:off x="6903720" y="3611880"/>
+            <a:ext cx="4754880" cy="822960"/>
           </a:xfrm>
           <a:prstGeom prst="rect">
             <a:avLst/>
@@ -5867,17 +6502,20 @@
           <a:lstStyle/>
           <a:p>
             <a:pPr indent="0" marL="0">
-              <a:buNone/>
-            </a:pPr>
-            <a:r>
-              <a:rPr lang="en-US" sz="1800" dirty="0">
+              <a:spcAft>
+                <a:spcPts val="200"/>
+              </a:spcAft>
+              <a:buNone/>
+            </a:pPr>
+            <a:r>
+              <a:rPr lang="en-US" sz="1700" dirty="0">
                 <a:solidFill>
                   <a:schemeClr val="tx1"/>
                 </a:solidFill>
               </a:rPr>
               <a:t>Mobile layout and RTL checked</a:t>
             </a:r>
-            <a:endParaRPr lang="en-US" sz="1800" dirty="0"/>
+            <a:endParaRPr lang="en-US" sz="1700" dirty="0"/>
           </a:p>
         </p:txBody>
       </p:sp>
@@ -5950,8 +6588,8 @@
         </p:nvSpPr>
         <p:spPr>
           <a:xfrm>
-            <a:off x="6903720" y="4754880"/>
-            <a:ext cx="4663440" cy="731520"/>
+            <a:off x="6903720" y="4709160"/>
+            <a:ext cx="4754880" cy="822960"/>
           </a:xfrm>
           <a:prstGeom prst="rect">
             <a:avLst/>
@@ -5964,17 +6602,40 @@
           <a:lstStyle/>
           <a:p>
             <a:pPr indent="0" marL="0">
-              <a:buNone/>
-            </a:pPr>
-            <a:r>
-              <a:rPr lang="en-US" sz="1800" dirty="0">
+              <a:spcAft>
+                <a:spcPts val="200"/>
+              </a:spcAft>
+              <a:buNone/>
+            </a:pPr>
+            <a:r>
+              <a:rPr lang="en-US" sz="1700" dirty="0">
                 <a:solidFill>
                   <a:schemeClr val="tx1"/>
                 </a:solidFill>
               </a:rPr>
               <a:t>2–3 tests for the new rule</a:t>
             </a:r>
-            <a:endParaRPr lang="en-US" sz="1800" dirty="0"/>
+            <a:endParaRPr lang="en-US" sz="1700" dirty="0"/>
+          </a:p>
+          <a:p>
+            <a:pPr indent="0" marL="0">
+              <a:spcAft>
+                <a:spcPts val="200"/>
+              </a:spcAft>
+              <a:buNone/>
+            </a:pPr>
+            <a:r>
+              <a:rPr lang="en-US" sz="1050" dirty="0">
+                <a:solidFill>
+                  <a:schemeClr val="tx2"/>
+                </a:solidFill>
+                <a:latin typeface="Courier New" pitchFamily="34" charset="0"/>
+                <a:ea typeface="Courier New" pitchFamily="34" charset="-122"/>
+                <a:cs typeface="Courier New" pitchFamily="34" charset="-120"/>
+              </a:rPr>
+              <a:t>Bidding_Core.Tests/ · &lt;component&gt;.spec.ts</a:t>
+            </a:r>
+            <a:endParaRPr lang="en-US" sz="1700" dirty="0"/>
           </a:p>
         </p:txBody>
       </p:sp>
@@ -6118,7 +6779,7 @@
                   <a:schemeClr val="bg2"/>
                 </a:solidFill>
               </a:rPr>
-              <a:t>Rules live in .cursor/rules and docs/DESIGN-GUIDE.md. Read them before your first PR.</a:t>
+              <a:t>Rules live in .cursor/rules/ and TrainingModule/docs/DESIGN-GUIDE.md. Setup is in README.md. Read them before your first PR.</a:t>
             </a:r>
             <a:endParaRPr lang="en-US" sz="2000" dirty="0"/>
           </a:p>
@@ -7106,6 +7767,9 @@
           <a:lstStyle/>
           <a:p>
             <a:pPr indent="0" marL="0">
+              <a:spcAft>
+                <a:spcPts val="400"/>
+              </a:spcAft>
               <a:buNone/>
             </a:pPr>
             <a:r>
@@ -7115,6 +7779,26 @@
                 </a:solidFill>
               </a:rPr>
               <a:t>Controllers, JWT, middleware, background jobs. Thin: validate input, call a service, return.</a:t>
+            </a:r>
+            <a:endParaRPr lang="en-US" sz="1600" dirty="0"/>
+          </a:p>
+          <a:p>
+            <a:pPr indent="0" marL="0">
+              <a:spcAft>
+                <a:spcPts val="400"/>
+              </a:spcAft>
+              <a:buNone/>
+            </a:pPr>
+            <a:r>
+              <a:rPr lang="en-US" sz="1200" dirty="0">
+                <a:solidFill>
+                  <a:schemeClr val="tx2"/>
+                </a:solidFill>
+                <a:latin typeface="Courier New" pitchFamily="34" charset="0"/>
+                <a:ea typeface="Courier New" pitchFamily="34" charset="-122"/>
+                <a:cs typeface="Courier New" pitchFamily="34" charset="-120"/>
+              </a:rPr>
+              <a:t>Bidding_API/Controllers/V2/  ·  Bidding_API/Common/ServiceExtensions.cs</a:t>
             </a:r>
             <a:endParaRPr lang="en-US" sz="1600" dirty="0"/>
           </a:p>
@@ -7230,6 +7914,9 @@
           <a:lstStyle/>
           <a:p>
             <a:pPr indent="0" marL="0">
+              <a:spcAft>
+                <a:spcPts val="400"/>
+              </a:spcAft>
               <a:buNone/>
             </a:pPr>
             <a:r>
@@ -7239,6 +7926,26 @@
                 </a:solidFill>
               </a:rPr>
               <a:t>Business services and rules. All decisions and guards live here.</a:t>
+            </a:r>
+            <a:endParaRPr lang="en-US" sz="1600" dirty="0"/>
+          </a:p>
+          <a:p>
+            <a:pPr indent="0" marL="0">
+              <a:spcAft>
+                <a:spcPts val="400"/>
+              </a:spcAft>
+              <a:buNone/>
+            </a:pPr>
+            <a:r>
+              <a:rPr lang="en-US" sz="1200" dirty="0">
+                <a:solidFill>
+                  <a:schemeClr val="tx2"/>
+                </a:solidFill>
+                <a:latin typeface="Courier New" pitchFamily="34" charset="0"/>
+                <a:ea typeface="Courier New" pitchFamily="34" charset="-122"/>
+                <a:cs typeface="Courier New" pitchFamily="34" charset="-120"/>
+              </a:rPr>
+              <a:t>Bidding_Core/Services/  ·  Bidding_Core/Helpers/</a:t>
             </a:r>
             <a:endParaRPr lang="en-US" sz="1600" dirty="0"/>
           </a:p>
@@ -7354,6 +8061,9 @@
           <a:lstStyle/>
           <a:p>
             <a:pPr indent="0" marL="0">
+              <a:spcAft>
+                <a:spcPts val="400"/>
+              </a:spcAft>
               <a:buNone/>
             </a:pPr>
             <a:r>
@@ -7363,6 +8073,26 @@
                 </a:solidFill>
               </a:rPr>
               <a:t>CHDBContext, data access, repositories, seed data.</a:t>
+            </a:r>
+            <a:endParaRPr lang="en-US" sz="1600" dirty="0"/>
+          </a:p>
+          <a:p>
+            <a:pPr indent="0" marL="0">
+              <a:spcAft>
+                <a:spcPts val="400"/>
+              </a:spcAft>
+              <a:buNone/>
+            </a:pPr>
+            <a:r>
+              <a:rPr lang="en-US" sz="1200" dirty="0">
+                <a:solidFill>
+                  <a:schemeClr val="tx2"/>
+                </a:solidFill>
+                <a:latin typeface="Courier New" pitchFamily="34" charset="0"/>
+                <a:ea typeface="Courier New" pitchFamily="34" charset="-122"/>
+                <a:cs typeface="Courier New" pitchFamily="34" charset="-120"/>
+              </a:rPr>
+              <a:t>Bidding_DLL/CHDBContext.cs  ·  Bidding_DLL/Seeding/</a:t>
             </a:r>
             <a:endParaRPr lang="en-US" sz="1600" dirty="0"/>
           </a:p>
@@ -7478,6 +8208,9 @@
           <a:lstStyle/>
           <a:p>
             <a:pPr indent="0" marL="0">
+              <a:spcAft>
+                <a:spcPts val="400"/>
+              </a:spcAft>
               <a:buNone/>
             </a:pPr>
             <a:r>
@@ -7487,6 +8220,26 @@
                 </a:solidFill>
               </a:rPr>
               <a:t>Entities, DTOs, enums, crypto and shared helpers.</a:t>
+            </a:r>
+            <a:endParaRPr lang="en-US" sz="1600" dirty="0"/>
+          </a:p>
+          <a:p>
+            <a:pPr indent="0" marL="0">
+              <a:spcAft>
+                <a:spcPts val="400"/>
+              </a:spcAft>
+              <a:buNone/>
+            </a:pPr>
+            <a:r>
+              <a:rPr lang="en-US" sz="1200" dirty="0">
+                <a:solidFill>
+                  <a:schemeClr val="tx2"/>
+                </a:solidFill>
+                <a:latin typeface="Courier New" pitchFamily="34" charset="0"/>
+                <a:ea typeface="Courier New" pitchFamily="34" charset="-122"/>
+                <a:cs typeface="Courier New" pitchFamily="34" charset="-120"/>
+              </a:rPr>
+              <a:t>Bidding_Models/  ·  Bidding_Common/</a:t>
             </a:r>
             <a:endParaRPr lang="en-US" sz="1600" dirty="0"/>
           </a:p>
@@ -8083,7 +8836,47 @@
                   <a:schemeClr val="tx1"/>
                 </a:solidFill>
               </a:rPr>
-              <a:t>New route? Add it to IdentityAccessAppPagesSeedData.cs with the same URL, so roles and groups can grant it.</a:t>
+              <a:t>New route? Add an AppPage with the same URL, so roles and groups can grant it.</a:t>
+            </a:r>
+            <a:endParaRPr lang="en-US" sz="1600" dirty="0"/>
+          </a:p>
+          <a:p>
+            <a:pPr indent="0" marL="0">
+              <a:spcAft>
+                <a:spcPts val="400"/>
+              </a:spcAft>
+              <a:buNone/>
+            </a:pPr>
+            <a:r>
+              <a:rPr lang="en-US" sz="1150" dirty="0">
+                <a:solidFill>
+                  <a:schemeClr val="tx2"/>
+                </a:solidFill>
+                <a:latin typeface="Courier New" pitchFamily="34" charset="0"/>
+                <a:ea typeface="Courier New" pitchFamily="34" charset="-122"/>
+                <a:cs typeface="Courier New" pitchFamily="34" charset="-120"/>
+              </a:rPr>
+              <a:t>Bidding_DLL/Seeding/IdentityAccessAppPagesSeedData.cs</a:t>
+            </a:r>
+            <a:endParaRPr lang="en-US" sz="1600" dirty="0"/>
+          </a:p>
+          <a:p>
+            <a:pPr indent="0" marL="0">
+              <a:spcAft>
+                <a:spcPts val="400"/>
+              </a:spcAft>
+              <a:buNone/>
+            </a:pPr>
+            <a:r>
+              <a:rPr lang="en-US" sz="1150" dirty="0">
+                <a:solidFill>
+                  <a:schemeClr val="tx2"/>
+                </a:solidFill>
+                <a:latin typeface="Courier New" pitchFamily="34" charset="0"/>
+                <a:ea typeface="Courier New" pitchFamily="34" charset="-122"/>
+                <a:cs typeface="Courier New" pitchFamily="34" charset="-120"/>
+              </a:rPr>
+              <a:t>Bidding_DLL/Seeding/IdentityAccessSeedData.cs (role map)</a:t>
             </a:r>
             <a:endParaRPr lang="en-US" sz="1600" dirty="0"/>
           </a:p>
@@ -8247,6 +9040,26 @@
                 </a:solidFill>
               </a:rPr>
               <a:t>RunIdentityAccessSeeder stays false on the shared database unless agreed.</a:t>
+            </a:r>
+            <a:endParaRPr lang="en-US" sz="1600" dirty="0"/>
+          </a:p>
+          <a:p>
+            <a:pPr indent="0" marL="0">
+              <a:spcAft>
+                <a:spcPts val="400"/>
+              </a:spcAft>
+              <a:buNone/>
+            </a:pPr>
+            <a:r>
+              <a:rPr lang="en-US" sz="1150" dirty="0">
+                <a:solidFill>
+                  <a:schemeClr val="tx2"/>
+                </a:solidFill>
+                <a:latin typeface="Courier New" pitchFamily="34" charset="0"/>
+                <a:ea typeface="Courier New" pitchFamily="34" charset="-122"/>
+                <a:cs typeface="Courier New" pitchFamily="34" charset="-120"/>
+              </a:rPr>
+              <a:t>Bidding_API/appsettings.Development.json</a:t>
             </a:r>
             <a:endParaRPr lang="en-US" sz="1600" dirty="0"/>
           </a:p>
@@ -8369,7 +9182,7 @@
         <p:spPr>
           <a:xfrm>
             <a:off x="548640" y="1463040"/>
-            <a:ext cx="3017520" cy="822960"/>
+            <a:ext cx="4114800" cy="822960"/>
           </a:xfrm>
           <a:prstGeom prst="roundRect">
             <a:avLst>
@@ -8395,8 +9208,8 @@
         </p:nvSpPr>
         <p:spPr>
           <a:xfrm>
-            <a:off x="777240" y="1463040"/>
-            <a:ext cx="2743200" cy="822960"/>
+            <a:off x="731520" y="1463040"/>
+            <a:ext cx="3840480" cy="822960"/>
           </a:xfrm>
           <a:prstGeom prst="rect">
             <a:avLst/>
@@ -8412,7 +9225,7 @@
               <a:buNone/>
             </a:pPr>
             <a:r>
-              <a:rPr lang="en-US" sz="1800" b="1" dirty="0">
+              <a:rPr lang="en-US" sz="1250" b="1" dirty="0">
                 <a:solidFill>
                   <a:schemeClr val="tx2"/>
                 </a:solidFill>
@@ -8420,9 +9233,9 @@
                 <a:ea typeface="Courier New" pitchFamily="34" charset="-122"/>
                 <a:cs typeface="Courier New" pitchFamily="34" charset="-120"/>
               </a:rPr>
-              <a:t>core/</a:t>
-            </a:r>
-            <a:endParaRPr lang="en-US" sz="1800" dirty="0"/>
+              <a:t>TrainingModule/src/app/core/</a:t>
+            </a:r>
+            <a:endParaRPr lang="en-US" sz="1250" dirty="0"/>
           </a:p>
         </p:txBody>
       </p:sp>
@@ -8434,8 +9247,8 @@
         </p:nvSpPr>
         <p:spPr>
           <a:xfrm>
-            <a:off x="3840480" y="1463040"/>
-            <a:ext cx="4206240" cy="822960"/>
+            <a:off x="4892040" y="1463040"/>
+            <a:ext cx="3291840" cy="822960"/>
           </a:xfrm>
           <a:prstGeom prst="rect">
             <a:avLst/>
@@ -8451,14 +9264,14 @@
               <a:buNone/>
             </a:pPr>
             <a:r>
-              <a:rPr lang="en-US" sz="1500" dirty="0">
+              <a:rPr lang="en-US" sz="1400" dirty="0">
                 <a:solidFill>
                   <a:schemeClr val="tx1"/>
                 </a:solidFill>
               </a:rPr>
               <a:t>auth, interceptors, store, translations, validators, ui (pipeline, pager, paged list)</a:t>
             </a:r>
-            <a:endParaRPr lang="en-US" sz="1500" dirty="0"/>
+            <a:endParaRPr lang="en-US" sz="1400" dirty="0"/>
           </a:p>
         </p:txBody>
       </p:sp>
@@ -8471,7 +9284,7 @@
         <p:spPr>
           <a:xfrm>
             <a:off x="548640" y="2560320"/>
-            <a:ext cx="3017520" cy="822960"/>
+            <a:ext cx="4114800" cy="822960"/>
           </a:xfrm>
           <a:prstGeom prst="roundRect">
             <a:avLst>
@@ -8497,8 +9310,8 @@
         </p:nvSpPr>
         <p:spPr>
           <a:xfrm>
-            <a:off x="777240" y="2560320"/>
-            <a:ext cx="2743200" cy="822960"/>
+            <a:off x="731520" y="2560320"/>
+            <a:ext cx="3840480" cy="822960"/>
           </a:xfrm>
           <a:prstGeom prst="rect">
             <a:avLst/>
@@ -8514,7 +9327,7 @@
               <a:buNone/>
             </a:pPr>
             <a:r>
-              <a:rPr lang="en-US" sz="1800" b="1" dirty="0">
+              <a:rPr lang="en-US" sz="1250" b="1" dirty="0">
                 <a:solidFill>
                   <a:schemeClr val="tx2"/>
                 </a:solidFill>
@@ -8522,9 +9335,9 @@
                 <a:ea typeface="Courier New" pitchFamily="34" charset="-122"/>
                 <a:cs typeface="Courier New" pitchFamily="34" charset="-120"/>
               </a:rPr>
-              <a:t>features/&lt;area&gt;/</a:t>
-            </a:r>
-            <a:endParaRPr lang="en-US" sz="1800" dirty="0"/>
+              <a:t>TrainingModule/src/app/features/&lt;area&gt;/</a:t>
+            </a:r>
+            <a:endParaRPr lang="en-US" sz="1250" dirty="0"/>
           </a:p>
         </p:txBody>
       </p:sp>
@@ -8536,8 +9349,8 @@
         </p:nvSpPr>
         <p:spPr>
           <a:xfrm>
-            <a:off x="3840480" y="2560320"/>
-            <a:ext cx="4206240" cy="822960"/>
+            <a:off x="4892040" y="2560320"/>
+            <a:ext cx="3291840" cy="822960"/>
           </a:xfrm>
           <a:prstGeom prst="rect">
             <a:avLst/>
@@ -8553,14 +9366,14 @@
               <a:buNone/>
             </a:pPr>
             <a:r>
-              <a:rPr lang="en-US" sz="1500" dirty="0">
+              <a:rPr lang="en-US" sz="1400" dirty="0">
                 <a:solidFill>
                   <a:schemeClr val="tx1"/>
                 </a:solidFill>
               </a:rPr>
               <a:t>one folder per feature: pages, data services, models</a:t>
             </a:r>
-            <a:endParaRPr lang="en-US" sz="1500" dirty="0"/>
+            <a:endParaRPr lang="en-US" sz="1400" dirty="0"/>
           </a:p>
         </p:txBody>
       </p:sp>
@@ -8573,7 +9386,7 @@
         <p:spPr>
           <a:xfrm>
             <a:off x="548640" y="3657600"/>
-            <a:ext cx="3017520" cy="822960"/>
+            <a:ext cx="4114800" cy="822960"/>
           </a:xfrm>
           <a:prstGeom prst="roundRect">
             <a:avLst>
@@ -8599,8 +9412,8 @@
         </p:nvSpPr>
         <p:spPr>
           <a:xfrm>
-            <a:off x="777240" y="3657600"/>
-            <a:ext cx="2743200" cy="822960"/>
+            <a:off x="731520" y="3657600"/>
+            <a:ext cx="3840480" cy="822960"/>
           </a:xfrm>
           <a:prstGeom prst="rect">
             <a:avLst/>
@@ -8616,7 +9429,7 @@
               <a:buNone/>
             </a:pPr>
             <a:r>
-              <a:rPr lang="en-US" sz="1800" b="1" dirty="0">
+              <a:rPr lang="en-US" sz="1250" b="1" dirty="0">
                 <a:solidFill>
                   <a:schemeClr val="tx2"/>
                 </a:solidFill>
@@ -8624,9 +9437,9 @@
                 <a:ea typeface="Courier New" pitchFamily="34" charset="-122"/>
                 <a:cs typeface="Courier New" pitchFamily="34" charset="-120"/>
               </a:rPr>
-              <a:t>layout/</a:t>
-            </a:r>
-            <a:endParaRPr lang="en-US" sz="1800" dirty="0"/>
+              <a:t>TrainingModule/src/app/layout/</a:t>
+            </a:r>
+            <a:endParaRPr lang="en-US" sz="1250" dirty="0"/>
           </a:p>
         </p:txBody>
       </p:sp>
@@ -8638,8 +9451,8 @@
         </p:nvSpPr>
         <p:spPr>
           <a:xfrm>
-            <a:off x="3840480" y="3657600"/>
-            <a:ext cx="4206240" cy="822960"/>
+            <a:off x="4892040" y="3657600"/>
+            <a:ext cx="3291840" cy="822960"/>
           </a:xfrm>
           <a:prstGeom prst="rect">
             <a:avLst/>
@@ -8655,14 +9468,14 @@
               <a:buNone/>
             </a:pPr>
             <a:r>
-              <a:rPr lang="en-US" sz="1500" dirty="0">
+              <a:rPr lang="en-US" sz="1400" dirty="0">
                 <a:solidFill>
                   <a:schemeClr val="tx1"/>
                 </a:solidFill>
               </a:rPr>
               <a:t>main layout, sidebar, header, notifications bell</a:t>
             </a:r>
-            <a:endParaRPr lang="en-US" sz="1500" dirty="0"/>
+            <a:endParaRPr lang="en-US" sz="1400" dirty="0"/>
           </a:p>
         </p:txBody>
       </p:sp>
@@ -8675,7 +9488,7 @@
         <p:spPr>
           <a:xfrm>
             <a:off x="548640" y="4754880"/>
-            <a:ext cx="3017520" cy="822960"/>
+            <a:ext cx="4114800" cy="822960"/>
           </a:xfrm>
           <a:prstGeom prst="roundRect">
             <a:avLst>
@@ -8701,8 +9514,8 @@
         </p:nvSpPr>
         <p:spPr>
           <a:xfrm>
-            <a:off x="777240" y="4754880"/>
-            <a:ext cx="2743200" cy="822960"/>
+            <a:off x="731520" y="4754880"/>
+            <a:ext cx="3840480" cy="822960"/>
           </a:xfrm>
           <a:prstGeom prst="rect">
             <a:avLst/>
@@ -8718,7 +9531,7 @@
               <a:buNone/>
             </a:pPr>
             <a:r>
-              <a:rPr lang="en-US" sz="1800" b="1" dirty="0">
+              <a:rPr lang="en-US" sz="1250" b="1" dirty="0">
                 <a:solidFill>
                   <a:schemeClr val="tx2"/>
                 </a:solidFill>
@@ -8726,9 +9539,9 @@
                 <a:ea typeface="Courier New" pitchFamily="34" charset="-122"/>
                 <a:cs typeface="Courier New" pitchFamily="34" charset="-120"/>
               </a:rPr>
-              <a:t>shared/</a:t>
-            </a:r>
-            <a:endParaRPr lang="en-US" sz="1800" dirty="0"/>
+              <a:t>TrainingModule/src/app/shared/</a:t>
+            </a:r>
+            <a:endParaRPr lang="en-US" sz="1250" dirty="0"/>
           </a:p>
         </p:txBody>
       </p:sp>
@@ -8740,8 +9553,8 @@
         </p:nvSpPr>
         <p:spPr>
           <a:xfrm>
-            <a:off x="3840480" y="4754880"/>
-            <a:ext cx="4206240" cy="822960"/>
+            <a:off x="4892040" y="4754880"/>
+            <a:ext cx="3291840" cy="822960"/>
           </a:xfrm>
           <a:prstGeom prst="rect">
             <a:avLst/>
@@ -8757,14 +9570,14 @@
               <a:buNone/>
             </a:pPr>
             <a:r>
-              <a:rPr lang="en-US" sz="1500" dirty="0">
+              <a:rPr lang="en-US" sz="1400" dirty="0">
                 <a:solidFill>
                   <a:schemeClr val="tx1"/>
                 </a:solidFill>
               </a:rPr>
               <a:t>small reusable components with no feature logic</a:t>
             </a:r>
-            <a:endParaRPr lang="en-US" sz="1500" dirty="0"/>
+            <a:endParaRPr lang="en-US" sz="1400" dirty="0"/>
           </a:p>
         </p:txBody>
       </p:sp>
@@ -8797,7 +9610,57 @@
       </p:sp>
       <p:sp>
         <p:nvSpPr>
-          <p:cNvPr id="16" name="stack-title"/>
+          <p:cNvPr id="16" name="routes-path"/>
+          <p:cNvSpPr txBox="1"/>
+          <p:nvPr/>
+        </p:nvSpPr>
+        <p:spPr>
+          <a:xfrm>
+            <a:off x="548640" y="5852160"/>
+            <a:ext cx="7680960" cy="365760"/>
+          </a:xfrm>
+          <a:prstGeom prst="rect">
+            <a:avLst/>
+          </a:prstGeom>
+          <a:noFill/>
+          <a:ln/>
+        </p:spPr>
+        <p:txBody>
+          <a:bodyPr wrap="square" lIns="0" tIns="0" rIns="0" bIns="0" rtlCol="0" anchor="ctr"/>
+          <a:lstStyle/>
+          <a:p>
+            <a:pPr indent="0" marL="0">
+              <a:buNone/>
+            </a:pPr>
+            <a:r>
+              <a:rPr lang="en-US" sz="1400" b="1" dirty="0">
+                <a:solidFill>
+                  <a:schemeClr val="tx1"/>
+                </a:solidFill>
+              </a:rPr>
+              <a:t>Routes: </a:t>
+            </a:r>
+            <a:pPr indent="0" marL="0">
+              <a:buNone/>
+            </a:pPr>
+            <a:r>
+              <a:rPr lang="en-US" sz="1200" dirty="0">
+                <a:solidFill>
+                  <a:schemeClr val="tx2"/>
+                </a:solidFill>
+                <a:latin typeface="Courier New" pitchFamily="34" charset="0"/>
+                <a:ea typeface="Courier New" pitchFamily="34" charset="-122"/>
+                <a:cs typeface="Courier New" pitchFamily="34" charset="-120"/>
+              </a:rPr>
+              <a:t>TrainingModule/src/app/app.routes.ts</a:t>
+            </a:r>
+            <a:endParaRPr lang="en-US" sz="1400" dirty="0"/>
+          </a:p>
+        </p:txBody>
+      </p:sp>
+      <p:sp>
+        <p:nvSpPr>
+          <p:cNvPr id="17" name="stack-title"/>
           <p:cNvSpPr txBox="1"/>
           <p:nvPr/>
         </p:nvSpPr>
@@ -8833,7 +9696,7 @@
       </p:sp>
       <p:sp>
         <p:nvSpPr>
-          <p:cNvPr id="17" name="stack-body"/>
+          <p:cNvPr id="18" name="stack-body"/>
           <p:cNvSpPr txBox="1"/>
           <p:nvPr/>
         </p:nvSpPr>
@@ -9786,8 +10649,8 @@
         </p:nvSpPr>
         <p:spPr>
           <a:xfrm>
-            <a:off x="548640" y="4526280"/>
-            <a:ext cx="11064240" cy="822960"/>
+            <a:off x="548640" y="4343400"/>
+            <a:ext cx="11064240" cy="457200"/>
           </a:xfrm>
           <a:prstGeom prst="rect">
             <a:avLst/>
@@ -9822,6 +10685,171 @@
               <a:t>the UI showcase form (/admin/showcase/new). Required fields show * from the validator, never hard-coded.</a:t>
             </a:r>
             <a:endParaRPr lang="en-US" sz="1600" dirty="0"/>
+          </a:p>
+        </p:txBody>
+      </p:sp>
+      <p:sp>
+        <p:nvSpPr>
+          <p:cNvPr id="27" name="pipeline-files"/>
+          <p:cNvSpPr/>
+          <p:nvPr/>
+        </p:nvSpPr>
+        <p:spPr>
+          <a:xfrm>
+            <a:off x="548640" y="4892040"/>
+            <a:ext cx="11064240" cy="1325880"/>
+          </a:xfrm>
+          <a:prstGeom prst="roundRect">
+            <a:avLst>
+              <a:gd name="adj" fmla="val 6897"/>
+            </a:avLst>
+          </a:prstGeom>
+          <a:solidFill>
+            <a:schemeClr val="bg2"/>
+          </a:solidFill>
+          <a:ln w="12700">
+            <a:solidFill>
+              <a:schemeClr val="bg2"/>
+            </a:solidFill>
+            <a:prstDash val="solid"/>
+          </a:ln>
+        </p:spPr>
+      </p:sp>
+      <p:sp>
+        <p:nvSpPr>
+          <p:cNvPr id="28" name="pipeline-files-label"/>
+          <p:cNvSpPr txBox="1"/>
+          <p:nvPr/>
+        </p:nvSpPr>
+        <p:spPr>
+          <a:xfrm>
+            <a:off x="777240" y="5001768"/>
+            <a:ext cx="914400" cy="274320"/>
+          </a:xfrm>
+          <a:prstGeom prst="rect">
+            <a:avLst/>
+          </a:prstGeom>
+          <a:noFill/>
+          <a:ln/>
+        </p:spPr>
+        <p:txBody>
+          <a:bodyPr wrap="square" lIns="0" tIns="0" rIns="0" bIns="0" rtlCol="0" anchor="ctr"/>
+          <a:lstStyle/>
+          <a:p>
+            <a:pPr indent="0" marL="0">
+              <a:buNone/>
+            </a:pPr>
+            <a:r>
+              <a:rPr lang="en-US" sz="1200" b="1" dirty="0">
+                <a:solidFill>
+                  <a:schemeClr val="accent2"/>
+                </a:solidFill>
+              </a:rPr>
+              <a:t>Files</a:t>
+            </a:r>
+            <a:endParaRPr lang="en-US" sz="1200" dirty="0"/>
+          </a:p>
+        </p:txBody>
+      </p:sp>
+      <p:sp>
+        <p:nvSpPr>
+          <p:cNvPr id="29" name="pipeline-files-0"/>
+          <p:cNvSpPr txBox="1"/>
+          <p:nvPr/>
+        </p:nvSpPr>
+        <p:spPr>
+          <a:xfrm>
+            <a:off x="777240" y="5303520"/>
+            <a:ext cx="10515600" cy="822960"/>
+          </a:xfrm>
+          <a:prstGeom prst="rect">
+            <a:avLst/>
+          </a:prstGeom>
+          <a:noFill/>
+          <a:ln/>
+        </p:spPr>
+        <p:txBody>
+          <a:bodyPr wrap="square" lIns="0" tIns="0" rIns="0" bIns="0" rtlCol="0" anchor="t"/>
+          <a:lstStyle/>
+          <a:p>
+            <a:pPr indent="0" marL="0">
+              <a:spcAft>
+                <a:spcPts val="300"/>
+              </a:spcAft>
+              <a:buNone/>
+            </a:pPr>
+            <a:r>
+              <a:rPr lang="en-US" sz="1100" dirty="0">
+                <a:solidFill>
+                  <a:schemeClr val="tx2"/>
+                </a:solidFill>
+                <a:latin typeface="Courier New" pitchFamily="34" charset="0"/>
+                <a:ea typeface="Courier New" pitchFamily="34" charset="-122"/>
+                <a:cs typeface="Courier New" pitchFamily="34" charset="-120"/>
+              </a:rPr>
+              <a:t>TrainingModule/src/app/core/validators/  (imported as @validators)</a:t>
+            </a:r>
+            <a:endParaRPr lang="en-US" sz="1100" dirty="0"/>
+          </a:p>
+          <a:p>
+            <a:pPr indent="0" marL="0">
+              <a:spcAft>
+                <a:spcPts val="300"/>
+              </a:spcAft>
+              <a:buNone/>
+            </a:pPr>
+            <a:r>
+              <a:rPr lang="en-US" sz="1100" dirty="0">
+                <a:solidFill>
+                  <a:schemeClr val="tx2"/>
+                </a:solidFill>
+                <a:latin typeface="Courier New" pitchFamily="34" charset="0"/>
+                <a:ea typeface="Courier New" pitchFamily="34" charset="-122"/>
+                <a:cs typeface="Courier New" pitchFamily="34" charset="-120"/>
+              </a:rPr>
+              <a:t>TrainingModule/src/app/core/validators/validation-message.pipe.ts</a:t>
+            </a:r>
+            <a:endParaRPr lang="en-US" sz="1100" dirty="0"/>
+          </a:p>
+          <a:p>
+            <a:pPr indent="0" marL="0">
+              <a:spcAft>
+                <a:spcPts val="300"/>
+              </a:spcAft>
+              <a:buNone/>
+            </a:pPr>
+            <a:r>
+              <a:rPr lang="en-US" sz="1100" dirty="0">
+                <a:solidFill>
+                  <a:schemeClr val="tx2"/>
+                </a:solidFill>
+                <a:latin typeface="Courier New" pitchFamily="34" charset="0"/>
+                <a:ea typeface="Courier New" pitchFamily="34" charset="-122"/>
+                <a:cs typeface="Courier New" pitchFamily="34" charset="-120"/>
+              </a:rPr>
+              <a:t>TrainingModule/src/app/core/ui/form-pipeline.service.ts</a:t>
+            </a:r>
+            <a:endParaRPr lang="en-US" sz="1100" dirty="0"/>
+          </a:p>
+          <a:p>
+            <a:pPr indent="0" marL="0">
+              <a:spcAft>
+                <a:spcPts val="300"/>
+              </a:spcAft>
+              <a:buNone/>
+            </a:pPr>
+            <a:r>
+              <a:rPr lang="en-US" sz="1100" dirty="0">
+                <a:solidFill>
+                  <a:schemeClr val="tx2"/>
+                </a:solidFill>
+                <a:latin typeface="Courier New" pitchFamily="34" charset="0"/>
+                <a:ea typeface="Courier New" pitchFamily="34" charset="-122"/>
+                <a:cs typeface="Courier New" pitchFamily="34" charset="-120"/>
+              </a:rPr>
+              <a:t>TrainingModule/src/app/core/ui/async-executor.service.ts</a:t>
+            </a:r>
+            <a:endParaRPr lang="en-US" sz="1100" dirty="0"/>
           </a:p>
         </p:txBody>
       </p:sp>
@@ -11065,12 +12093,12 @@
         </p:nvSpPr>
         <p:spPr>
           <a:xfrm>
-            <a:off x="548640" y="5120640"/>
-            <a:ext cx="11064240" cy="1005840"/>
+            <a:off x="548640" y="5074920"/>
+            <a:ext cx="11064240" cy="777240"/>
           </a:xfrm>
           <a:prstGeom prst="roundRect">
             <a:avLst>
-              <a:gd name="adj" fmla="val 10909"/>
+              <a:gd name="adj" fmla="val 14118"/>
             </a:avLst>
           </a:prstGeom>
           <a:solidFill>
@@ -11092,8 +12120,8 @@
         </p:nvSpPr>
         <p:spPr>
           <a:xfrm>
-            <a:off x="868680" y="5120640"/>
-            <a:ext cx="10424160" cy="1005840"/>
+            <a:off x="868680" y="5074920"/>
+            <a:ext cx="10424160" cy="777240"/>
           </a:xfrm>
           <a:prstGeom prst="rect">
             <a:avLst/>
@@ -11109,7 +12137,7 @@
               <a:buNone/>
             </a:pPr>
             <a:r>
-              <a:rPr lang="en-US" sz="1700" b="1" dirty="0">
+              <a:rPr lang="en-US" sz="1600" b="1" dirty="0">
                 <a:solidFill>
                   <a:schemeClr val="bg1"/>
                 </a:solidFill>
@@ -11120,14 +12148,67 @@
               <a:buNone/>
             </a:pPr>
             <a:r>
-              <a:rPr lang="en-US" sz="1700" dirty="0">
+              <a:rPr lang="en-US" sz="1600" dirty="0">
                 <a:solidFill>
                   <a:schemeClr val="bg1"/>
                 </a:solidFill>
               </a:rPr>
               <a:t>{ ok: true, value } and the page navigates. On any stop it gets { ok: false, reason } and simply returns: the messages are already on screen.</a:t>
             </a:r>
-            <a:endParaRPr lang="en-US" sz="1700" dirty="0"/>
+            <a:endParaRPr lang="en-US" sz="1600" dirty="0"/>
+          </a:p>
+        </p:txBody>
+      </p:sp>
+      <p:sp>
+        <p:nvSpPr>
+          <p:cNvPr id="37" name="flow-files"/>
+          <p:cNvSpPr txBox="1"/>
+          <p:nvPr/>
+        </p:nvSpPr>
+        <p:spPr>
+          <a:xfrm>
+            <a:off x="548640" y="5925312"/>
+            <a:ext cx="11064240" cy="365760"/>
+          </a:xfrm>
+          <a:prstGeom prst="rect">
+            <a:avLst/>
+          </a:prstGeom>
+          <a:noFill/>
+          <a:ln/>
+        </p:spPr>
+        <p:txBody>
+          <a:bodyPr wrap="square" lIns="0" tIns="0" rIns="0" bIns="0" rtlCol="0" anchor="ctr"/>
+          <a:lstStyle/>
+          <a:p>
+            <a:pPr indent="0" marL="0">
+              <a:buNone/>
+            </a:pPr>
+            <a:r>
+              <a:rPr lang="en-US" sz="1050" b="1" dirty="0">
+                <a:solidFill>
+                  <a:schemeClr val="accent2"/>
+                </a:solidFill>
+                <a:latin typeface="Calibri" pitchFamily="34" charset="0"/>
+                <a:ea typeface="Calibri" pitchFamily="34" charset="-122"/>
+                <a:cs typeface="Calibri" pitchFamily="34" charset="-120"/>
+              </a:rPr>
+              <a:t>Files: </a:t>
+            </a:r>
+            <a:pPr indent="0" marL="0">
+              <a:buNone/>
+            </a:pPr>
+            <a:r>
+              <a:rPr lang="en-US" sz="1050" dirty="0">
+                <a:solidFill>
+                  <a:schemeClr val="tx2"/>
+                </a:solidFill>
+                <a:latin typeface="Courier New" pitchFamily="34" charset="0"/>
+                <a:ea typeface="Courier New" pitchFamily="34" charset="-122"/>
+                <a:cs typeface="Courier New" pitchFamily="34" charset="-120"/>
+              </a:rPr>
+              <a:t>TrainingModule/src/app/core/ui/form-pipeline.service.ts  ·  TrainingModule/src/app/core/ui/form-pipeline.types.ts</a:t>
+            </a:r>
+            <a:endParaRPr lang="en-US" sz="1050" dirty="0"/>
           </a:p>
         </p:txBody>
       </p:sp>
@@ -11248,11 +12329,11 @@
         <p:spPr>
           <a:xfrm>
             <a:off x="548640" y="1371600"/>
-            <a:ext cx="6400800" cy="4800600"/>
+            <a:ext cx="6400800" cy="4206240"/>
           </a:xfrm>
           <a:prstGeom prst="roundRect">
             <a:avLst>
-              <a:gd name="adj" fmla="val 2286"/>
+              <a:gd name="adj" fmla="val 2609"/>
             </a:avLst>
           </a:prstGeom>
           <a:solidFill>
@@ -11274,8 +12355,8 @@
         </p:nvSpPr>
         <p:spPr>
           <a:xfrm>
-            <a:off x="822960" y="1508760"/>
-            <a:ext cx="5943600" cy="4526280"/>
+            <a:off x="822960" y="1481328"/>
+            <a:ext cx="5943600" cy="4023360"/>
           </a:xfrm>
           <a:prstGeom prst="rect">
             <a:avLst/>
@@ -11602,31 +12683,57 @@
         </p:nvSpPr>
         <p:spPr>
           <a:xfrm>
-            <a:off x="548640" y="6199632"/>
-            <a:ext cx="6400800" cy="201168"/>
-          </a:xfrm>
-          <a:prstGeom prst="rect">
-            <a:avLst/>
-          </a:prstGeom>
-          <a:noFill/>
-          <a:ln/>
-        </p:spPr>
-        <p:txBody>
-          <a:bodyPr wrap="square" lIns="0" tIns="0" rIns="0" bIns="0" rtlCol="0" anchor="ctr"/>
-          <a:lstStyle/>
-          <a:p>
-            <a:pPr indent="0" marL="0">
-              <a:buNone/>
-            </a:pPr>
-            <a:r>
-              <a:rPr lang="en-US" sz="1000" i="1" dirty="0">
-                <a:solidFill>
-                  <a:schemeClr val="accent6"/>
-                </a:solidFill>
-              </a:rPr>
-              <a:t>showcase-form-page.component.ts</a:t>
-            </a:r>
-            <a:endParaRPr lang="en-US" sz="1000" dirty="0"/>
+            <a:off x="548640" y="5669280"/>
+            <a:ext cx="6400800" cy="548640"/>
+          </a:xfrm>
+          <a:prstGeom prst="rect">
+            <a:avLst/>
+          </a:prstGeom>
+          <a:noFill/>
+          <a:ln/>
+        </p:spPr>
+        <p:txBody>
+          <a:bodyPr wrap="square" lIns="0" tIns="0" rIns="0" bIns="0" rtlCol="0" anchor="t"/>
+          <a:lstStyle/>
+          <a:p>
+            <a:pPr indent="0" marL="0">
+              <a:spcAft>
+                <a:spcPts val="300"/>
+              </a:spcAft>
+              <a:buNone/>
+            </a:pPr>
+            <a:r>
+              <a:rPr lang="en-US" sz="1050" dirty="0">
+                <a:solidFill>
+                  <a:schemeClr val="tx2"/>
+                </a:solidFill>
+                <a:latin typeface="Courier New" pitchFamily="34" charset="0"/>
+                <a:ea typeface="Courier New" pitchFamily="34" charset="-122"/>
+                <a:cs typeface="Courier New" pitchFamily="34" charset="-120"/>
+              </a:rPr>
+              <a:t>TrainingModule/src/app/features/admin/showcase/showcase-form-page.component.ts</a:t>
+            </a:r>
+            <a:endParaRPr lang="en-US" sz="1050" dirty="0"/>
+          </a:p>
+          <a:p>
+            <a:pPr indent="0" marL="0">
+              <a:spcAft>
+                <a:spcPts val="300"/>
+              </a:spcAft>
+              <a:buNone/>
+            </a:pPr>
+            <a:r>
+              <a:rPr lang="en-US" sz="1050" dirty="0">
+                <a:solidFill>
+                  <a:schemeClr val="tx2"/>
+                </a:solidFill>
+                <a:latin typeface="Courier New" pitchFamily="34" charset="0"/>
+                <a:ea typeface="Courier New" pitchFamily="34" charset="-122"/>
+                <a:cs typeface="Courier New" pitchFamily="34" charset="-120"/>
+              </a:rPr>
+              <a:t>TrainingModule/src/app/features/admin/showcase/showcase-form.ts</a:t>
+            </a:r>
+            <a:endParaRPr lang="en-US" sz="1050" dirty="0"/>
           </a:p>
         </p:txBody>
       </p:sp>
@@ -11738,7 +12845,7 @@
                   <a:schemeClr val="tx1"/>
                 </a:solidFill>
               </a:rPr>
-              <a:t>The FormGroup built with @validators. Rules match the API rules.</a:t>
+              <a:t>Built in showcase-form.ts with @validators. Same rules as Bidding_Core/Helpers/ShowcaseRules.cs.</a:t>
             </a:r>
             <a:endParaRPr lang="en-US" sz="1400" dirty="0"/>
           </a:p>
@@ -12277,11 +13384,11 @@
         <p:spPr>
           <a:xfrm>
             <a:off x="548640" y="1463040"/>
-            <a:ext cx="5394960" cy="3566160"/>
+            <a:ext cx="5394960" cy="3108960"/>
           </a:xfrm>
           <a:prstGeom prst="roundRect">
             <a:avLst>
-              <a:gd name="adj" fmla="val 3077"/>
+              <a:gd name="adj" fmla="val 3529"/>
             </a:avLst>
           </a:prstGeom>
           <a:solidFill>
@@ -12401,7 +13508,7 @@
         <p:spPr>
           <a:xfrm>
             <a:off x="822960" y="2377440"/>
-            <a:ext cx="4892040" cy="2468880"/>
+            <a:ext cx="4892040" cy="2011680"/>
           </a:xfrm>
           <a:prstGeom prst="rect">
             <a:avLst/>
@@ -12495,11 +13602,11 @@
         <p:spPr>
           <a:xfrm>
             <a:off x="6217920" y="1463040"/>
-            <a:ext cx="5394960" cy="3566160"/>
+            <a:ext cx="5394960" cy="3108960"/>
           </a:xfrm>
           <a:prstGeom prst="roundRect">
             <a:avLst>
-              <a:gd name="adj" fmla="val 3077"/>
+              <a:gd name="adj" fmla="val 3529"/>
             </a:avLst>
           </a:prstGeom>
           <a:solidFill>
@@ -12619,7 +13726,7 @@
         <p:spPr>
           <a:xfrm>
             <a:off x="6492240" y="2377440"/>
-            <a:ext cx="4892040" cy="2468880"/>
+            <a:ext cx="4892040" cy="2011680"/>
           </a:xfrm>
           <a:prstGeom prst="rect">
             <a:avLst/>
@@ -12701,6 +13808,253 @@
               <a:t>Never swallow errors in a component</a:t>
             </a:r>
             <a:endParaRPr lang="en-US" sz="1600" dirty="0"/>
+          </a:p>
+        </p:txBody>
+      </p:sp>
+      <p:sp>
+        <p:nvSpPr>
+          <p:cNvPr id="13" name="loading-files"/>
+          <p:cNvSpPr/>
+          <p:nvPr/>
+        </p:nvSpPr>
+        <p:spPr>
+          <a:xfrm>
+            <a:off x="548640" y="4754880"/>
+            <a:ext cx="11064240" cy="1463040"/>
+          </a:xfrm>
+          <a:prstGeom prst="roundRect">
+            <a:avLst>
+              <a:gd name="adj" fmla="val 6250"/>
+            </a:avLst>
+          </a:prstGeom>
+          <a:solidFill>
+            <a:schemeClr val="bg2"/>
+          </a:solidFill>
+          <a:ln w="12700">
+            <a:solidFill>
+              <a:schemeClr val="bg2"/>
+            </a:solidFill>
+            <a:prstDash val="solid"/>
+          </a:ln>
+        </p:spPr>
+      </p:sp>
+      <p:sp>
+        <p:nvSpPr>
+          <p:cNvPr id="14" name="loading-files-label"/>
+          <p:cNvSpPr txBox="1"/>
+          <p:nvPr/>
+        </p:nvSpPr>
+        <p:spPr>
+          <a:xfrm>
+            <a:off x="777240" y="4864608"/>
+            <a:ext cx="914400" cy="274320"/>
+          </a:xfrm>
+          <a:prstGeom prst="rect">
+            <a:avLst/>
+          </a:prstGeom>
+          <a:noFill/>
+          <a:ln/>
+        </p:spPr>
+        <p:txBody>
+          <a:bodyPr wrap="square" lIns="0" tIns="0" rIns="0" bIns="0" rtlCol="0" anchor="ctr"/>
+          <a:lstStyle/>
+          <a:p>
+            <a:pPr indent="0" marL="0">
+              <a:buNone/>
+            </a:pPr>
+            <a:r>
+              <a:rPr lang="en-US" sz="1200" b="1" dirty="0">
+                <a:solidFill>
+                  <a:schemeClr val="accent2"/>
+                </a:solidFill>
+              </a:rPr>
+              <a:t>Files</a:t>
+            </a:r>
+            <a:endParaRPr lang="en-US" sz="1200" dirty="0"/>
+          </a:p>
+        </p:txBody>
+      </p:sp>
+      <p:sp>
+        <p:nvSpPr>
+          <p:cNvPr id="15" name="loading-files-0"/>
+          <p:cNvSpPr txBox="1"/>
+          <p:nvPr/>
+        </p:nvSpPr>
+        <p:spPr>
+          <a:xfrm>
+            <a:off x="777240" y="5166360"/>
+            <a:ext cx="5212080" cy="960120"/>
+          </a:xfrm>
+          <a:prstGeom prst="rect">
+            <a:avLst/>
+          </a:prstGeom>
+          <a:noFill/>
+          <a:ln/>
+        </p:spPr>
+        <p:txBody>
+          <a:bodyPr wrap="square" lIns="0" tIns="0" rIns="0" bIns="0" rtlCol="0" anchor="t"/>
+          <a:lstStyle/>
+          <a:p>
+            <a:pPr indent="0" marL="0">
+              <a:spcAft>
+                <a:spcPts val="300"/>
+              </a:spcAft>
+              <a:buNone/>
+            </a:pPr>
+            <a:r>
+              <a:rPr lang="en-US" sz="950" dirty="0">
+                <a:solidFill>
+                  <a:schemeClr val="tx2"/>
+                </a:solidFill>
+                <a:latin typeface="Courier New" pitchFamily="34" charset="0"/>
+                <a:ea typeface="Courier New" pitchFamily="34" charset="-122"/>
+                <a:cs typeface="Courier New" pitchFamily="34" charset="-120"/>
+              </a:rPr>
+              <a:t>TrainingModule/src/app/core/ui/async-executor.service.ts</a:t>
+            </a:r>
+            <a:endParaRPr lang="en-US" sz="950" dirty="0"/>
+          </a:p>
+          <a:p>
+            <a:pPr indent="0" marL="0">
+              <a:spcAft>
+                <a:spcPts val="300"/>
+              </a:spcAft>
+              <a:buNone/>
+            </a:pPr>
+            <a:r>
+              <a:rPr lang="en-US" sz="950" dirty="0">
+                <a:solidFill>
+                  <a:schemeClr val="tx2"/>
+                </a:solidFill>
+                <a:latin typeface="Courier New" pitchFamily="34" charset="0"/>
+                <a:ea typeface="Courier New" pitchFamily="34" charset="-122"/>
+                <a:cs typeface="Courier New" pitchFamily="34" charset="-120"/>
+              </a:rPr>
+              <a:t>TrainingModule/src/app/core/store/ui-async/ui-async.reducer.ts</a:t>
+            </a:r>
+            <a:endParaRPr lang="en-US" sz="950" dirty="0"/>
+          </a:p>
+          <a:p>
+            <a:pPr indent="0" marL="0">
+              <a:spcAft>
+                <a:spcPts val="300"/>
+              </a:spcAft>
+              <a:buNone/>
+            </a:pPr>
+            <a:r>
+              <a:rPr lang="en-US" sz="950" dirty="0">
+                <a:solidFill>
+                  <a:schemeClr val="tx2"/>
+                </a:solidFill>
+                <a:latin typeface="Courier New" pitchFamily="34" charset="0"/>
+                <a:ea typeface="Courier New" pitchFamily="34" charset="-122"/>
+                <a:cs typeface="Courier New" pitchFamily="34" charset="-120"/>
+              </a:rPr>
+              <a:t>TrainingModule/src/app/layout/main-layout/main-layout.component.ts</a:t>
+            </a:r>
+            <a:endParaRPr lang="en-US" sz="950" dirty="0"/>
+          </a:p>
+          <a:p>
+            <a:pPr indent="0" marL="0">
+              <a:spcAft>
+                <a:spcPts val="300"/>
+              </a:spcAft>
+              <a:buNone/>
+            </a:pPr>
+            <a:r>
+              <a:rPr lang="en-US" sz="950" dirty="0">
+                <a:solidFill>
+                  <a:schemeClr val="tx2"/>
+                </a:solidFill>
+                <a:latin typeface="Courier New" pitchFamily="34" charset="0"/>
+                <a:ea typeface="Courier New" pitchFamily="34" charset="-122"/>
+                <a:cs typeface="Courier New" pitchFamily="34" charset="-120"/>
+              </a:rPr>
+              <a:t>TrainingModule/src/app/core/interceptors/http-error.interceptor.ts</a:t>
+            </a:r>
+            <a:endParaRPr lang="en-US" sz="950" dirty="0"/>
+          </a:p>
+        </p:txBody>
+      </p:sp>
+      <p:sp>
+        <p:nvSpPr>
+          <p:cNvPr id="16" name="loading-files-1"/>
+          <p:cNvSpPr txBox="1"/>
+          <p:nvPr/>
+        </p:nvSpPr>
+        <p:spPr>
+          <a:xfrm>
+            <a:off x="6080760" y="5166360"/>
+            <a:ext cx="5212080" cy="960120"/>
+          </a:xfrm>
+          <a:prstGeom prst="rect">
+            <a:avLst/>
+          </a:prstGeom>
+          <a:noFill/>
+          <a:ln/>
+        </p:spPr>
+        <p:txBody>
+          <a:bodyPr wrap="square" lIns="0" tIns="0" rIns="0" bIns="0" rtlCol="0" anchor="t"/>
+          <a:lstStyle/>
+          <a:p>
+            <a:pPr indent="0" marL="0">
+              <a:spcAft>
+                <a:spcPts val="300"/>
+              </a:spcAft>
+              <a:buNone/>
+            </a:pPr>
+            <a:r>
+              <a:rPr lang="en-US" sz="950" dirty="0">
+                <a:solidFill>
+                  <a:schemeClr val="tx2"/>
+                </a:solidFill>
+                <a:latin typeface="Courier New" pitchFamily="34" charset="0"/>
+                <a:ea typeface="Courier New" pitchFamily="34" charset="-122"/>
+                <a:cs typeface="Courier New" pitchFamily="34" charset="-120"/>
+              </a:rPr>
+              <a:t>TrainingModule/src/app/core/errors/global-error-handler.ts</a:t>
+            </a:r>
+            <a:endParaRPr lang="en-US" sz="950" dirty="0"/>
+          </a:p>
+          <a:p>
+            <a:pPr indent="0" marL="0">
+              <a:spcAft>
+                <a:spcPts val="300"/>
+              </a:spcAft>
+              <a:buNone/>
+            </a:pPr>
+            <a:r>
+              <a:rPr lang="en-US" sz="950" dirty="0">
+                <a:solidFill>
+                  <a:schemeClr val="tx2"/>
+                </a:solidFill>
+                <a:latin typeface="Courier New" pitchFamily="34" charset="0"/>
+                <a:ea typeface="Courier New" pitchFamily="34" charset="-122"/>
+                <a:cs typeface="Courier New" pitchFamily="34" charset="-120"/>
+              </a:rPr>
+              <a:t>TrainingModule/src/app/core/errors/client-error-reporter.service.ts</a:t>
+            </a:r>
+            <a:endParaRPr lang="en-US" sz="950" dirty="0"/>
+          </a:p>
+          <a:p>
+            <a:pPr indent="0" marL="0">
+              <a:spcAft>
+                <a:spcPts val="300"/>
+              </a:spcAft>
+              <a:buNone/>
+            </a:pPr>
+            <a:r>
+              <a:rPr lang="en-US" sz="950" dirty="0">
+                <a:solidFill>
+                  <a:schemeClr val="tx2"/>
+                </a:solidFill>
+                <a:latin typeface="Courier New" pitchFamily="34" charset="0"/>
+                <a:ea typeface="Courier New" pitchFamily="34" charset="-122"/>
+                <a:cs typeface="Courier New" pitchFamily="34" charset="-120"/>
+              </a:rPr>
+              <a:t>Bidding_API/ExceptionHandler/ExceptionMiddlewareExtensions.cs</a:t>
+            </a:r>
+            <a:endParaRPr lang="en-US" sz="950" dirty="0"/>
           </a:p>
         </p:txBody>
       </p:sp>

</xml_diff>

<commit_message>
Deck: trainer/trainee roles for organizations and individuals
Co-authored-by: Cursor <cursoragent@cursor.com>
</commit_message>
<xml_diff>
--- a/docs/training-standards.pptx
+++ b/docs/training-standards.pptx
@@ -19,9 +19,11 @@
     <p:sldId id="267" r:id="rId13"/>
     <p:sldId id="268" r:id="rId14"/>
     <p:sldId id="269" r:id="rId15"/>
+    <p:sldId id="270" r:id="rId16"/>
+    <p:sldId id="271" r:id="rId17"/>
   </p:sldIdLst>
   <p:notesMasterIdLst>
-    <p:notesMasterId r:id="rId16"/>
+    <p:notesMasterId r:id="rId18"/>
   </p:notesMasterIdLst>
   <p:sldSz cx="12192000" cy="6858000"/>
   <p:notesSz cx="6858000" cy="12192000"/>
@@ -120,19 +122,19 @@
   <p:extLst>
     <p:ext uri="{521415D9-36F7-43E2-AB2F-B90AF26B5E84}">
       <p14:sectionLst xmlns:p14="http://schemas.microsoft.com/office/powerpoint/2010/main">
-        <p14:section name="Intro" id="{f446ceb9-4852-00d8-b4c0-3239a4d48b1f}">
+        <p14:section name="Intro" id="{d8800e73-0c8f-7c4c-c1e3-48e4cc245a59}">
           <p14:sldIdLst>
             <p14:sldId id="256"/>
             <p14:sldId id="257"/>
           </p14:sldIdLst>
         </p14:section>
-        <p14:section name="Backend" id="{104c24d1-bd61-03a7-12fd-0217eee9d8d4}">
+        <p14:section name="Backend" id="{2dec100a-b6ee-21cd-b01a-69f16f3f0b93}">
           <p14:sldIdLst>
             <p14:sldId id="258"/>
             <p14:sldId id="259"/>
           </p14:sldIdLst>
         </p14:section>
-        <p14:section name="Frontend" id="{0a61b297-b4af-10a1-8125-2fca5312b195}">
+        <p14:section name="Frontend" id="{eb0ac9b3-9781-1546-ac33-9a32f7883404}">
           <p14:sldIdLst>
             <p14:sldId id="260"/>
             <p14:sldId id="261"/>
@@ -142,16 +144,22 @@
             <p14:sldId id="265"/>
           </p14:sldIdLst>
         </p14:section>
-        <p14:section name="Pages" id="{ee645d21-89f9-9ab7-9602-7cfae371cedf}">
+        <p14:section name="Pages" id="{38ea0cf8-5d65-cca9-6225-c99ad7cdf598}">
           <p14:sldIdLst>
             <p14:sldId id="266"/>
             <p14:sldId id="267"/>
           </p14:sldIdLst>
         </p14:section>
-        <p14:section name="Checklist" id="{1cde8afa-f3e6-c4fb-cb0c-8e0b9e51e943}">
+        <p14:section name="Roles" id="{c4bf5f53-cd6b-aed5-f533-280e9a0f0629}">
           <p14:sldIdLst>
             <p14:sldId id="268"/>
             <p14:sldId id="269"/>
+          </p14:sldIdLst>
+        </p14:section>
+        <p14:section name="Checklist" id="{d61761f7-fae1-9705-61f7-ecc5647a6993}">
+          <p14:sldIdLst>
+            <p14:sldId id="270"/>
+            <p14:sldId id="271"/>
           </p14:sldIdLst>
         </p14:section>
       </p14:sectionLst>
@@ -910,7 +918,7 @@
           <a:p>
             <a:r>
               <a:rPr lang="en-US" dirty="0"/>
-              <a:t>Use this as the PR checklist. If any line is missing, the page is not done.</a:t>
+              <a:t>A role name is UserType.UserGroup. Organizations are Corporate users linked to an Organization row; the company AccountAdmin manages its users and custom roles. Individuals have no organization. The open question is how a company sends its employees as trainees.</a:t>
             </a:r>
             <a:endParaRPr lang="en-US" dirty="0"/>
           </a:p>
@@ -998,7 +1006,7 @@
           <a:p>
             <a:r>
               <a:rPr lang="en-US" dirty="0"/>
-              <a:t>Questions. Point the team at the README for setup: connection string, JWT keys to change, and the no-migrations rule.</a:t>
+              <a:t>Steps 1 to 4 are normal work for every new page. Steps 5 and 6 touch shared enums and seed data, so agree them with the platform team before coding. Restart the API with the seeder enabled on a dev database to pick up role-page changes.</a:t>
             </a:r>
             <a:endParaRPr lang="en-US" dirty="0"/>
           </a:p>
@@ -1022,6 +1030,182 @@
             <a:fld id="{F7021451-1387-4CA6-816F-3879F97B5CBC}" type="slidenum">
               <a:rPr lang="en-US"/>
               <a:t>14</a:t>
+            </a:fld>
+            <a:endParaRPr lang="en-US"/>
+          </a:p>
+        </p:txBody>
+      </p:sp>
+    </p:spTree>
+    <p:extLst>
+      <p:ext uri="{BB962C8B-B14F-4D97-AF65-F5344CB8AC3E}">
+        <p14:creationId xmlns:p14="http://schemas.microsoft.com/office/powerpoint/2010/main" val="1024086991"/>
+      </p:ext>
+    </p:extLst>
+  </p:cSld>
+  <p:clrMapOvr>
+    <a:masterClrMapping/>
+  </p:clrMapOvr>
+</p:notes>
+</file>
+
+<file path=ppt/notesSlides/notesSlide15.xml><?xml version="1.0" encoding="utf-8"?>
+<p:notes xmlns:a="http://schemas.openxmlformats.org/drawingml/2006/main" xmlns:r="http://schemas.openxmlformats.org/officeDocument/2006/relationships" xmlns:p="http://schemas.openxmlformats.org/presentationml/2006/main">
+  <p:cSld>
+    <p:spTree>
+      <p:nvGrpSpPr>
+        <p:cNvPr id="1" name=""/>
+        <p:cNvGrpSpPr/>
+        <p:nvPr/>
+      </p:nvGrpSpPr>
+      <p:grpSpPr>
+        <a:xfrm>
+          <a:off x="0" y="0"/>
+          <a:ext cx="0" cy="0"/>
+          <a:chOff x="0" y="0"/>
+          <a:chExt cx="0" cy="0"/>
+        </a:xfrm>
+      </p:grpSpPr>
+      <p:sp>
+        <p:nvSpPr>
+          <p:cNvPr id="2" name="Slide Image Placeholder 1"/>
+          <p:cNvSpPr>
+            <a:spLocks noGrp="1" noRot="1" noChangeAspect="1"/>
+          </p:cNvSpPr>
+          <p:nvPr>
+            <p:ph type="sldImg"/>
+          </p:nvPr>
+        </p:nvSpPr>
+        <p:spPr/>
+      </p:sp>
+      <p:sp>
+        <p:nvSpPr>
+          <p:cNvPr id="3" name="Notes Placeholder 2"/>
+          <p:cNvSpPr>
+            <a:spLocks noGrp="1"/>
+          </p:cNvSpPr>
+          <p:nvPr>
+            <p:ph type="body" idx="1"/>
+          </p:nvPr>
+        </p:nvSpPr>
+        <p:spPr/>
+        <p:txBody>
+          <a:bodyPr/>
+          <a:lstStyle/>
+          <a:p>
+            <a:r>
+              <a:rPr lang="en-US" dirty="0"/>
+              <a:t>Use this as the PR checklist. If any line is missing, the page is not done.</a:t>
+            </a:r>
+            <a:endParaRPr lang="en-US" dirty="0"/>
+          </a:p>
+        </p:txBody>
+      </p:sp>
+      <p:sp>
+        <p:nvSpPr>
+          <p:cNvPr id="4" name="Slide Number Placeholder 3"/>
+          <p:cNvSpPr>
+            <a:spLocks noGrp="1"/>
+          </p:cNvSpPr>
+          <p:nvPr>
+            <p:ph type="sldNum" sz="quarter" idx="10"/>
+          </p:nvPr>
+        </p:nvSpPr>
+        <p:spPr/>
+        <p:txBody>
+          <a:bodyPr/>
+          <a:lstStyle/>
+          <a:p>
+            <a:fld id="{F7021451-1387-4CA6-816F-3879F97B5CBC}" type="slidenum">
+              <a:rPr lang="en-US"/>
+              <a:t>15</a:t>
+            </a:fld>
+            <a:endParaRPr lang="en-US"/>
+          </a:p>
+        </p:txBody>
+      </p:sp>
+    </p:spTree>
+    <p:extLst>
+      <p:ext uri="{BB962C8B-B14F-4D97-AF65-F5344CB8AC3E}">
+        <p14:creationId xmlns:p14="http://schemas.microsoft.com/office/powerpoint/2010/main" val="1024086991"/>
+      </p:ext>
+    </p:extLst>
+  </p:cSld>
+  <p:clrMapOvr>
+    <a:masterClrMapping/>
+  </p:clrMapOvr>
+</p:notes>
+</file>
+
+<file path=ppt/notesSlides/notesSlide16.xml><?xml version="1.0" encoding="utf-8"?>
+<p:notes xmlns:a="http://schemas.openxmlformats.org/drawingml/2006/main" xmlns:r="http://schemas.openxmlformats.org/officeDocument/2006/relationships" xmlns:p="http://schemas.openxmlformats.org/presentationml/2006/main">
+  <p:cSld>
+    <p:spTree>
+      <p:nvGrpSpPr>
+        <p:cNvPr id="1" name=""/>
+        <p:cNvGrpSpPr/>
+        <p:nvPr/>
+      </p:nvGrpSpPr>
+      <p:grpSpPr>
+        <a:xfrm>
+          <a:off x="0" y="0"/>
+          <a:ext cx="0" cy="0"/>
+          <a:chOff x="0" y="0"/>
+          <a:chExt cx="0" cy="0"/>
+        </a:xfrm>
+      </p:grpSpPr>
+      <p:sp>
+        <p:nvSpPr>
+          <p:cNvPr id="2" name="Slide Image Placeholder 1"/>
+          <p:cNvSpPr>
+            <a:spLocks noGrp="1" noRot="1" noChangeAspect="1"/>
+          </p:cNvSpPr>
+          <p:nvPr>
+            <p:ph type="sldImg"/>
+          </p:nvPr>
+        </p:nvSpPr>
+        <p:spPr/>
+      </p:sp>
+      <p:sp>
+        <p:nvSpPr>
+          <p:cNvPr id="3" name="Notes Placeholder 2"/>
+          <p:cNvSpPr>
+            <a:spLocks noGrp="1"/>
+          </p:cNvSpPr>
+          <p:nvPr>
+            <p:ph type="body" idx="1"/>
+          </p:nvPr>
+        </p:nvSpPr>
+        <p:spPr/>
+        <p:txBody>
+          <a:bodyPr/>
+          <a:lstStyle/>
+          <a:p>
+            <a:r>
+              <a:rPr lang="en-US" dirty="0"/>
+              <a:t>Questions. Point the team at the README for setup: connection string, JWT keys to change, and the no-migrations rule.</a:t>
+            </a:r>
+            <a:endParaRPr lang="en-US" dirty="0"/>
+          </a:p>
+        </p:txBody>
+      </p:sp>
+      <p:sp>
+        <p:nvSpPr>
+          <p:cNvPr id="4" name="Slide Number Placeholder 3"/>
+          <p:cNvSpPr>
+            <a:spLocks noGrp="1"/>
+          </p:cNvSpPr>
+          <p:nvPr>
+            <p:ph type="sldNum" sz="quarter" idx="10"/>
+          </p:nvPr>
+        </p:nvSpPr>
+        <p:spPr/>
+        <p:txBody>
+          <a:bodyPr/>
+          <a:lstStyle/>
+          <a:p>
+            <a:fld id="{F7021451-1387-4CA6-816F-3879F97B5CBC}" type="slidenum">
+              <a:rPr lang="en-US"/>
+              <a:t>16</a:t>
             </a:fld>
             <a:endParaRPr lang="en-US"/>
           </a:p>
@@ -5693,7 +5877,7 @@
                   <a:schemeClr val="tx2"/>
                 </a:solidFill>
               </a:rPr>
-              <a:t>Adding a new page: the checklist</a:t>
+              <a:t>Trainers and trainees, as organizations and individuals</a:t>
             </a:r>
             <a:endParaRPr lang="en-US" sz="3600" dirty="0"/>
           </a:p>
@@ -5701,17 +5885,91 @@
       </p:sp>
       <p:sp>
         <p:nvSpPr>
-          <p:cNvPr id="3" name="chk-0-badge"/>
+          <p:cNvPr id="3" name="rm-col-0"/>
+          <p:cNvSpPr txBox="1"/>
+          <p:nvPr/>
+        </p:nvSpPr>
+        <p:spPr>
+          <a:xfrm>
+            <a:off x="2148840" y="1325880"/>
+            <a:ext cx="4663440" cy="411480"/>
+          </a:xfrm>
+          <a:prstGeom prst="rect">
+            <a:avLst/>
+          </a:prstGeom>
+          <a:noFill/>
+          <a:ln/>
+        </p:spPr>
+        <p:txBody>
+          <a:bodyPr wrap="square" lIns="0" tIns="0" rIns="0" bIns="0" rtlCol="0" anchor="ctr"/>
+          <a:lstStyle/>
+          <a:p>
+            <a:pPr algn="ctr" indent="0" marL="0">
+              <a:buNone/>
+            </a:pPr>
+            <a:r>
+              <a:rPr lang="en-US" sz="1700" b="1" dirty="0">
+                <a:solidFill>
+                  <a:schemeClr val="tx2"/>
+                </a:solidFill>
+              </a:rPr>
+              <a:t>Organization (Corporate)</a:t>
+            </a:r>
+            <a:endParaRPr lang="en-US" sz="1700" dirty="0"/>
+          </a:p>
+        </p:txBody>
+      </p:sp>
+      <p:sp>
+        <p:nvSpPr>
+          <p:cNvPr id="4" name="rm-col-1"/>
+          <p:cNvSpPr txBox="1"/>
+          <p:nvPr/>
+        </p:nvSpPr>
+        <p:spPr>
+          <a:xfrm>
+            <a:off x="6949440" y="1325880"/>
+            <a:ext cx="4663440" cy="411480"/>
+          </a:xfrm>
+          <a:prstGeom prst="rect">
+            <a:avLst/>
+          </a:prstGeom>
+          <a:noFill/>
+          <a:ln/>
+        </p:spPr>
+        <p:txBody>
+          <a:bodyPr wrap="square" lIns="0" tIns="0" rIns="0" bIns="0" rtlCol="0" anchor="ctr"/>
+          <a:lstStyle/>
+          <a:p>
+            <a:pPr algn="ctr" indent="0" marL="0">
+              <a:buNone/>
+            </a:pPr>
+            <a:r>
+              <a:rPr lang="en-US" sz="1700" b="1" dirty="0">
+                <a:solidFill>
+                  <a:schemeClr val="tx2"/>
+                </a:solidFill>
+              </a:rPr>
+              <a:t>Individual</a:t>
+            </a:r>
+            <a:endParaRPr lang="en-US" sz="1700" dirty="0"/>
+          </a:p>
+        </p:txBody>
+      </p:sp>
+      <p:sp>
+        <p:nvSpPr>
+          <p:cNvPr id="5" name="rm-row-0"/>
           <p:cNvSpPr/>
           <p:nvPr/>
         </p:nvSpPr>
         <p:spPr>
           <a:xfrm>
-            <a:off x="548640" y="1572768"/>
-            <a:ext cx="502920" cy="502920"/>
-          </a:xfrm>
-          <a:prstGeom prst="ellipse">
-            <a:avLst/>
+            <a:off x="548640" y="1874520"/>
+            <a:ext cx="1463040" cy="1874520"/>
+          </a:xfrm>
+          <a:prstGeom prst="roundRect">
+            <a:avLst>
+              <a:gd name="adj" fmla="val 7500"/>
+            </a:avLst>
           </a:prstGeom>
           <a:solidFill>
             <a:schemeClr val="tx2"/>
@@ -5726,14 +5984,14 @@
       </p:sp>
       <p:sp>
         <p:nvSpPr>
-          <p:cNvPr id="4" name="chk-0-badge-text"/>
-          <p:cNvSpPr txBox="1"/>
-          <p:nvPr/>
-        </p:nvSpPr>
-        <p:spPr>
-          <a:xfrm>
-            <a:off x="548640" y="1572768"/>
-            <a:ext cx="502920" cy="502920"/>
+          <p:cNvPr id="6" name="rm-row-0-t"/>
+          <p:cNvSpPr txBox="1"/>
+          <p:nvPr/>
+        </p:nvSpPr>
+        <p:spPr>
+          <a:xfrm>
+            <a:off x="548640" y="1874520"/>
+            <a:ext cx="1463040" cy="1874520"/>
           </a:xfrm>
           <a:prstGeom prst="rect">
             <a:avLst/>
@@ -5749,89 +6007,32 @@
               <a:buNone/>
             </a:pPr>
             <a:r>
-              <a:rPr lang="en-US" sz="1600" b="1" dirty="0">
+              <a:rPr lang="en-US" sz="1800" b="1" dirty="0">
                 <a:solidFill>
                   <a:schemeClr val="bg1"/>
                 </a:solidFill>
               </a:rPr>
-              <a:t>1</a:t>
-            </a:r>
-            <a:endParaRPr lang="en-US" sz="1600" dirty="0"/>
-          </a:p>
-        </p:txBody>
-      </p:sp>
-      <p:sp>
-        <p:nvSpPr>
-          <p:cNvPr id="5" name="chk-0-t"/>
-          <p:cNvSpPr txBox="1"/>
-          <p:nvPr/>
-        </p:nvSpPr>
-        <p:spPr>
-          <a:xfrm>
-            <a:off x="1280160" y="1417320"/>
-            <a:ext cx="4754880" cy="822960"/>
-          </a:xfrm>
-          <a:prstGeom prst="rect">
-            <a:avLst/>
-          </a:prstGeom>
-          <a:noFill/>
-          <a:ln/>
-        </p:spPr>
-        <p:txBody>
-          <a:bodyPr wrap="square" lIns="0" tIns="0" rIns="0" bIns="0" rtlCol="0" anchor="ctr"/>
-          <a:lstStyle/>
-          <a:p>
-            <a:pPr indent="0" marL="0">
-              <a:spcAft>
-                <a:spcPts val="200"/>
-              </a:spcAft>
-              <a:buNone/>
-            </a:pPr>
-            <a:r>
-              <a:rPr lang="en-US" sz="1700" dirty="0">
-                <a:solidFill>
-                  <a:schemeClr val="tx1"/>
-                </a:solidFill>
-              </a:rPr>
-              <a:t>Route and sidebar link</a:t>
-            </a:r>
-            <a:endParaRPr lang="en-US" sz="1700" dirty="0"/>
-          </a:p>
-          <a:p>
-            <a:pPr indent="0" marL="0">
-              <a:spcAft>
-                <a:spcPts val="200"/>
-              </a:spcAft>
-              <a:buNone/>
-            </a:pPr>
-            <a:r>
-              <a:rPr lang="en-US" sz="1050" dirty="0">
-                <a:solidFill>
-                  <a:schemeClr val="tx2"/>
-                </a:solidFill>
-                <a:latin typeface="Courier New" pitchFamily="34" charset="0"/>
-                <a:ea typeface="Courier New" pitchFamily="34" charset="-122"/>
-                <a:cs typeface="Courier New" pitchFamily="34" charset="-120"/>
-              </a:rPr>
-              <a:t>TrainingModule/src/app/app.routes.ts</a:t>
-            </a:r>
-            <a:endParaRPr lang="en-US" sz="1700" dirty="0"/>
-          </a:p>
-        </p:txBody>
-      </p:sp>
-      <p:sp>
-        <p:nvSpPr>
-          <p:cNvPr id="6" name="chk-1-badge"/>
+              <a:t>Trainer</a:t>
+            </a:r>
+            <a:endParaRPr lang="en-US" sz="1800" dirty="0"/>
+          </a:p>
+        </p:txBody>
+      </p:sp>
+      <p:sp>
+        <p:nvSpPr>
+          <p:cNvPr id="7" name="rm-row-1"/>
           <p:cNvSpPr/>
           <p:nvPr/>
         </p:nvSpPr>
         <p:spPr>
           <a:xfrm>
-            <a:off x="548640" y="2670048"/>
-            <a:ext cx="502920" cy="502920"/>
-          </a:xfrm>
-          <a:prstGeom prst="ellipse">
-            <a:avLst/>
+            <a:off x="548640" y="3931920"/>
+            <a:ext cx="1463040" cy="1874520"/>
+          </a:xfrm>
+          <a:prstGeom prst="roundRect">
+            <a:avLst>
+              <a:gd name="adj" fmla="val 7500"/>
+            </a:avLst>
           </a:prstGeom>
           <a:solidFill>
             <a:schemeClr val="tx2"/>
@@ -5846,14 +6047,14 @@
       </p:sp>
       <p:sp>
         <p:nvSpPr>
-          <p:cNvPr id="7" name="chk-1-badge-text"/>
-          <p:cNvSpPr txBox="1"/>
-          <p:nvPr/>
-        </p:nvSpPr>
-        <p:spPr>
-          <a:xfrm>
-            <a:off x="548640" y="2670048"/>
-            <a:ext cx="502920" cy="502920"/>
+          <p:cNvPr id="8" name="rm-row-1-t"/>
+          <p:cNvSpPr txBox="1"/>
+          <p:nvPr/>
+        </p:nvSpPr>
+        <p:spPr>
+          <a:xfrm>
+            <a:off x="548640" y="3931920"/>
+            <a:ext cx="1463040" cy="1874520"/>
           </a:xfrm>
           <a:prstGeom prst="rect">
             <a:avLst/>
@@ -5869,27 +6070,54 @@
               <a:buNone/>
             </a:pPr>
             <a:r>
-              <a:rPr lang="en-US" sz="1600" b="1" dirty="0">
+              <a:rPr lang="en-US" sz="1800" b="1" dirty="0">
                 <a:solidFill>
                   <a:schemeClr val="bg1"/>
                 </a:solidFill>
               </a:rPr>
-              <a:t>2</a:t>
-            </a:r>
-            <a:endParaRPr lang="en-US" sz="1600" dirty="0"/>
-          </a:p>
-        </p:txBody>
-      </p:sp>
-      <p:sp>
-        <p:nvSpPr>
-          <p:cNvPr id="8" name="chk-1-t"/>
-          <p:cNvSpPr txBox="1"/>
-          <p:nvPr/>
-        </p:nvSpPr>
-        <p:spPr>
-          <a:xfrm>
-            <a:off x="1280160" y="2514600"/>
-            <a:ext cx="4754880" cy="822960"/>
+              <a:t>Trainee</a:t>
+            </a:r>
+            <a:endParaRPr lang="en-US" sz="1800" dirty="0"/>
+          </a:p>
+        </p:txBody>
+      </p:sp>
+      <p:sp>
+        <p:nvSpPr>
+          <p:cNvPr id="9" name="rm-cell-0"/>
+          <p:cNvSpPr/>
+          <p:nvPr/>
+        </p:nvSpPr>
+        <p:spPr>
+          <a:xfrm>
+            <a:off x="2148840" y="1874520"/>
+            <a:ext cx="4663440" cy="1874520"/>
+          </a:xfrm>
+          <a:prstGeom prst="roundRect">
+            <a:avLst>
+              <a:gd name="adj" fmla="val 5854"/>
+            </a:avLst>
+          </a:prstGeom>
+          <a:solidFill>
+            <a:schemeClr val="bg2"/>
+          </a:solidFill>
+          <a:ln w="6350">
+            <a:solidFill>
+              <a:schemeClr val="bg2"/>
+            </a:solidFill>
+            <a:prstDash val="solid"/>
+          </a:ln>
+        </p:spPr>
+      </p:sp>
+      <p:sp>
+        <p:nvSpPr>
+          <p:cNvPr id="10" name="rm-cell-0-name"/>
+          <p:cNvSpPr txBox="1"/>
+          <p:nvPr/>
+        </p:nvSpPr>
+        <p:spPr>
+          <a:xfrm>
+            <a:off x="2377440" y="2057400"/>
+            <a:ext cx="2651760" cy="365760"/>
           </a:xfrm>
           <a:prstGeom prst="rect">
             <a:avLst/>
@@ -5902,30 +6130,10 @@
           <a:lstStyle/>
           <a:p>
             <a:pPr indent="0" marL="0">
-              <a:spcAft>
-                <a:spcPts val="200"/>
-              </a:spcAft>
-              <a:buNone/>
-            </a:pPr>
-            <a:r>
-              <a:rPr lang="en-US" sz="1700" dirty="0">
-                <a:solidFill>
-                  <a:schemeClr val="tx1"/>
-                </a:solidFill>
-              </a:rPr>
-              <a:t>AppPage seed entry with the same URL</a:t>
-            </a:r>
-            <a:endParaRPr lang="en-US" sz="1700" dirty="0"/>
-          </a:p>
-          <a:p>
-            <a:pPr indent="0" marL="0">
-              <a:spcAft>
-                <a:spcPts val="200"/>
-              </a:spcAft>
-              <a:buNone/>
-            </a:pPr>
-            <a:r>
-              <a:rPr lang="en-US" sz="1050" dirty="0">
+              <a:buNone/>
+            </a:pPr>
+            <a:r>
+              <a:rPr lang="en-US" sz="1500" b="1" dirty="0">
                 <a:solidFill>
                   <a:schemeClr val="tx2"/>
                 </a:solidFill>
@@ -5933,32 +6141,34 @@
                 <a:ea typeface="Courier New" pitchFamily="34" charset="-122"/>
                 <a:cs typeface="Courier New" pitchFamily="34" charset="-120"/>
               </a:rPr>
-              <a:t>Bidding_DLL/Seeding/IdentityAccessAppPagesSeedData.cs</a:t>
-            </a:r>
-            <a:endParaRPr lang="en-US" sz="1700" dirty="0"/>
-          </a:p>
-        </p:txBody>
-      </p:sp>
-      <p:sp>
-        <p:nvSpPr>
-          <p:cNvPr id="9" name="chk-2-badge"/>
+              <a:t>Corporate.Trainer</a:t>
+            </a:r>
+            <a:endParaRPr lang="en-US" sz="1500" dirty="0"/>
+          </a:p>
+        </p:txBody>
+      </p:sp>
+      <p:sp>
+        <p:nvSpPr>
+          <p:cNvPr id="11" name="rm-cell-0-pill"/>
           <p:cNvSpPr/>
           <p:nvPr/>
         </p:nvSpPr>
         <p:spPr>
           <a:xfrm>
-            <a:off x="548640" y="3767328"/>
-            <a:ext cx="502920" cy="502920"/>
-          </a:xfrm>
-          <a:prstGeom prst="ellipse">
-            <a:avLst/>
+            <a:off x="4937760" y="2075688"/>
+            <a:ext cx="1645920" cy="329184"/>
+          </a:xfrm>
+          <a:prstGeom prst="roundRect">
+            <a:avLst>
+              <a:gd name="adj" fmla="val 50000"/>
+            </a:avLst>
           </a:prstGeom>
           <a:solidFill>
-            <a:schemeClr val="tx2"/>
+            <a:schemeClr val="accent3"/>
           </a:solidFill>
           <a:ln w="12700">
             <a:solidFill>
-              <a:schemeClr val="tx2"/>
+              <a:schemeClr val="accent3"/>
             </a:solidFill>
             <a:prstDash val="solid"/>
           </a:ln>
@@ -5966,14 +6176,14 @@
       </p:sp>
       <p:sp>
         <p:nvSpPr>
-          <p:cNvPr id="10" name="chk-2-badge-text"/>
-          <p:cNvSpPr txBox="1"/>
-          <p:nvPr/>
-        </p:nvSpPr>
-        <p:spPr>
-          <a:xfrm>
-            <a:off x="548640" y="3767328"/>
-            <a:ext cx="502920" cy="502920"/>
+          <p:cNvPr id="12" name="rm-cell-0-status"/>
+          <p:cNvSpPr txBox="1"/>
+          <p:nvPr/>
+        </p:nvSpPr>
+        <p:spPr>
+          <a:xfrm>
+            <a:off x="4937760" y="2075688"/>
+            <a:ext cx="1645920" cy="329184"/>
           </a:xfrm>
           <a:prstGeom prst="rect">
             <a:avLst/>
@@ -5989,27 +6199,90 @@
               <a:buNone/>
             </a:pPr>
             <a:r>
-              <a:rPr lang="en-US" sz="1600" b="1" dirty="0">
+              <a:rPr lang="en-US" sz="1100" b="1" dirty="0">
                 <a:solidFill>
                   <a:schemeClr val="bg1"/>
                 </a:solidFill>
               </a:rPr>
-              <a:t>3</a:t>
-            </a:r>
-            <a:endParaRPr lang="en-US" sz="1600" dirty="0"/>
-          </a:p>
-        </p:txBody>
-      </p:sp>
-      <p:sp>
-        <p:nvSpPr>
-          <p:cNvPr id="11" name="chk-2-t"/>
-          <p:cNvSpPr txBox="1"/>
-          <p:nvPr/>
-        </p:nvSpPr>
-        <p:spPr>
-          <a:xfrm>
-            <a:off x="1280160" y="3611880"/>
-            <a:ext cx="4754880" cy="822960"/>
+              <a:t>Exists · row 8</a:t>
+            </a:r>
+            <a:endParaRPr lang="en-US" sz="1100" dirty="0"/>
+          </a:p>
+        </p:txBody>
+      </p:sp>
+      <p:sp>
+        <p:nvSpPr>
+          <p:cNvPr id="13" name="rm-cell-0-body"/>
+          <p:cNvSpPr txBox="1"/>
+          <p:nvPr/>
+        </p:nvSpPr>
+        <p:spPr>
+          <a:xfrm>
+            <a:off x="2377440" y="2560320"/>
+            <a:ext cx="4206240" cy="1051560"/>
+          </a:xfrm>
+          <a:prstGeom prst="rect">
+            <a:avLst/>
+          </a:prstGeom>
+          <a:noFill/>
+          <a:ln/>
+        </p:spPr>
+        <p:txBody>
+          <a:bodyPr wrap="square" lIns="0" tIns="0" rIns="0" bIns="0" rtlCol="0" anchor="t"/>
+          <a:lstStyle/>
+          <a:p>
+            <a:pPr indent="0" marL="0">
+              <a:buNone/>
+            </a:pPr>
+            <a:r>
+              <a:rPr lang="en-US" sz="1400" dirty="0">
+                <a:solidFill>
+                  <a:schemeClr val="tx1"/>
+                </a:solidFill>
+              </a:rPr>
+              <a:t>Training provider company. Its AccountAdmin adds trainer users and can clone custom roles from this template. Claims: training.read, training.write.</a:t>
+            </a:r>
+            <a:endParaRPr lang="en-US" sz="1400" dirty="0"/>
+          </a:p>
+        </p:txBody>
+      </p:sp>
+      <p:sp>
+        <p:nvSpPr>
+          <p:cNvPr id="14" name="rm-cell-1"/>
+          <p:cNvSpPr/>
+          <p:nvPr/>
+        </p:nvSpPr>
+        <p:spPr>
+          <a:xfrm>
+            <a:off x="6949440" y="1874520"/>
+            <a:ext cx="4663440" cy="1874520"/>
+          </a:xfrm>
+          <a:prstGeom prst="roundRect">
+            <a:avLst>
+              <a:gd name="adj" fmla="val 5854"/>
+            </a:avLst>
+          </a:prstGeom>
+          <a:solidFill>
+            <a:schemeClr val="bg2"/>
+          </a:solidFill>
+          <a:ln w="6350">
+            <a:solidFill>
+              <a:schemeClr val="bg2"/>
+            </a:solidFill>
+            <a:prstDash val="solid"/>
+          </a:ln>
+        </p:spPr>
+      </p:sp>
+      <p:sp>
+        <p:nvSpPr>
+          <p:cNvPr id="15" name="rm-cell-1-name"/>
+          <p:cNvSpPr txBox="1"/>
+          <p:nvPr/>
+        </p:nvSpPr>
+        <p:spPr>
+          <a:xfrm>
+            <a:off x="7178040" y="2057400"/>
+            <a:ext cx="2651760" cy="365760"/>
           </a:xfrm>
           <a:prstGeom prst="rect">
             <a:avLst/>
@@ -6022,30 +6295,10 @@
           <a:lstStyle/>
           <a:p>
             <a:pPr indent="0" marL="0">
-              <a:spcAft>
-                <a:spcPts val="200"/>
-              </a:spcAft>
-              <a:buNone/>
-            </a:pPr>
-            <a:r>
-              <a:rPr lang="en-US" sz="1700" dirty="0">
-                <a:solidFill>
-                  <a:schemeClr val="tx1"/>
-                </a:solidFill>
-              </a:rPr>
-              <a:t>API endpoint + service rule + DTOs</a:t>
-            </a:r>
-            <a:endParaRPr lang="en-US" sz="1700" dirty="0"/>
-          </a:p>
-          <a:p>
-            <a:pPr indent="0" marL="0">
-              <a:spcAft>
-                <a:spcPts val="200"/>
-              </a:spcAft>
-              <a:buNone/>
-            </a:pPr>
-            <a:r>
-              <a:rPr lang="en-US" sz="1050" dirty="0">
+              <a:buNone/>
+            </a:pPr>
+            <a:r>
+              <a:rPr lang="en-US" sz="1500" b="1" dirty="0">
                 <a:solidFill>
                   <a:schemeClr val="tx2"/>
                 </a:solidFill>
@@ -6053,32 +6306,34 @@
                 <a:ea typeface="Courier New" pitchFamily="34" charset="-122"/>
                 <a:cs typeface="Courier New" pitchFamily="34" charset="-120"/>
               </a:rPr>
-              <a:t>Bidding_API/Controllers/V2/ · Bidding_Core/Services/</a:t>
-            </a:r>
-            <a:endParaRPr lang="en-US" sz="1700" dirty="0"/>
-          </a:p>
-        </p:txBody>
-      </p:sp>
-      <p:sp>
-        <p:nvSpPr>
-          <p:cNvPr id="12" name="chk-3-badge"/>
+              <a:t>Individual.Trainer</a:t>
+            </a:r>
+            <a:endParaRPr lang="en-US" sz="1500" dirty="0"/>
+          </a:p>
+        </p:txBody>
+      </p:sp>
+      <p:sp>
+        <p:nvSpPr>
+          <p:cNvPr id="16" name="rm-cell-1-pill"/>
           <p:cNvSpPr/>
           <p:nvPr/>
         </p:nvSpPr>
         <p:spPr>
           <a:xfrm>
-            <a:off x="548640" y="4864608"/>
-            <a:ext cx="502920" cy="502920"/>
-          </a:xfrm>
-          <a:prstGeom prst="ellipse">
-            <a:avLst/>
+            <a:off x="9738360" y="2075688"/>
+            <a:ext cx="1645920" cy="329184"/>
+          </a:xfrm>
+          <a:prstGeom prst="roundRect">
+            <a:avLst>
+              <a:gd name="adj" fmla="val 50000"/>
+            </a:avLst>
           </a:prstGeom>
           <a:solidFill>
-            <a:schemeClr val="tx2"/>
+            <a:schemeClr val="accent3"/>
           </a:solidFill>
           <a:ln w="12700">
             <a:solidFill>
-              <a:schemeClr val="tx2"/>
+              <a:schemeClr val="accent3"/>
             </a:solidFill>
             <a:prstDash val="solid"/>
           </a:ln>
@@ -6086,14 +6341,14 @@
       </p:sp>
       <p:sp>
         <p:nvSpPr>
-          <p:cNvPr id="13" name="chk-3-badge-text"/>
-          <p:cNvSpPr txBox="1"/>
-          <p:nvPr/>
-        </p:nvSpPr>
-        <p:spPr>
-          <a:xfrm>
-            <a:off x="548640" y="4864608"/>
-            <a:ext cx="502920" cy="502920"/>
+          <p:cNvPr id="17" name="rm-cell-1-status"/>
+          <p:cNvSpPr txBox="1"/>
+          <p:nvPr/>
+        </p:nvSpPr>
+        <p:spPr>
+          <a:xfrm>
+            <a:off x="9738360" y="2075688"/>
+            <a:ext cx="1645920" cy="329184"/>
           </a:xfrm>
           <a:prstGeom prst="rect">
             <a:avLst/>
@@ -6109,27 +6364,90 @@
               <a:buNone/>
             </a:pPr>
             <a:r>
-              <a:rPr lang="en-US" sz="1600" b="1" dirty="0">
+              <a:rPr lang="en-US" sz="1100" b="1" dirty="0">
                 <a:solidFill>
                   <a:schemeClr val="bg1"/>
                 </a:solidFill>
               </a:rPr>
-              <a:t>4</a:t>
-            </a:r>
-            <a:endParaRPr lang="en-US" sz="1600" dirty="0"/>
-          </a:p>
-        </p:txBody>
-      </p:sp>
-      <p:sp>
-        <p:nvSpPr>
-          <p:cNvPr id="14" name="chk-3-t"/>
-          <p:cNvSpPr txBox="1"/>
-          <p:nvPr/>
-        </p:nvSpPr>
-        <p:spPr>
-          <a:xfrm>
-            <a:off x="1280160" y="4709160"/>
-            <a:ext cx="4754880" cy="822960"/>
+              <a:t>Exists · row 12</a:t>
+            </a:r>
+            <a:endParaRPr lang="en-US" sz="1100" dirty="0"/>
+          </a:p>
+        </p:txBody>
+      </p:sp>
+      <p:sp>
+        <p:nvSpPr>
+          <p:cNvPr id="18" name="rm-cell-1-body"/>
+          <p:cNvSpPr txBox="1"/>
+          <p:nvPr/>
+        </p:nvSpPr>
+        <p:spPr>
+          <a:xfrm>
+            <a:off x="7178040" y="2560320"/>
+            <a:ext cx="4206240" cy="1051560"/>
+          </a:xfrm>
+          <a:prstGeom prst="rect">
+            <a:avLst/>
+          </a:prstGeom>
+          <a:noFill/>
+          <a:ln/>
+        </p:spPr>
+        <p:txBody>
+          <a:bodyPr wrap="square" lIns="0" tIns="0" rIns="0" bIns="0" rtlCol="0" anchor="t"/>
+          <a:lstStyle/>
+          <a:p>
+            <a:pPr indent="0" marL="0">
+              <a:buNone/>
+            </a:pPr>
+            <a:r>
+              <a:rPr lang="en-US" sz="1400" dirty="0">
+                <a:solidFill>
+                  <a:schemeClr val="tx1"/>
+                </a:solidFill>
+              </a:rPr>
+              <a:t>Independent trainer with a personal account. Same training claims; sees only their own data.</a:t>
+            </a:r>
+            <a:endParaRPr lang="en-US" sz="1400" dirty="0"/>
+          </a:p>
+        </p:txBody>
+      </p:sp>
+      <p:sp>
+        <p:nvSpPr>
+          <p:cNvPr id="19" name="rm-cell-2"/>
+          <p:cNvSpPr/>
+          <p:nvPr/>
+        </p:nvSpPr>
+        <p:spPr>
+          <a:xfrm>
+            <a:off x="2148840" y="3931920"/>
+            <a:ext cx="4663440" cy="1874520"/>
+          </a:xfrm>
+          <a:prstGeom prst="roundRect">
+            <a:avLst>
+              <a:gd name="adj" fmla="val 5854"/>
+            </a:avLst>
+          </a:prstGeom>
+          <a:solidFill>
+            <a:schemeClr val="bg1"/>
+          </a:solidFill>
+          <a:ln w="19050">
+            <a:solidFill>
+              <a:schemeClr val="accent2"/>
+            </a:solidFill>
+            <a:prstDash val="dash"/>
+          </a:ln>
+        </p:spPr>
+      </p:sp>
+      <p:sp>
+        <p:nvSpPr>
+          <p:cNvPr id="20" name="rm-cell-2-name"/>
+          <p:cNvSpPr txBox="1"/>
+          <p:nvPr/>
+        </p:nvSpPr>
+        <p:spPr>
+          <a:xfrm>
+            <a:off x="2377440" y="4114800"/>
+            <a:ext cx="2651760" cy="365760"/>
           </a:xfrm>
           <a:prstGeom prst="rect">
             <a:avLst/>
@@ -6142,30 +6460,10 @@
           <a:lstStyle/>
           <a:p>
             <a:pPr indent="0" marL="0">
-              <a:spcAft>
-                <a:spcPts val="200"/>
-              </a:spcAft>
-              <a:buNone/>
-            </a:pPr>
-            <a:r>
-              <a:rPr lang="en-US" sz="1700" dirty="0">
-                <a:solidFill>
-                  <a:schemeClr val="tx1"/>
-                </a:solidFill>
-              </a:rPr>
-              <a:t>Data service, then NgRx slice if shared</a:t>
-            </a:r>
-            <a:endParaRPr lang="en-US" sz="1700" dirty="0"/>
-          </a:p>
-          <a:p>
-            <a:pPr indent="0" marL="0">
-              <a:spcAft>
-                <a:spcPts val="200"/>
-              </a:spcAft>
-              <a:buNone/>
-            </a:pPr>
-            <a:r>
-              <a:rPr lang="en-US" sz="1050" dirty="0">
+              <a:buNone/>
+            </a:pPr>
+            <a:r>
+              <a:rPr lang="en-US" sz="1500" b="1" dirty="0">
                 <a:solidFill>
                   <a:schemeClr val="tx2"/>
                 </a:solidFill>
@@ -6173,365 +6471,27 @@
                 <a:ea typeface="Courier New" pitchFamily="34" charset="-122"/>
                 <a:cs typeface="Courier New" pitchFamily="34" charset="-120"/>
               </a:rPr>
-              <a:t>TrainingModule/src/app/core/store/&lt;feature&gt;/</a:t>
-            </a:r>
-            <a:endParaRPr lang="en-US" sz="1700" dirty="0"/>
-          </a:p>
-        </p:txBody>
-      </p:sp>
-      <p:sp>
-        <p:nvSpPr>
-          <p:cNvPr id="15" name="chk-4-badge"/>
+              <a:t>Corporate.Trainee</a:t>
+            </a:r>
+            <a:endParaRPr lang="en-US" sz="1500" dirty="0"/>
+          </a:p>
+        </p:txBody>
+      </p:sp>
+      <p:sp>
+        <p:nvSpPr>
+          <p:cNvPr id="21" name="rm-cell-2-pill"/>
           <p:cNvSpPr/>
           <p:nvPr/>
         </p:nvSpPr>
         <p:spPr>
           <a:xfrm>
-            <a:off x="6172200" y="1572768"/>
-            <a:ext cx="502920" cy="502920"/>
-          </a:xfrm>
-          <a:prstGeom prst="ellipse">
-            <a:avLst/>
-          </a:prstGeom>
-          <a:solidFill>
-            <a:schemeClr val="tx2"/>
-          </a:solidFill>
-          <a:ln w="12700">
-            <a:solidFill>
-              <a:schemeClr val="tx2"/>
-            </a:solidFill>
-            <a:prstDash val="solid"/>
-          </a:ln>
-        </p:spPr>
-      </p:sp>
-      <p:sp>
-        <p:nvSpPr>
-          <p:cNvPr id="16" name="chk-4-badge-text"/>
-          <p:cNvSpPr txBox="1"/>
-          <p:nvPr/>
-        </p:nvSpPr>
-        <p:spPr>
-          <a:xfrm>
-            <a:off x="6172200" y="1572768"/>
-            <a:ext cx="502920" cy="502920"/>
-          </a:xfrm>
-          <a:prstGeom prst="rect">
-            <a:avLst/>
-          </a:prstGeom>
-          <a:noFill/>
-          <a:ln/>
-        </p:spPr>
-        <p:txBody>
-          <a:bodyPr wrap="square" lIns="0" tIns="0" rIns="0" bIns="0" rtlCol="0" anchor="ctr"/>
-          <a:lstStyle/>
-          <a:p>
-            <a:pPr algn="ctr" indent="0" marL="0">
-              <a:buNone/>
-            </a:pPr>
-            <a:r>
-              <a:rPr lang="en-US" sz="1600" b="1" dirty="0">
-                <a:solidFill>
-                  <a:schemeClr val="bg1"/>
-                </a:solidFill>
-              </a:rPr>
-              <a:t>5</a:t>
-            </a:r>
-            <a:endParaRPr lang="en-US" sz="1600" dirty="0"/>
-          </a:p>
-        </p:txBody>
-      </p:sp>
-      <p:sp>
-        <p:nvSpPr>
-          <p:cNvPr id="17" name="chk-4-t"/>
-          <p:cNvSpPr txBox="1"/>
-          <p:nvPr/>
-        </p:nvSpPr>
-        <p:spPr>
-          <a:xfrm>
-            <a:off x="6903720" y="1417320"/>
-            <a:ext cx="4754880" cy="822960"/>
-          </a:xfrm>
-          <a:prstGeom prst="rect">
-            <a:avLst/>
-          </a:prstGeom>
-          <a:noFill/>
-          <a:ln/>
-        </p:spPr>
-        <p:txBody>
-          <a:bodyPr wrap="square" lIns="0" tIns="0" rIns="0" bIns="0" rtlCol="0" anchor="ctr"/>
-          <a:lstStyle/>
-          <a:p>
-            <a:pPr indent="0" marL="0">
-              <a:spcAft>
-                <a:spcPts val="200"/>
-              </a:spcAft>
-              <a:buNone/>
-            </a:pPr>
-            <a:r>
-              <a:rPr lang="en-US" sz="1700" dirty="0">
-                <a:solidFill>
-                  <a:schemeClr val="tx1"/>
-                </a:solidFill>
-              </a:rPr>
-              <a:t>Form pipeline, executor, validators</a:t>
-            </a:r>
-            <a:endParaRPr lang="en-US" sz="1700" dirty="0"/>
-          </a:p>
-          <a:p>
-            <a:pPr indent="0" marL="0">
-              <a:spcAft>
-                <a:spcPts val="200"/>
-              </a:spcAft>
-              <a:buNone/>
-            </a:pPr>
-            <a:r>
-              <a:rPr lang="en-US" sz="1050" dirty="0">
-                <a:solidFill>
-                  <a:schemeClr val="tx2"/>
-                </a:solidFill>
-                <a:latin typeface="Courier New" pitchFamily="34" charset="0"/>
-                <a:ea typeface="Courier New" pitchFamily="34" charset="-122"/>
-                <a:cs typeface="Courier New" pitchFamily="34" charset="-120"/>
-              </a:rPr>
-              <a:t>TrainingModule/src/app/core/ui/form-pipeline.service.ts</a:t>
-            </a:r>
-            <a:endParaRPr lang="en-US" sz="1700" dirty="0"/>
-          </a:p>
-        </p:txBody>
-      </p:sp>
-      <p:sp>
-        <p:nvSpPr>
-          <p:cNvPr id="18" name="chk-5-badge"/>
-          <p:cNvSpPr/>
-          <p:nvPr/>
-        </p:nvSpPr>
-        <p:spPr>
-          <a:xfrm>
-            <a:off x="6172200" y="2670048"/>
-            <a:ext cx="502920" cy="502920"/>
-          </a:xfrm>
-          <a:prstGeom prst="ellipse">
-            <a:avLst/>
-          </a:prstGeom>
-          <a:solidFill>
-            <a:schemeClr val="tx2"/>
-          </a:solidFill>
-          <a:ln w="12700">
-            <a:solidFill>
-              <a:schemeClr val="tx2"/>
-            </a:solidFill>
-            <a:prstDash val="solid"/>
-          </a:ln>
-        </p:spPr>
-      </p:sp>
-      <p:sp>
-        <p:nvSpPr>
-          <p:cNvPr id="19" name="chk-5-badge-text"/>
-          <p:cNvSpPr txBox="1"/>
-          <p:nvPr/>
-        </p:nvSpPr>
-        <p:spPr>
-          <a:xfrm>
-            <a:off x="6172200" y="2670048"/>
-            <a:ext cx="502920" cy="502920"/>
-          </a:xfrm>
-          <a:prstGeom prst="rect">
-            <a:avLst/>
-          </a:prstGeom>
-          <a:noFill/>
-          <a:ln/>
-        </p:spPr>
-        <p:txBody>
-          <a:bodyPr wrap="square" lIns="0" tIns="0" rIns="0" bIns="0" rtlCol="0" anchor="ctr"/>
-          <a:lstStyle/>
-          <a:p>
-            <a:pPr algn="ctr" indent="0" marL="0">
-              <a:buNone/>
-            </a:pPr>
-            <a:r>
-              <a:rPr lang="en-US" sz="1600" b="1" dirty="0">
-                <a:solidFill>
-                  <a:schemeClr val="bg1"/>
-                </a:solidFill>
-              </a:rPr>
-              <a:t>6</a:t>
-            </a:r>
-            <a:endParaRPr lang="en-US" sz="1600" dirty="0"/>
-          </a:p>
-        </p:txBody>
-      </p:sp>
-      <p:sp>
-        <p:nvSpPr>
-          <p:cNvPr id="20" name="chk-5-t"/>
-          <p:cNvSpPr txBox="1"/>
-          <p:nvPr/>
-        </p:nvSpPr>
-        <p:spPr>
-          <a:xfrm>
-            <a:off x="6903720" y="2514600"/>
-            <a:ext cx="4754880" cy="822960"/>
-          </a:xfrm>
-          <a:prstGeom prst="rect">
-            <a:avLst/>
-          </a:prstGeom>
-          <a:noFill/>
-          <a:ln/>
-        </p:spPr>
-        <p:txBody>
-          <a:bodyPr wrap="square" lIns="0" tIns="0" rIns="0" bIns="0" rtlCol="0" anchor="ctr"/>
-          <a:lstStyle/>
-          <a:p>
-            <a:pPr indent="0" marL="0">
-              <a:spcAft>
-                <a:spcPts val="200"/>
-              </a:spcAft>
-              <a:buNone/>
-            </a:pPr>
-            <a:r>
-              <a:rPr lang="en-US" sz="1700" dirty="0">
-                <a:solidFill>
-                  <a:schemeClr val="tx1"/>
-                </a:solidFill>
-              </a:rPr>
-              <a:t>English in templates, Arabic translations</a:t>
-            </a:r>
-            <a:endParaRPr lang="en-US" sz="1700" dirty="0"/>
-          </a:p>
-          <a:p>
-            <a:pPr indent="0" marL="0">
-              <a:spcAft>
-                <a:spcPts val="200"/>
-              </a:spcAft>
-              <a:buNone/>
-            </a:pPr>
-            <a:r>
-              <a:rPr lang="en-US" sz="1050" dirty="0">
-                <a:solidFill>
-                  <a:schemeClr val="tx2"/>
-                </a:solidFill>
-                <a:latin typeface="Courier New" pitchFamily="34" charset="0"/>
-                <a:ea typeface="Courier New" pitchFamily="34" charset="-122"/>
-                <a:cs typeface="Courier New" pitchFamily="34" charset="-120"/>
-              </a:rPr>
-              <a:t>TrainingModule/src/app/core/translations/&lt;area&gt;/</a:t>
-            </a:r>
-            <a:endParaRPr lang="en-US" sz="1700" dirty="0"/>
-          </a:p>
-        </p:txBody>
-      </p:sp>
-      <p:sp>
-        <p:nvSpPr>
-          <p:cNvPr id="21" name="chk-6-badge"/>
-          <p:cNvSpPr/>
-          <p:nvPr/>
-        </p:nvSpPr>
-        <p:spPr>
-          <a:xfrm>
-            <a:off x="6172200" y="3767328"/>
-            <a:ext cx="502920" cy="502920"/>
-          </a:xfrm>
-          <a:prstGeom prst="ellipse">
-            <a:avLst/>
-          </a:prstGeom>
-          <a:solidFill>
-            <a:schemeClr val="tx2"/>
-          </a:solidFill>
-          <a:ln w="12700">
-            <a:solidFill>
-              <a:schemeClr val="tx2"/>
-            </a:solidFill>
-            <a:prstDash val="solid"/>
-          </a:ln>
-        </p:spPr>
-      </p:sp>
-      <p:sp>
-        <p:nvSpPr>
-          <p:cNvPr id="22" name="chk-6-badge-text"/>
-          <p:cNvSpPr txBox="1"/>
-          <p:nvPr/>
-        </p:nvSpPr>
-        <p:spPr>
-          <a:xfrm>
-            <a:off x="6172200" y="3767328"/>
-            <a:ext cx="502920" cy="502920"/>
-          </a:xfrm>
-          <a:prstGeom prst="rect">
-            <a:avLst/>
-          </a:prstGeom>
-          <a:noFill/>
-          <a:ln/>
-        </p:spPr>
-        <p:txBody>
-          <a:bodyPr wrap="square" lIns="0" tIns="0" rIns="0" bIns="0" rtlCol="0" anchor="ctr"/>
-          <a:lstStyle/>
-          <a:p>
-            <a:pPr algn="ctr" indent="0" marL="0">
-              <a:buNone/>
-            </a:pPr>
-            <a:r>
-              <a:rPr lang="en-US" sz="1600" b="1" dirty="0">
-                <a:solidFill>
-                  <a:schemeClr val="bg1"/>
-                </a:solidFill>
-              </a:rPr>
-              <a:t>7</a:t>
-            </a:r>
-            <a:endParaRPr lang="en-US" sz="1600" dirty="0"/>
-          </a:p>
-        </p:txBody>
-      </p:sp>
-      <p:sp>
-        <p:nvSpPr>
-          <p:cNvPr id="23" name="chk-6-t"/>
-          <p:cNvSpPr txBox="1"/>
-          <p:nvPr/>
-        </p:nvSpPr>
-        <p:spPr>
-          <a:xfrm>
-            <a:off x="6903720" y="3611880"/>
-            <a:ext cx="4754880" cy="822960"/>
-          </a:xfrm>
-          <a:prstGeom prst="rect">
-            <a:avLst/>
-          </a:prstGeom>
-          <a:noFill/>
-          <a:ln/>
-        </p:spPr>
-        <p:txBody>
-          <a:bodyPr wrap="square" lIns="0" tIns="0" rIns="0" bIns="0" rtlCol="0" anchor="ctr"/>
-          <a:lstStyle/>
-          <a:p>
-            <a:pPr indent="0" marL="0">
-              <a:spcAft>
-                <a:spcPts val="200"/>
-              </a:spcAft>
-              <a:buNone/>
-            </a:pPr>
-            <a:r>
-              <a:rPr lang="en-US" sz="1700" dirty="0">
-                <a:solidFill>
-                  <a:schemeClr val="tx1"/>
-                </a:solidFill>
-              </a:rPr>
-              <a:t>Mobile layout and RTL checked</a:t>
-            </a:r>
-            <a:endParaRPr lang="en-US" sz="1700" dirty="0"/>
-          </a:p>
-        </p:txBody>
-      </p:sp>
-      <p:sp>
-        <p:nvSpPr>
-          <p:cNvPr id="24" name="chk-7-badge"/>
-          <p:cNvSpPr/>
-          <p:nvPr/>
-        </p:nvSpPr>
-        <p:spPr>
-          <a:xfrm>
-            <a:off x="6172200" y="4864608"/>
-            <a:ext cx="502920" cy="502920"/>
-          </a:xfrm>
-          <a:prstGeom prst="ellipse">
-            <a:avLst/>
+            <a:off x="4937760" y="4133088"/>
+            <a:ext cx="1645920" cy="329184"/>
+          </a:xfrm>
+          <a:prstGeom prst="roundRect">
+            <a:avLst>
+              <a:gd name="adj" fmla="val 50000"/>
+            </a:avLst>
           </a:prstGeom>
           <a:solidFill>
             <a:schemeClr val="accent2"/>
@@ -6546,14 +6506,14 @@
       </p:sp>
       <p:sp>
         <p:nvSpPr>
-          <p:cNvPr id="25" name="chk-7-badge-text"/>
-          <p:cNvSpPr txBox="1"/>
-          <p:nvPr/>
-        </p:nvSpPr>
-        <p:spPr>
-          <a:xfrm>
-            <a:off x="6172200" y="4864608"/>
-            <a:ext cx="502920" cy="502920"/>
+          <p:cNvPr id="22" name="rm-cell-2-status"/>
+          <p:cNvSpPr txBox="1"/>
+          <p:nvPr/>
+        </p:nvSpPr>
+        <p:spPr>
+          <a:xfrm>
+            <a:off x="4937760" y="4133088"/>
+            <a:ext cx="1645920" cy="329184"/>
           </a:xfrm>
           <a:prstGeom prst="rect">
             <a:avLst/>
@@ -6569,27 +6529,90 @@
               <a:buNone/>
             </a:pPr>
             <a:r>
-              <a:rPr lang="en-US" sz="1600" b="1" dirty="0">
+              <a:rPr lang="en-US" sz="1100" b="1" dirty="0">
                 <a:solidFill>
                   <a:schemeClr val="bg1"/>
                 </a:solidFill>
               </a:rPr>
-              <a:t>8</a:t>
-            </a:r>
-            <a:endParaRPr lang="en-US" sz="1600" dirty="0"/>
-          </a:p>
-        </p:txBody>
-      </p:sp>
-      <p:sp>
-        <p:nvSpPr>
-          <p:cNvPr id="26" name="chk-7-t"/>
-          <p:cNvSpPr txBox="1"/>
-          <p:nvPr/>
-        </p:nvSpPr>
-        <p:spPr>
-          <a:xfrm>
-            <a:off x="6903720" y="4709160"/>
-            <a:ext cx="4754880" cy="822960"/>
+              <a:t>Missing · to decide</a:t>
+            </a:r>
+            <a:endParaRPr lang="en-US" sz="1100" dirty="0"/>
+          </a:p>
+        </p:txBody>
+      </p:sp>
+      <p:sp>
+        <p:nvSpPr>
+          <p:cNvPr id="23" name="rm-cell-2-body"/>
+          <p:cNvSpPr txBox="1"/>
+          <p:nvPr/>
+        </p:nvSpPr>
+        <p:spPr>
+          <a:xfrm>
+            <a:off x="2377440" y="4617720"/>
+            <a:ext cx="4206240" cy="1051560"/>
+          </a:xfrm>
+          <a:prstGeom prst="rect">
+            <a:avLst/>
+          </a:prstGeom>
+          <a:noFill/>
+          <a:ln/>
+        </p:spPr>
+        <p:txBody>
+          <a:bodyPr wrap="square" lIns="0" tIns="0" rIns="0" bIns="0" rtlCol="0" anchor="t"/>
+          <a:lstStyle/>
+          <a:p>
+            <a:pPr indent="0" marL="0">
+              <a:buNone/>
+            </a:pPr>
+            <a:r>
+              <a:rPr lang="en-US" sz="1400" dirty="0">
+                <a:solidFill>
+                  <a:schemeClr val="tx1"/>
+                </a:solidFill>
+              </a:rPr>
+              <a:t>A company that enrolls its employees. Either add a Corporate Trainee group and template role, or let SME / NonSME companies enroll their staff.</a:t>
+            </a:r>
+            <a:endParaRPr lang="en-US" sz="1400" dirty="0"/>
+          </a:p>
+        </p:txBody>
+      </p:sp>
+      <p:sp>
+        <p:nvSpPr>
+          <p:cNvPr id="24" name="rm-cell-3"/>
+          <p:cNvSpPr/>
+          <p:nvPr/>
+        </p:nvSpPr>
+        <p:spPr>
+          <a:xfrm>
+            <a:off x="6949440" y="3931920"/>
+            <a:ext cx="4663440" cy="1874520"/>
+          </a:xfrm>
+          <a:prstGeom prst="roundRect">
+            <a:avLst>
+              <a:gd name="adj" fmla="val 5854"/>
+            </a:avLst>
+          </a:prstGeom>
+          <a:solidFill>
+            <a:schemeClr val="bg2"/>
+          </a:solidFill>
+          <a:ln w="6350">
+            <a:solidFill>
+              <a:schemeClr val="bg2"/>
+            </a:solidFill>
+            <a:prstDash val="solid"/>
+          </a:ln>
+        </p:spPr>
+      </p:sp>
+      <p:sp>
+        <p:nvSpPr>
+          <p:cNvPr id="25" name="rm-cell-3-name"/>
+          <p:cNvSpPr txBox="1"/>
+          <p:nvPr/>
+        </p:nvSpPr>
+        <p:spPr>
+          <a:xfrm>
+            <a:off x="7178040" y="4114800"/>
+            <a:ext cx="2651760" cy="365760"/>
           </a:xfrm>
           <a:prstGeom prst="rect">
             <a:avLst/>
@@ -6602,30 +6625,10 @@
           <a:lstStyle/>
           <a:p>
             <a:pPr indent="0" marL="0">
-              <a:spcAft>
-                <a:spcPts val="200"/>
-              </a:spcAft>
-              <a:buNone/>
-            </a:pPr>
-            <a:r>
-              <a:rPr lang="en-US" sz="1700" dirty="0">
-                <a:solidFill>
-                  <a:schemeClr val="tx1"/>
-                </a:solidFill>
-              </a:rPr>
-              <a:t>2–3 tests for the new rule</a:t>
-            </a:r>
-            <a:endParaRPr lang="en-US" sz="1700" dirty="0"/>
-          </a:p>
-          <a:p>
-            <a:pPr indent="0" marL="0">
-              <a:spcAft>
-                <a:spcPts val="200"/>
-              </a:spcAft>
-              <a:buNone/>
-            </a:pPr>
-            <a:r>
-              <a:rPr lang="en-US" sz="1050" dirty="0">
+              <a:buNone/>
+            </a:pPr>
+            <a:r>
+              <a:rPr lang="en-US" sz="1500" b="1" dirty="0">
                 <a:solidFill>
                   <a:schemeClr val="tx2"/>
                 </a:solidFill>
@@ -6633,9 +6636,169 @@
                 <a:ea typeface="Courier New" pitchFamily="34" charset="-122"/>
                 <a:cs typeface="Courier New" pitchFamily="34" charset="-120"/>
               </a:rPr>
-              <a:t>Bidding_Core.Tests/ · &lt;component&gt;.spec.ts</a:t>
-            </a:r>
-            <a:endParaRPr lang="en-US" sz="1700" dirty="0"/>
+              <a:t>Individual.Trainee</a:t>
+            </a:r>
+            <a:endParaRPr lang="en-US" sz="1500" dirty="0"/>
+          </a:p>
+        </p:txBody>
+      </p:sp>
+      <p:sp>
+        <p:nvSpPr>
+          <p:cNvPr id="26" name="rm-cell-3-pill"/>
+          <p:cNvSpPr/>
+          <p:nvPr/>
+        </p:nvSpPr>
+        <p:spPr>
+          <a:xfrm>
+            <a:off x="9738360" y="4133088"/>
+            <a:ext cx="1645920" cy="329184"/>
+          </a:xfrm>
+          <a:prstGeom prst="roundRect">
+            <a:avLst>
+              <a:gd name="adj" fmla="val 50000"/>
+            </a:avLst>
+          </a:prstGeom>
+          <a:solidFill>
+            <a:schemeClr val="accent3"/>
+          </a:solidFill>
+          <a:ln w="12700">
+            <a:solidFill>
+              <a:schemeClr val="accent3"/>
+            </a:solidFill>
+            <a:prstDash val="solid"/>
+          </a:ln>
+        </p:spPr>
+      </p:sp>
+      <p:sp>
+        <p:nvSpPr>
+          <p:cNvPr id="27" name="rm-cell-3-status"/>
+          <p:cNvSpPr txBox="1"/>
+          <p:nvPr/>
+        </p:nvSpPr>
+        <p:spPr>
+          <a:xfrm>
+            <a:off x="9738360" y="4133088"/>
+            <a:ext cx="1645920" cy="329184"/>
+          </a:xfrm>
+          <a:prstGeom prst="rect">
+            <a:avLst/>
+          </a:prstGeom>
+          <a:noFill/>
+          <a:ln/>
+        </p:spPr>
+        <p:txBody>
+          <a:bodyPr wrap="square" lIns="0" tIns="0" rIns="0" bIns="0" rtlCol="0" anchor="ctr"/>
+          <a:lstStyle/>
+          <a:p>
+            <a:pPr algn="ctr" indent="0" marL="0">
+              <a:buNone/>
+            </a:pPr>
+            <a:r>
+              <a:rPr lang="en-US" sz="1100" b="1" dirty="0">
+                <a:solidFill>
+                  <a:schemeClr val="bg1"/>
+                </a:solidFill>
+              </a:rPr>
+              <a:t>Exists · row 11</a:t>
+            </a:r>
+            <a:endParaRPr lang="en-US" sz="1100" dirty="0"/>
+          </a:p>
+        </p:txBody>
+      </p:sp>
+      <p:sp>
+        <p:nvSpPr>
+          <p:cNvPr id="28" name="rm-cell-3-body"/>
+          <p:cNvSpPr txBox="1"/>
+          <p:nvPr/>
+        </p:nvSpPr>
+        <p:spPr>
+          <a:xfrm>
+            <a:off x="7178040" y="4617720"/>
+            <a:ext cx="4206240" cy="1051560"/>
+          </a:xfrm>
+          <a:prstGeom prst="rect">
+            <a:avLst/>
+          </a:prstGeom>
+          <a:noFill/>
+          <a:ln/>
+        </p:spPr>
+        <p:txBody>
+          <a:bodyPr wrap="square" lIns="0" tIns="0" rIns="0" bIns="0" rtlCol="0" anchor="t"/>
+          <a:lstStyle/>
+          <a:p>
+            <a:pPr indent="0" marL="0">
+              <a:buNone/>
+            </a:pPr>
+            <a:r>
+              <a:rPr lang="en-US" sz="1400" dirty="0">
+                <a:solidFill>
+                  <a:schemeClr val="tx1"/>
+                </a:solidFill>
+              </a:rPr>
+              <a:t>Person who registers for and attends trainings. Claim: training.read.</a:t>
+            </a:r>
+            <a:endParaRPr lang="en-US" sz="1400" dirty="0"/>
+          </a:p>
+        </p:txBody>
+      </p:sp>
+      <p:sp>
+        <p:nvSpPr>
+          <p:cNvPr id="29" name="rm-where"/>
+          <p:cNvSpPr txBox="1"/>
+          <p:nvPr/>
+        </p:nvSpPr>
+        <p:spPr>
+          <a:xfrm>
+            <a:off x="548640" y="5897880"/>
+            <a:ext cx="11064240" cy="365760"/>
+          </a:xfrm>
+          <a:prstGeom prst="rect">
+            <a:avLst/>
+          </a:prstGeom>
+          <a:noFill/>
+          <a:ln/>
+        </p:spPr>
+        <p:txBody>
+          <a:bodyPr wrap="square" lIns="0" tIns="0" rIns="0" bIns="0" rtlCol="0" anchor="ctr"/>
+          <a:lstStyle/>
+          <a:p>
+            <a:pPr indent="0" marL="0">
+              <a:buNone/>
+            </a:pPr>
+            <a:r>
+              <a:rPr lang="en-US" sz="1400" b="1" dirty="0">
+                <a:solidFill>
+                  <a:schemeClr val="tx1"/>
+                </a:solidFill>
+              </a:rPr>
+              <a:t>Where to see them: </a:t>
+            </a:r>
+            <a:pPr indent="0" marL="0">
+              <a:buNone/>
+            </a:pPr>
+            <a:r>
+              <a:rPr lang="en-US" sz="1400" dirty="0">
+                <a:solidFill>
+                  <a:schemeClr val="tx1"/>
+                </a:solidFill>
+              </a:rPr>
+              <a:t>/admin/template-roles (sorted by name). Defined in </a:t>
+            </a:r>
+            <a:pPr indent="0" marL="0">
+              <a:buNone/>
+            </a:pPr>
+            <a:r>
+              <a:rPr lang="en-US" sz="1150" dirty="0">
+                <a:solidFill>
+                  <a:schemeClr val="tx2"/>
+                </a:solidFill>
+                <a:latin typeface="Courier New" pitchFamily="34" charset="0"/>
+                <a:ea typeface="Courier New" pitchFamily="34" charset="-122"/>
+                <a:cs typeface="Courier New" pitchFamily="34" charset="-120"/>
+              </a:rPr>
+              <a:t>Bidding_DLL/Seeding/IdentityAccessSeedData.cs</a:t>
+            </a:r>
+            <a:endParaRPr lang="en-US" sz="1400" dirty="0"/>
           </a:p>
         </p:txBody>
       </p:sp>
@@ -6695,6 +6858,1984 @@
 <file path=ppt/slides/slide14.xml><?xml version="1.0" encoding="utf-8"?>
 <p:sld xmlns:a="http://schemas.openxmlformats.org/drawingml/2006/main" xmlns:r="http://schemas.openxmlformats.org/officeDocument/2006/relationships" xmlns:p="http://schemas.openxmlformats.org/presentationml/2006/main">
   <p:cSld name="Slide 14">
+    <p:spTree>
+      <p:nvGrpSpPr>
+        <p:cNvPr id="1" name=""/>
+        <p:cNvGrpSpPr/>
+        <p:nvPr/>
+      </p:nvGrpSpPr>
+      <p:grpSpPr>
+        <a:xfrm>
+          <a:off x="0" y="0"/>
+          <a:ext cx="0" cy="0"/>
+          <a:chOff x="0" y="0"/>
+          <a:chExt cx="0" cy="0"/>
+        </a:xfrm>
+      </p:grpSpPr>
+      <p:sp>
+        <p:nvSpPr>
+          <p:cNvPr id="2" name="Text 0"/>
+          <p:cNvSpPr/>
+          <p:nvPr>
+            <p:ph idx="100" type="title" hasCustomPrompt="1"/>
+          </p:nvPr>
+        </p:nvSpPr>
+        <p:spPr>
+          <a:xfrm>
+            <a:off x="548640" y="365760"/>
+            <a:ext cx="11064240" cy="822960"/>
+          </a:xfrm>
+          <a:prstGeom prst="rect">
+            <a:avLst/>
+          </a:prstGeom>
+          <a:noFill/>
+          <a:ln/>
+        </p:spPr>
+        <p:txBody>
+          <a:bodyPr wrap="square" lIns="0" tIns="0" rIns="0" bIns="0" rtlCol="0" anchor="ctr"/>
+          <a:lstStyle/>
+          <a:p>
+            <a:pPr algn="l" indent="0" marL="0">
+              <a:buNone/>
+            </a:pPr>
+            <a:r>
+              <a:rPr lang="en-US" sz="3600" b="1" dirty="0">
+                <a:solidFill>
+                  <a:schemeClr val="tx2"/>
+                </a:solidFill>
+              </a:rPr>
+              <a:t>Making the roles work in the new module</a:t>
+            </a:r>
+            <a:endParaRPr lang="en-US" sz="3600" dirty="0"/>
+          </a:p>
+        </p:txBody>
+      </p:sp>
+      <p:sp>
+        <p:nvSpPr>
+          <p:cNvPr id="3" name="rw-0-badge"/>
+          <p:cNvSpPr/>
+          <p:nvPr/>
+        </p:nvSpPr>
+        <p:spPr>
+          <a:xfrm>
+            <a:off x="548640" y="1417320"/>
+            <a:ext cx="502920" cy="502920"/>
+          </a:xfrm>
+          <a:prstGeom prst="ellipse">
+            <a:avLst/>
+          </a:prstGeom>
+          <a:solidFill>
+            <a:schemeClr val="tx2"/>
+          </a:solidFill>
+          <a:ln w="12700">
+            <a:solidFill>
+              <a:schemeClr val="tx2"/>
+            </a:solidFill>
+            <a:prstDash val="solid"/>
+          </a:ln>
+        </p:spPr>
+      </p:sp>
+      <p:sp>
+        <p:nvSpPr>
+          <p:cNvPr id="4" name="rw-0-badge-text"/>
+          <p:cNvSpPr txBox="1"/>
+          <p:nvPr/>
+        </p:nvSpPr>
+        <p:spPr>
+          <a:xfrm>
+            <a:off x="548640" y="1417320"/>
+            <a:ext cx="502920" cy="502920"/>
+          </a:xfrm>
+          <a:prstGeom prst="rect">
+            <a:avLst/>
+          </a:prstGeom>
+          <a:noFill/>
+          <a:ln/>
+        </p:spPr>
+        <p:txBody>
+          <a:bodyPr wrap="square" lIns="0" tIns="0" rIns="0" bIns="0" rtlCol="0" anchor="ctr"/>
+          <a:lstStyle/>
+          <a:p>
+            <a:pPr algn="ctr" indent="0" marL="0">
+              <a:buNone/>
+            </a:pPr>
+            <a:r>
+              <a:rPr lang="en-US" sz="1600" b="1" dirty="0">
+                <a:solidFill>
+                  <a:schemeClr val="bg1"/>
+                </a:solidFill>
+              </a:rPr>
+              <a:t>1</a:t>
+            </a:r>
+            <a:endParaRPr lang="en-US" sz="1600" dirty="0"/>
+          </a:p>
+        </p:txBody>
+      </p:sp>
+      <p:sp>
+        <p:nvSpPr>
+          <p:cNvPr id="5" name="rw-0-t"/>
+          <p:cNvSpPr txBox="1"/>
+          <p:nvPr/>
+        </p:nvSpPr>
+        <p:spPr>
+          <a:xfrm>
+            <a:off x="1234440" y="1371600"/>
+            <a:ext cx="4754880" cy="1417320"/>
+          </a:xfrm>
+          <a:prstGeom prst="rect">
+            <a:avLst/>
+          </a:prstGeom>
+          <a:noFill/>
+          <a:ln/>
+        </p:spPr>
+        <p:txBody>
+          <a:bodyPr wrap="square" lIns="0" tIns="0" rIns="0" bIns="0" rtlCol="0" anchor="t"/>
+          <a:lstStyle/>
+          <a:p>
+            <a:pPr indent="0" marL="0">
+              <a:spcAft>
+                <a:spcPts val="300"/>
+              </a:spcAft>
+              <a:buNone/>
+            </a:pPr>
+            <a:r>
+              <a:rPr lang="en-US" sz="1700" b="1" dirty="0">
+                <a:solidFill>
+                  <a:schemeClr val="tx1"/>
+                </a:solidFill>
+              </a:rPr>
+              <a:t>Seed the new pages</a:t>
+            </a:r>
+            <a:endParaRPr lang="en-US" sz="1700" dirty="0"/>
+          </a:p>
+          <a:p>
+            <a:pPr indent="0" marL="0">
+              <a:spcAft>
+                <a:spcPts val="300"/>
+              </a:spcAft>
+              <a:buNone/>
+            </a:pPr>
+            <a:r>
+              <a:rPr lang="en-US" sz="1350" dirty="0">
+                <a:solidFill>
+                  <a:schemeClr val="tx1"/>
+                </a:solidFill>
+              </a:rPr>
+              <a:t>Give trainer and trainee pages their own code prefix and URL.</a:t>
+            </a:r>
+            <a:endParaRPr lang="en-US" sz="1700" dirty="0"/>
+          </a:p>
+          <a:p>
+            <a:pPr indent="0" marL="0">
+              <a:spcAft>
+                <a:spcPts val="300"/>
+              </a:spcAft>
+              <a:buNone/>
+            </a:pPr>
+            <a:r>
+              <a:rPr lang="en-US" sz="1000" dirty="0">
+                <a:solidFill>
+                  <a:schemeClr val="tx2"/>
+                </a:solidFill>
+                <a:latin typeface="Courier New" pitchFamily="34" charset="0"/>
+                <a:ea typeface="Courier New" pitchFamily="34" charset="-122"/>
+                <a:cs typeface="Courier New" pitchFamily="34" charset="-120"/>
+              </a:rPr>
+              <a:t>Bidding_DLL/Seeding/IdentityAccessAppPagesSeedData.cs</a:t>
+            </a:r>
+            <a:endParaRPr lang="en-US" sz="1700" dirty="0"/>
+          </a:p>
+        </p:txBody>
+      </p:sp>
+      <p:sp>
+        <p:nvSpPr>
+          <p:cNvPr id="6" name="rw-1-badge"/>
+          <p:cNvSpPr/>
+          <p:nvPr/>
+        </p:nvSpPr>
+        <p:spPr>
+          <a:xfrm>
+            <a:off x="6172200" y="1417320"/>
+            <a:ext cx="502920" cy="502920"/>
+          </a:xfrm>
+          <a:prstGeom prst="ellipse">
+            <a:avLst/>
+          </a:prstGeom>
+          <a:solidFill>
+            <a:schemeClr val="tx2"/>
+          </a:solidFill>
+          <a:ln w="12700">
+            <a:solidFill>
+              <a:schemeClr val="tx2"/>
+            </a:solidFill>
+            <a:prstDash val="solid"/>
+          </a:ln>
+        </p:spPr>
+      </p:sp>
+      <p:sp>
+        <p:nvSpPr>
+          <p:cNvPr id="7" name="rw-1-badge-text"/>
+          <p:cNvSpPr txBox="1"/>
+          <p:nvPr/>
+        </p:nvSpPr>
+        <p:spPr>
+          <a:xfrm>
+            <a:off x="6172200" y="1417320"/>
+            <a:ext cx="502920" cy="502920"/>
+          </a:xfrm>
+          <a:prstGeom prst="rect">
+            <a:avLst/>
+          </a:prstGeom>
+          <a:noFill/>
+          <a:ln/>
+        </p:spPr>
+        <p:txBody>
+          <a:bodyPr wrap="square" lIns="0" tIns="0" rIns="0" bIns="0" rtlCol="0" anchor="ctr"/>
+          <a:lstStyle/>
+          <a:p>
+            <a:pPr algn="ctr" indent="0" marL="0">
+              <a:buNone/>
+            </a:pPr>
+            <a:r>
+              <a:rPr lang="en-US" sz="1600" b="1" dirty="0">
+                <a:solidFill>
+                  <a:schemeClr val="bg1"/>
+                </a:solidFill>
+              </a:rPr>
+              <a:t>2</a:t>
+            </a:r>
+            <a:endParaRPr lang="en-US" sz="1600" dirty="0"/>
+          </a:p>
+        </p:txBody>
+      </p:sp>
+      <p:sp>
+        <p:nvSpPr>
+          <p:cNvPr id="8" name="rw-1-t"/>
+          <p:cNvSpPr txBox="1"/>
+          <p:nvPr/>
+        </p:nvSpPr>
+        <p:spPr>
+          <a:xfrm>
+            <a:off x="6858000" y="1371600"/>
+            <a:ext cx="4754880" cy="1417320"/>
+          </a:xfrm>
+          <a:prstGeom prst="rect">
+            <a:avLst/>
+          </a:prstGeom>
+          <a:noFill/>
+          <a:ln/>
+        </p:spPr>
+        <p:txBody>
+          <a:bodyPr wrap="square" lIns="0" tIns="0" rIns="0" bIns="0" rtlCol="0" anchor="t"/>
+          <a:lstStyle/>
+          <a:p>
+            <a:pPr indent="0" marL="0">
+              <a:spcAft>
+                <a:spcPts val="300"/>
+              </a:spcAft>
+              <a:buNone/>
+            </a:pPr>
+            <a:r>
+              <a:rPr lang="en-US" sz="1700" b="1" dirty="0">
+                <a:solidFill>
+                  <a:schemeClr val="tx1"/>
+                </a:solidFill>
+              </a:rPr>
+              <a:t>Point the roles at them</a:t>
+            </a:r>
+            <a:endParaRPr lang="en-US" sz="1700" dirty="0"/>
+          </a:p>
+          <a:p>
+            <a:pPr indent="0" marL="0">
+              <a:spcAft>
+                <a:spcPts val="300"/>
+              </a:spcAft>
+              <a:buNone/>
+            </a:pPr>
+            <a:r>
+              <a:rPr lang="en-US" sz="1350" dirty="0">
+                <a:solidFill>
+                  <a:schemeClr val="tx1"/>
+                </a:solidFill>
+              </a:rPr>
+              <a:t>trainerPages / traineePages still list the old Bidding_Web nw.training pages. Switch them to the new prefixes.</a:t>
+            </a:r>
+            <a:endParaRPr lang="en-US" sz="1700" dirty="0"/>
+          </a:p>
+          <a:p>
+            <a:pPr indent="0" marL="0">
+              <a:spcAft>
+                <a:spcPts val="300"/>
+              </a:spcAft>
+              <a:buNone/>
+            </a:pPr>
+            <a:r>
+              <a:rPr lang="en-US" sz="1000" dirty="0">
+                <a:solidFill>
+                  <a:schemeClr val="tx2"/>
+                </a:solidFill>
+                <a:latin typeface="Courier New" pitchFamily="34" charset="0"/>
+                <a:ea typeface="Courier New" pitchFamily="34" charset="-122"/>
+                <a:cs typeface="Courier New" pitchFamily="34" charset="-120"/>
+              </a:rPr>
+              <a:t>Bidding_DLL/Seeding/IdentityAccessSeedData.cs  (BuildRolePages)</a:t>
+            </a:r>
+            <a:endParaRPr lang="en-US" sz="1700" dirty="0"/>
+          </a:p>
+        </p:txBody>
+      </p:sp>
+      <p:sp>
+        <p:nvSpPr>
+          <p:cNvPr id="9" name="rw-2-badge"/>
+          <p:cNvSpPr/>
+          <p:nvPr/>
+        </p:nvSpPr>
+        <p:spPr>
+          <a:xfrm>
+            <a:off x="548640" y="2971800"/>
+            <a:ext cx="502920" cy="502920"/>
+          </a:xfrm>
+          <a:prstGeom prst="ellipse">
+            <a:avLst/>
+          </a:prstGeom>
+          <a:solidFill>
+            <a:schemeClr val="tx2"/>
+          </a:solidFill>
+          <a:ln w="12700">
+            <a:solidFill>
+              <a:schemeClr val="tx2"/>
+            </a:solidFill>
+            <a:prstDash val="solid"/>
+          </a:ln>
+        </p:spPr>
+      </p:sp>
+      <p:sp>
+        <p:nvSpPr>
+          <p:cNvPr id="10" name="rw-2-badge-text"/>
+          <p:cNvSpPr txBox="1"/>
+          <p:nvPr/>
+        </p:nvSpPr>
+        <p:spPr>
+          <a:xfrm>
+            <a:off x="548640" y="2971800"/>
+            <a:ext cx="502920" cy="502920"/>
+          </a:xfrm>
+          <a:prstGeom prst="rect">
+            <a:avLst/>
+          </a:prstGeom>
+          <a:noFill/>
+          <a:ln/>
+        </p:spPr>
+        <p:txBody>
+          <a:bodyPr wrap="square" lIns="0" tIns="0" rIns="0" bIns="0" rtlCol="0" anchor="ctr"/>
+          <a:lstStyle/>
+          <a:p>
+            <a:pPr algn="ctr" indent="0" marL="0">
+              <a:buNone/>
+            </a:pPr>
+            <a:r>
+              <a:rPr lang="en-US" sz="1600" b="1" dirty="0">
+                <a:solidFill>
+                  <a:schemeClr val="bg1"/>
+                </a:solidFill>
+              </a:rPr>
+              <a:t>3</a:t>
+            </a:r>
+            <a:endParaRPr lang="en-US" sz="1600" dirty="0"/>
+          </a:p>
+        </p:txBody>
+      </p:sp>
+      <p:sp>
+        <p:nvSpPr>
+          <p:cNvPr id="11" name="rw-2-t"/>
+          <p:cNvSpPr txBox="1"/>
+          <p:nvPr/>
+        </p:nvSpPr>
+        <p:spPr>
+          <a:xfrm>
+            <a:off x="1234440" y="2926080"/>
+            <a:ext cx="4754880" cy="1417320"/>
+          </a:xfrm>
+          <a:prstGeom prst="rect">
+            <a:avLst/>
+          </a:prstGeom>
+          <a:noFill/>
+          <a:ln/>
+        </p:spPr>
+        <p:txBody>
+          <a:bodyPr wrap="square" lIns="0" tIns="0" rIns="0" bIns="0" rtlCol="0" anchor="t"/>
+          <a:lstStyle/>
+          <a:p>
+            <a:pPr indent="0" marL="0">
+              <a:spcAft>
+                <a:spcPts val="300"/>
+              </a:spcAft>
+              <a:buNone/>
+            </a:pPr>
+            <a:r>
+              <a:rPr lang="en-US" sz="1700" b="1" dirty="0">
+                <a:solidFill>
+                  <a:schemeClr val="tx1"/>
+                </a:solidFill>
+              </a:rPr>
+              <a:t>Enforce claims in the API</a:t>
+            </a:r>
+            <a:endParaRPr lang="en-US" sz="1700" dirty="0"/>
+          </a:p>
+          <a:p>
+            <a:pPr indent="0" marL="0">
+              <a:spcAft>
+                <a:spcPts val="300"/>
+              </a:spcAft>
+              <a:buNone/>
+            </a:pPr>
+            <a:r>
+              <a:rPr lang="en-US" sz="1350" dirty="0">
+                <a:solidFill>
+                  <a:schemeClr val="tx1"/>
+                </a:solidFill>
+              </a:rPr>
+              <a:t>Check training.read / training.write in the service, not only in the sidebar.</a:t>
+            </a:r>
+            <a:endParaRPr lang="en-US" sz="1700" dirty="0"/>
+          </a:p>
+          <a:p>
+            <a:pPr indent="0" marL="0">
+              <a:spcAft>
+                <a:spcPts val="300"/>
+              </a:spcAft>
+              <a:buNone/>
+            </a:pPr>
+            <a:r>
+              <a:rPr lang="en-US" sz="1000" dirty="0">
+                <a:solidFill>
+                  <a:schemeClr val="tx2"/>
+                </a:solidFill>
+                <a:latin typeface="Courier New" pitchFamily="34" charset="0"/>
+                <a:ea typeface="Courier New" pitchFamily="34" charset="-122"/>
+                <a:cs typeface="Courier New" pitchFamily="34" charset="-120"/>
+              </a:rPr>
+              <a:t>Bidding_Core/Services/</a:t>
+            </a:r>
+            <a:endParaRPr lang="en-US" sz="1700" dirty="0"/>
+          </a:p>
+        </p:txBody>
+      </p:sp>
+      <p:sp>
+        <p:nvSpPr>
+          <p:cNvPr id="12" name="rw-3-badge"/>
+          <p:cNvSpPr/>
+          <p:nvPr/>
+        </p:nvSpPr>
+        <p:spPr>
+          <a:xfrm>
+            <a:off x="6172200" y="2971800"/>
+            <a:ext cx="502920" cy="502920"/>
+          </a:xfrm>
+          <a:prstGeom prst="ellipse">
+            <a:avLst/>
+          </a:prstGeom>
+          <a:solidFill>
+            <a:schemeClr val="tx2"/>
+          </a:solidFill>
+          <a:ln w="12700">
+            <a:solidFill>
+              <a:schemeClr val="tx2"/>
+            </a:solidFill>
+            <a:prstDash val="solid"/>
+          </a:ln>
+        </p:spPr>
+      </p:sp>
+      <p:sp>
+        <p:nvSpPr>
+          <p:cNvPr id="13" name="rw-3-badge-text"/>
+          <p:cNvSpPr txBox="1"/>
+          <p:nvPr/>
+        </p:nvSpPr>
+        <p:spPr>
+          <a:xfrm>
+            <a:off x="6172200" y="2971800"/>
+            <a:ext cx="502920" cy="502920"/>
+          </a:xfrm>
+          <a:prstGeom prst="rect">
+            <a:avLst/>
+          </a:prstGeom>
+          <a:noFill/>
+          <a:ln/>
+        </p:spPr>
+        <p:txBody>
+          <a:bodyPr wrap="square" lIns="0" tIns="0" rIns="0" bIns="0" rtlCol="0" anchor="ctr"/>
+          <a:lstStyle/>
+          <a:p>
+            <a:pPr algn="ctr" indent="0" marL="0">
+              <a:buNone/>
+            </a:pPr>
+            <a:r>
+              <a:rPr lang="en-US" sz="1600" b="1" dirty="0">
+                <a:solidFill>
+                  <a:schemeClr val="bg1"/>
+                </a:solidFill>
+              </a:rPr>
+              <a:t>4</a:t>
+            </a:r>
+            <a:endParaRPr lang="en-US" sz="1600" dirty="0"/>
+          </a:p>
+        </p:txBody>
+      </p:sp>
+      <p:sp>
+        <p:nvSpPr>
+          <p:cNvPr id="14" name="rw-3-t"/>
+          <p:cNvSpPr txBox="1"/>
+          <p:nvPr/>
+        </p:nvSpPr>
+        <p:spPr>
+          <a:xfrm>
+            <a:off x="6858000" y="2926080"/>
+            <a:ext cx="4754880" cy="1417320"/>
+          </a:xfrm>
+          <a:prstGeom prst="rect">
+            <a:avLst/>
+          </a:prstGeom>
+          <a:noFill/>
+          <a:ln/>
+        </p:spPr>
+        <p:txBody>
+          <a:bodyPr wrap="square" lIns="0" tIns="0" rIns="0" bIns="0" rtlCol="0" anchor="t"/>
+          <a:lstStyle/>
+          <a:p>
+            <a:pPr indent="0" marL="0">
+              <a:spcAft>
+                <a:spcPts val="300"/>
+              </a:spcAft>
+              <a:buNone/>
+            </a:pPr>
+            <a:r>
+              <a:rPr lang="en-US" sz="1700" b="1" dirty="0">
+                <a:solidFill>
+                  <a:schemeClr val="tx1"/>
+                </a:solidFill>
+              </a:rPr>
+              <a:t>Set the data scope</a:t>
+            </a:r>
+            <a:endParaRPr lang="en-US" sz="1700" dirty="0"/>
+          </a:p>
+          <a:p>
+            <a:pPr indent="0" marL="0">
+              <a:spcAft>
+                <a:spcPts val="300"/>
+              </a:spcAft>
+              <a:buNone/>
+            </a:pPr>
+            <a:r>
+              <a:rPr lang="en-US" sz="1350" dirty="0">
+                <a:solidFill>
+                  <a:schemeClr val="tx1"/>
+                </a:solidFill>
+              </a:rPr>
+              <a:t>organization for company trainers (whole company), mine for individuals. Editable per page in Groups → Pages.</a:t>
+            </a:r>
+            <a:endParaRPr lang="en-US" sz="1700" dirty="0"/>
+          </a:p>
+          <a:p>
+            <a:pPr indent="0" marL="0">
+              <a:spcAft>
+                <a:spcPts val="300"/>
+              </a:spcAft>
+              <a:buNone/>
+            </a:pPr>
+            <a:r>
+              <a:rPr lang="en-US" sz="1000" dirty="0">
+                <a:solidFill>
+                  <a:schemeClr val="tx2"/>
+                </a:solidFill>
+                <a:latin typeface="Courier New" pitchFamily="34" charset="0"/>
+                <a:ea typeface="Courier New" pitchFamily="34" charset="-122"/>
+                <a:cs typeface="Courier New" pitchFamily="34" charset="-120"/>
+              </a:rPr>
+              <a:t>Bidding_Models/DatabaseModel/IdentityAccess/RolePage.cs</a:t>
+            </a:r>
+            <a:endParaRPr lang="en-US" sz="1700" dirty="0"/>
+          </a:p>
+        </p:txBody>
+      </p:sp>
+      <p:sp>
+        <p:nvSpPr>
+          <p:cNvPr id="15" name="rw-4-badge"/>
+          <p:cNvSpPr/>
+          <p:nvPr/>
+        </p:nvSpPr>
+        <p:spPr>
+          <a:xfrm>
+            <a:off x="548640" y="4526280"/>
+            <a:ext cx="502920" cy="502920"/>
+          </a:xfrm>
+          <a:prstGeom prst="ellipse">
+            <a:avLst/>
+          </a:prstGeom>
+          <a:solidFill>
+            <a:schemeClr val="tx2"/>
+          </a:solidFill>
+          <a:ln w="12700">
+            <a:solidFill>
+              <a:schemeClr val="tx2"/>
+            </a:solidFill>
+            <a:prstDash val="solid"/>
+          </a:ln>
+        </p:spPr>
+      </p:sp>
+      <p:sp>
+        <p:nvSpPr>
+          <p:cNvPr id="16" name="rw-4-badge-text"/>
+          <p:cNvSpPr txBox="1"/>
+          <p:nvPr/>
+        </p:nvSpPr>
+        <p:spPr>
+          <a:xfrm>
+            <a:off x="548640" y="4526280"/>
+            <a:ext cx="502920" cy="502920"/>
+          </a:xfrm>
+          <a:prstGeom prst="rect">
+            <a:avLst/>
+          </a:prstGeom>
+          <a:noFill/>
+          <a:ln/>
+        </p:spPr>
+        <p:txBody>
+          <a:bodyPr wrap="square" lIns="0" tIns="0" rIns="0" bIns="0" rtlCol="0" anchor="ctr"/>
+          <a:lstStyle/>
+          <a:p>
+            <a:pPr algn="ctr" indent="0" marL="0">
+              <a:buNone/>
+            </a:pPr>
+            <a:r>
+              <a:rPr lang="en-US" sz="1600" b="1" dirty="0">
+                <a:solidFill>
+                  <a:schemeClr val="bg1"/>
+                </a:solidFill>
+              </a:rPr>
+              <a:t>5</a:t>
+            </a:r>
+            <a:endParaRPr lang="en-US" sz="1600" dirty="0"/>
+          </a:p>
+        </p:txBody>
+      </p:sp>
+      <p:sp>
+        <p:nvSpPr>
+          <p:cNvPr id="17" name="rw-4-t"/>
+          <p:cNvSpPr txBox="1"/>
+          <p:nvPr/>
+        </p:nvSpPr>
+        <p:spPr>
+          <a:xfrm>
+            <a:off x="1234440" y="4480560"/>
+            <a:ext cx="4754880" cy="1417320"/>
+          </a:xfrm>
+          <a:prstGeom prst="rect">
+            <a:avLst/>
+          </a:prstGeom>
+          <a:noFill/>
+          <a:ln/>
+        </p:spPr>
+        <p:txBody>
+          <a:bodyPr wrap="square" lIns="0" tIns="0" rIns="0" bIns="0" rtlCol="0" anchor="t"/>
+          <a:lstStyle/>
+          <a:p>
+            <a:pPr indent="0" marL="0">
+              <a:spcAft>
+                <a:spcPts val="300"/>
+              </a:spcAft>
+              <a:buNone/>
+            </a:pPr>
+            <a:r>
+              <a:rPr lang="en-US" sz="1700" b="1" dirty="0">
+                <a:solidFill>
+                  <a:schemeClr val="tx1"/>
+                </a:solidFill>
+              </a:rPr>
+              <a:t>Map the profile type</a:t>
+            </a:r>
+            <a:endParaRPr lang="en-US" sz="1700" dirty="0"/>
+          </a:p>
+          <a:p>
+            <a:pPr indent="0" marL="0">
+              <a:spcAft>
+                <a:spcPts val="300"/>
+              </a:spcAft>
+              <a:buNone/>
+            </a:pPr>
+            <a:r>
+              <a:rPr lang="en-US" sz="1350" dirty="0">
+                <a:solidFill>
+                  <a:schemeClr val="tx1"/>
+                </a:solidFill>
+              </a:rPr>
+              <a:t>TryMapProfileType has no Trainer / Trainee case and ProfileTypes has no value for them. Agree with the platform team.</a:t>
+            </a:r>
+            <a:endParaRPr lang="en-US" sz="1700" dirty="0"/>
+          </a:p>
+          <a:p>
+            <a:pPr indent="0" marL="0">
+              <a:spcAft>
+                <a:spcPts val="300"/>
+              </a:spcAft>
+              <a:buNone/>
+            </a:pPr>
+            <a:r>
+              <a:rPr lang="en-US" sz="1000" dirty="0">
+                <a:solidFill>
+                  <a:schemeClr val="tx2"/>
+                </a:solidFill>
+                <a:latin typeface="Courier New" pitchFamily="34" charset="0"/>
+                <a:ea typeface="Courier New" pitchFamily="34" charset="-122"/>
+                <a:cs typeface="Courier New" pitchFamily="34" charset="-120"/>
+              </a:rPr>
+              <a:t>Bidding_Core/Helpers/IdentityAccessAdminRules.cs · Bidding_Models/Enums.cs</a:t>
+            </a:r>
+            <a:endParaRPr lang="en-US" sz="1700" dirty="0"/>
+          </a:p>
+        </p:txBody>
+      </p:sp>
+      <p:sp>
+        <p:nvSpPr>
+          <p:cNvPr id="18" name="rw-5-badge"/>
+          <p:cNvSpPr/>
+          <p:nvPr/>
+        </p:nvSpPr>
+        <p:spPr>
+          <a:xfrm>
+            <a:off x="6172200" y="4526280"/>
+            <a:ext cx="502920" cy="502920"/>
+          </a:xfrm>
+          <a:prstGeom prst="ellipse">
+            <a:avLst/>
+          </a:prstGeom>
+          <a:solidFill>
+            <a:schemeClr val="accent2"/>
+          </a:solidFill>
+          <a:ln w="12700">
+            <a:solidFill>
+              <a:schemeClr val="accent2"/>
+            </a:solidFill>
+            <a:prstDash val="solid"/>
+          </a:ln>
+        </p:spPr>
+      </p:sp>
+      <p:sp>
+        <p:nvSpPr>
+          <p:cNvPr id="19" name="rw-5-badge-text"/>
+          <p:cNvSpPr txBox="1"/>
+          <p:nvPr/>
+        </p:nvSpPr>
+        <p:spPr>
+          <a:xfrm>
+            <a:off x="6172200" y="4526280"/>
+            <a:ext cx="502920" cy="502920"/>
+          </a:xfrm>
+          <a:prstGeom prst="rect">
+            <a:avLst/>
+          </a:prstGeom>
+          <a:noFill/>
+          <a:ln/>
+        </p:spPr>
+        <p:txBody>
+          <a:bodyPr wrap="square" lIns="0" tIns="0" rIns="0" bIns="0" rtlCol="0" anchor="ctr"/>
+          <a:lstStyle/>
+          <a:p>
+            <a:pPr algn="ctr" indent="0" marL="0">
+              <a:buNone/>
+            </a:pPr>
+            <a:r>
+              <a:rPr lang="en-US" sz="1600" b="1" dirty="0">
+                <a:solidFill>
+                  <a:schemeClr val="bg1"/>
+                </a:solidFill>
+              </a:rPr>
+              <a:t>6</a:t>
+            </a:r>
+            <a:endParaRPr lang="en-US" sz="1600" dirty="0"/>
+          </a:p>
+        </p:txBody>
+      </p:sp>
+      <p:sp>
+        <p:nvSpPr>
+          <p:cNvPr id="20" name="rw-5-t"/>
+          <p:cNvSpPr txBox="1"/>
+          <p:nvPr/>
+        </p:nvSpPr>
+        <p:spPr>
+          <a:xfrm>
+            <a:off x="6858000" y="4480560"/>
+            <a:ext cx="4754880" cy="1417320"/>
+          </a:xfrm>
+          <a:prstGeom prst="rect">
+            <a:avLst/>
+          </a:prstGeom>
+          <a:noFill/>
+          <a:ln/>
+        </p:spPr>
+        <p:txBody>
+          <a:bodyPr wrap="square" lIns="0" tIns="0" rIns="0" bIns="0" rtlCol="0" anchor="t"/>
+          <a:lstStyle/>
+          <a:p>
+            <a:pPr indent="0" marL="0">
+              <a:spcAft>
+                <a:spcPts val="300"/>
+              </a:spcAft>
+              <a:buNone/>
+            </a:pPr>
+            <a:r>
+              <a:rPr lang="en-US" sz="1700" b="1" dirty="0">
+                <a:solidFill>
+                  <a:schemeClr val="tx1"/>
+                </a:solidFill>
+              </a:rPr>
+              <a:t>Decide the corporate trainee</a:t>
+            </a:r>
+            <a:endParaRPr lang="en-US" sz="1700" dirty="0"/>
+          </a:p>
+          <a:p>
+            <a:pPr indent="0" marL="0">
+              <a:spcAft>
+                <a:spcPts val="300"/>
+              </a:spcAft>
+              <a:buNone/>
+            </a:pPr>
+            <a:r>
+              <a:rPr lang="en-US" sz="1350" dirty="0">
+                <a:solidFill>
+                  <a:schemeClr val="tx1"/>
+                </a:solidFill>
+              </a:rPr>
+              <a:t>If needed: new user group, template role and role id, with its pages and claims.</a:t>
+            </a:r>
+            <a:endParaRPr lang="en-US" sz="1700" dirty="0"/>
+          </a:p>
+          <a:p>
+            <a:pPr indent="0" marL="0">
+              <a:spcAft>
+                <a:spcPts val="300"/>
+              </a:spcAft>
+              <a:buNone/>
+            </a:pPr>
+            <a:r>
+              <a:rPr lang="en-US" sz="1000" dirty="0">
+                <a:solidFill>
+                  <a:schemeClr val="tx2"/>
+                </a:solidFill>
+                <a:latin typeface="Courier New" pitchFamily="34" charset="0"/>
+                <a:ea typeface="Courier New" pitchFamily="34" charset="-122"/>
+                <a:cs typeface="Courier New" pitchFamily="34" charset="-120"/>
+              </a:rPr>
+              <a:t>Bidding_DLL/Seeding/IdentityAccessSeedData.cs  (UserGroups, TemplateRoleIds)</a:t>
+            </a:r>
+            <a:endParaRPr lang="en-US" sz="1700" dirty="0"/>
+          </a:p>
+        </p:txBody>
+      </p:sp>
+      <p:sp>
+        <p:nvSpPr>
+          <p:cNvPr id="25" name="Slide Number Placeholder 0"/>
+          <p:cNvSpPr>
+            <a:spLocks noGrp="1"/>
+          </p:cNvSpPr>
+          <p:nvPr>
+            <p:ph type="sldNum" sz="quarter" idx="4294967295"/>
+          </p:nvPr>
+        </p:nvSpPr>
+        <p:spPr>
+          <a:xfrm>
+            <a:off x="11155680" y="6400800"/>
+            <a:ext cx="457200" cy="274320"/>
+          </a:xfrm>
+          <a:prstGeom prst="rect">
+            <a:avLst/>
+          </a:prstGeom>
+          <a:extLst>
+            <a:ext uri="{C572A759-6A51-4108-AA02-DFA0A04FC94B}">
+              <ma14:wrappingTextBoxFlag xmlns:ma14="http://schemas.microsoft.com/office/mac/drawingml/2011/main" val="0"/>
+            </a:ext>
+          </a:extLst>
+        </p:spPr>
+        <p:txBody>
+          <a:bodyPr/>
+          <a:lstStyle>
+            <a:lvl1pPr>
+              <a:defRPr sz="1000">
+                <a:solidFill>
+                  <a:schemeClr val="accent6"/>
+                </a:solidFill>
+              </a:defRPr>
+            </a:lvl1pPr>
+          </a:lstStyle>
+          <a:p>
+            <a:pPr algn="r"/>
+            <a:fld id="{F7021451-1387-4CA6-816F-3879F97B5CBC}" type="slidenum">
+              <a:rPr b="0" lang="en-US"/>
+              <a:t>14</a:t>
+            </a:fld>
+            <a:endParaRPr lang="en-US"/>
+          </a:p>
+        </p:txBody>
+      </p:sp>
+    </p:spTree>
+  </p:cSld>
+  <p:clrMapOvr>
+    <a:masterClrMapping/>
+  </p:clrMapOvr>
+</p:sld>
+</file>
+
+<file path=ppt/slides/slide15.xml><?xml version="1.0" encoding="utf-8"?>
+<p:sld xmlns:a="http://schemas.openxmlformats.org/drawingml/2006/main" xmlns:r="http://schemas.openxmlformats.org/officeDocument/2006/relationships" xmlns:p="http://schemas.openxmlformats.org/presentationml/2006/main">
+  <p:cSld name="Slide 15">
+    <p:spTree>
+      <p:nvGrpSpPr>
+        <p:cNvPr id="1" name=""/>
+        <p:cNvGrpSpPr/>
+        <p:nvPr/>
+      </p:nvGrpSpPr>
+      <p:grpSpPr>
+        <a:xfrm>
+          <a:off x="0" y="0"/>
+          <a:ext cx="0" cy="0"/>
+          <a:chOff x="0" y="0"/>
+          <a:chExt cx="0" cy="0"/>
+        </a:xfrm>
+      </p:grpSpPr>
+      <p:sp>
+        <p:nvSpPr>
+          <p:cNvPr id="2" name="Text 0"/>
+          <p:cNvSpPr/>
+          <p:nvPr>
+            <p:ph idx="100" type="title" hasCustomPrompt="1"/>
+          </p:nvPr>
+        </p:nvSpPr>
+        <p:spPr>
+          <a:xfrm>
+            <a:off x="548640" y="365760"/>
+            <a:ext cx="11064240" cy="822960"/>
+          </a:xfrm>
+          <a:prstGeom prst="rect">
+            <a:avLst/>
+          </a:prstGeom>
+          <a:noFill/>
+          <a:ln/>
+        </p:spPr>
+        <p:txBody>
+          <a:bodyPr wrap="square" lIns="0" tIns="0" rIns="0" bIns="0" rtlCol="0" anchor="ctr"/>
+          <a:lstStyle/>
+          <a:p>
+            <a:pPr algn="l" indent="0" marL="0">
+              <a:buNone/>
+            </a:pPr>
+            <a:r>
+              <a:rPr lang="en-US" sz="3600" b="1" dirty="0">
+                <a:solidFill>
+                  <a:schemeClr val="tx2"/>
+                </a:solidFill>
+              </a:rPr>
+              <a:t>Adding a new page: the checklist</a:t>
+            </a:r>
+            <a:endParaRPr lang="en-US" sz="3600" dirty="0"/>
+          </a:p>
+        </p:txBody>
+      </p:sp>
+      <p:sp>
+        <p:nvSpPr>
+          <p:cNvPr id="3" name="chk-0-badge"/>
+          <p:cNvSpPr/>
+          <p:nvPr/>
+        </p:nvSpPr>
+        <p:spPr>
+          <a:xfrm>
+            <a:off x="548640" y="1572768"/>
+            <a:ext cx="502920" cy="502920"/>
+          </a:xfrm>
+          <a:prstGeom prst="ellipse">
+            <a:avLst/>
+          </a:prstGeom>
+          <a:solidFill>
+            <a:schemeClr val="tx2"/>
+          </a:solidFill>
+          <a:ln w="12700">
+            <a:solidFill>
+              <a:schemeClr val="tx2"/>
+            </a:solidFill>
+            <a:prstDash val="solid"/>
+          </a:ln>
+        </p:spPr>
+      </p:sp>
+      <p:sp>
+        <p:nvSpPr>
+          <p:cNvPr id="4" name="chk-0-badge-text"/>
+          <p:cNvSpPr txBox="1"/>
+          <p:nvPr/>
+        </p:nvSpPr>
+        <p:spPr>
+          <a:xfrm>
+            <a:off x="548640" y="1572768"/>
+            <a:ext cx="502920" cy="502920"/>
+          </a:xfrm>
+          <a:prstGeom prst="rect">
+            <a:avLst/>
+          </a:prstGeom>
+          <a:noFill/>
+          <a:ln/>
+        </p:spPr>
+        <p:txBody>
+          <a:bodyPr wrap="square" lIns="0" tIns="0" rIns="0" bIns="0" rtlCol="0" anchor="ctr"/>
+          <a:lstStyle/>
+          <a:p>
+            <a:pPr algn="ctr" indent="0" marL="0">
+              <a:buNone/>
+            </a:pPr>
+            <a:r>
+              <a:rPr lang="en-US" sz="1600" b="1" dirty="0">
+                <a:solidFill>
+                  <a:schemeClr val="bg1"/>
+                </a:solidFill>
+              </a:rPr>
+              <a:t>1</a:t>
+            </a:r>
+            <a:endParaRPr lang="en-US" sz="1600" dirty="0"/>
+          </a:p>
+        </p:txBody>
+      </p:sp>
+      <p:sp>
+        <p:nvSpPr>
+          <p:cNvPr id="5" name="chk-0-t"/>
+          <p:cNvSpPr txBox="1"/>
+          <p:nvPr/>
+        </p:nvSpPr>
+        <p:spPr>
+          <a:xfrm>
+            <a:off x="1280160" y="1417320"/>
+            <a:ext cx="4754880" cy="822960"/>
+          </a:xfrm>
+          <a:prstGeom prst="rect">
+            <a:avLst/>
+          </a:prstGeom>
+          <a:noFill/>
+          <a:ln/>
+        </p:spPr>
+        <p:txBody>
+          <a:bodyPr wrap="square" lIns="0" tIns="0" rIns="0" bIns="0" rtlCol="0" anchor="ctr"/>
+          <a:lstStyle/>
+          <a:p>
+            <a:pPr indent="0" marL="0">
+              <a:spcAft>
+                <a:spcPts val="200"/>
+              </a:spcAft>
+              <a:buNone/>
+            </a:pPr>
+            <a:r>
+              <a:rPr lang="en-US" sz="1700" dirty="0">
+                <a:solidFill>
+                  <a:schemeClr val="tx1"/>
+                </a:solidFill>
+              </a:rPr>
+              <a:t>Route and sidebar link</a:t>
+            </a:r>
+            <a:endParaRPr lang="en-US" sz="1700" dirty="0"/>
+          </a:p>
+          <a:p>
+            <a:pPr indent="0" marL="0">
+              <a:spcAft>
+                <a:spcPts val="200"/>
+              </a:spcAft>
+              <a:buNone/>
+            </a:pPr>
+            <a:r>
+              <a:rPr lang="en-US" sz="1050" dirty="0">
+                <a:solidFill>
+                  <a:schemeClr val="tx2"/>
+                </a:solidFill>
+                <a:latin typeface="Courier New" pitchFamily="34" charset="0"/>
+                <a:ea typeface="Courier New" pitchFamily="34" charset="-122"/>
+                <a:cs typeface="Courier New" pitchFamily="34" charset="-120"/>
+              </a:rPr>
+              <a:t>TrainingModule/src/app/app.routes.ts</a:t>
+            </a:r>
+            <a:endParaRPr lang="en-US" sz="1700" dirty="0"/>
+          </a:p>
+        </p:txBody>
+      </p:sp>
+      <p:sp>
+        <p:nvSpPr>
+          <p:cNvPr id="6" name="chk-1-badge"/>
+          <p:cNvSpPr/>
+          <p:nvPr/>
+        </p:nvSpPr>
+        <p:spPr>
+          <a:xfrm>
+            <a:off x="548640" y="2670048"/>
+            <a:ext cx="502920" cy="502920"/>
+          </a:xfrm>
+          <a:prstGeom prst="ellipse">
+            <a:avLst/>
+          </a:prstGeom>
+          <a:solidFill>
+            <a:schemeClr val="tx2"/>
+          </a:solidFill>
+          <a:ln w="12700">
+            <a:solidFill>
+              <a:schemeClr val="tx2"/>
+            </a:solidFill>
+            <a:prstDash val="solid"/>
+          </a:ln>
+        </p:spPr>
+      </p:sp>
+      <p:sp>
+        <p:nvSpPr>
+          <p:cNvPr id="7" name="chk-1-badge-text"/>
+          <p:cNvSpPr txBox="1"/>
+          <p:nvPr/>
+        </p:nvSpPr>
+        <p:spPr>
+          <a:xfrm>
+            <a:off x="548640" y="2670048"/>
+            <a:ext cx="502920" cy="502920"/>
+          </a:xfrm>
+          <a:prstGeom prst="rect">
+            <a:avLst/>
+          </a:prstGeom>
+          <a:noFill/>
+          <a:ln/>
+        </p:spPr>
+        <p:txBody>
+          <a:bodyPr wrap="square" lIns="0" tIns="0" rIns="0" bIns="0" rtlCol="0" anchor="ctr"/>
+          <a:lstStyle/>
+          <a:p>
+            <a:pPr algn="ctr" indent="0" marL="0">
+              <a:buNone/>
+            </a:pPr>
+            <a:r>
+              <a:rPr lang="en-US" sz="1600" b="1" dirty="0">
+                <a:solidFill>
+                  <a:schemeClr val="bg1"/>
+                </a:solidFill>
+              </a:rPr>
+              <a:t>2</a:t>
+            </a:r>
+            <a:endParaRPr lang="en-US" sz="1600" dirty="0"/>
+          </a:p>
+        </p:txBody>
+      </p:sp>
+      <p:sp>
+        <p:nvSpPr>
+          <p:cNvPr id="8" name="chk-1-t"/>
+          <p:cNvSpPr txBox="1"/>
+          <p:nvPr/>
+        </p:nvSpPr>
+        <p:spPr>
+          <a:xfrm>
+            <a:off x="1280160" y="2514600"/>
+            <a:ext cx="4754880" cy="822960"/>
+          </a:xfrm>
+          <a:prstGeom prst="rect">
+            <a:avLst/>
+          </a:prstGeom>
+          <a:noFill/>
+          <a:ln/>
+        </p:spPr>
+        <p:txBody>
+          <a:bodyPr wrap="square" lIns="0" tIns="0" rIns="0" bIns="0" rtlCol="0" anchor="ctr"/>
+          <a:lstStyle/>
+          <a:p>
+            <a:pPr indent="0" marL="0">
+              <a:spcAft>
+                <a:spcPts val="200"/>
+              </a:spcAft>
+              <a:buNone/>
+            </a:pPr>
+            <a:r>
+              <a:rPr lang="en-US" sz="1700" dirty="0">
+                <a:solidFill>
+                  <a:schemeClr val="tx1"/>
+                </a:solidFill>
+              </a:rPr>
+              <a:t>AppPage seed entry with the same URL</a:t>
+            </a:r>
+            <a:endParaRPr lang="en-US" sz="1700" dirty="0"/>
+          </a:p>
+          <a:p>
+            <a:pPr indent="0" marL="0">
+              <a:spcAft>
+                <a:spcPts val="200"/>
+              </a:spcAft>
+              <a:buNone/>
+            </a:pPr>
+            <a:r>
+              <a:rPr lang="en-US" sz="1050" dirty="0">
+                <a:solidFill>
+                  <a:schemeClr val="tx2"/>
+                </a:solidFill>
+                <a:latin typeface="Courier New" pitchFamily="34" charset="0"/>
+                <a:ea typeface="Courier New" pitchFamily="34" charset="-122"/>
+                <a:cs typeface="Courier New" pitchFamily="34" charset="-120"/>
+              </a:rPr>
+              <a:t>Bidding_DLL/Seeding/IdentityAccessAppPagesSeedData.cs</a:t>
+            </a:r>
+            <a:endParaRPr lang="en-US" sz="1700" dirty="0"/>
+          </a:p>
+        </p:txBody>
+      </p:sp>
+      <p:sp>
+        <p:nvSpPr>
+          <p:cNvPr id="9" name="chk-2-badge"/>
+          <p:cNvSpPr/>
+          <p:nvPr/>
+        </p:nvSpPr>
+        <p:spPr>
+          <a:xfrm>
+            <a:off x="548640" y="3767328"/>
+            <a:ext cx="502920" cy="502920"/>
+          </a:xfrm>
+          <a:prstGeom prst="ellipse">
+            <a:avLst/>
+          </a:prstGeom>
+          <a:solidFill>
+            <a:schemeClr val="tx2"/>
+          </a:solidFill>
+          <a:ln w="12700">
+            <a:solidFill>
+              <a:schemeClr val="tx2"/>
+            </a:solidFill>
+            <a:prstDash val="solid"/>
+          </a:ln>
+        </p:spPr>
+      </p:sp>
+      <p:sp>
+        <p:nvSpPr>
+          <p:cNvPr id="10" name="chk-2-badge-text"/>
+          <p:cNvSpPr txBox="1"/>
+          <p:nvPr/>
+        </p:nvSpPr>
+        <p:spPr>
+          <a:xfrm>
+            <a:off x="548640" y="3767328"/>
+            <a:ext cx="502920" cy="502920"/>
+          </a:xfrm>
+          <a:prstGeom prst="rect">
+            <a:avLst/>
+          </a:prstGeom>
+          <a:noFill/>
+          <a:ln/>
+        </p:spPr>
+        <p:txBody>
+          <a:bodyPr wrap="square" lIns="0" tIns="0" rIns="0" bIns="0" rtlCol="0" anchor="ctr"/>
+          <a:lstStyle/>
+          <a:p>
+            <a:pPr algn="ctr" indent="0" marL="0">
+              <a:buNone/>
+            </a:pPr>
+            <a:r>
+              <a:rPr lang="en-US" sz="1600" b="1" dirty="0">
+                <a:solidFill>
+                  <a:schemeClr val="bg1"/>
+                </a:solidFill>
+              </a:rPr>
+              <a:t>3</a:t>
+            </a:r>
+            <a:endParaRPr lang="en-US" sz="1600" dirty="0"/>
+          </a:p>
+        </p:txBody>
+      </p:sp>
+      <p:sp>
+        <p:nvSpPr>
+          <p:cNvPr id="11" name="chk-2-t"/>
+          <p:cNvSpPr txBox="1"/>
+          <p:nvPr/>
+        </p:nvSpPr>
+        <p:spPr>
+          <a:xfrm>
+            <a:off x="1280160" y="3611880"/>
+            <a:ext cx="4754880" cy="822960"/>
+          </a:xfrm>
+          <a:prstGeom prst="rect">
+            <a:avLst/>
+          </a:prstGeom>
+          <a:noFill/>
+          <a:ln/>
+        </p:spPr>
+        <p:txBody>
+          <a:bodyPr wrap="square" lIns="0" tIns="0" rIns="0" bIns="0" rtlCol="0" anchor="ctr"/>
+          <a:lstStyle/>
+          <a:p>
+            <a:pPr indent="0" marL="0">
+              <a:spcAft>
+                <a:spcPts val="200"/>
+              </a:spcAft>
+              <a:buNone/>
+            </a:pPr>
+            <a:r>
+              <a:rPr lang="en-US" sz="1700" dirty="0">
+                <a:solidFill>
+                  <a:schemeClr val="tx1"/>
+                </a:solidFill>
+              </a:rPr>
+              <a:t>API endpoint + service rule + DTOs</a:t>
+            </a:r>
+            <a:endParaRPr lang="en-US" sz="1700" dirty="0"/>
+          </a:p>
+          <a:p>
+            <a:pPr indent="0" marL="0">
+              <a:spcAft>
+                <a:spcPts val="200"/>
+              </a:spcAft>
+              <a:buNone/>
+            </a:pPr>
+            <a:r>
+              <a:rPr lang="en-US" sz="1050" dirty="0">
+                <a:solidFill>
+                  <a:schemeClr val="tx2"/>
+                </a:solidFill>
+                <a:latin typeface="Courier New" pitchFamily="34" charset="0"/>
+                <a:ea typeface="Courier New" pitchFamily="34" charset="-122"/>
+                <a:cs typeface="Courier New" pitchFamily="34" charset="-120"/>
+              </a:rPr>
+              <a:t>Bidding_API/Controllers/V2/ · Bidding_Core/Services/</a:t>
+            </a:r>
+            <a:endParaRPr lang="en-US" sz="1700" dirty="0"/>
+          </a:p>
+        </p:txBody>
+      </p:sp>
+      <p:sp>
+        <p:nvSpPr>
+          <p:cNvPr id="12" name="chk-3-badge"/>
+          <p:cNvSpPr/>
+          <p:nvPr/>
+        </p:nvSpPr>
+        <p:spPr>
+          <a:xfrm>
+            <a:off x="548640" y="4864608"/>
+            <a:ext cx="502920" cy="502920"/>
+          </a:xfrm>
+          <a:prstGeom prst="ellipse">
+            <a:avLst/>
+          </a:prstGeom>
+          <a:solidFill>
+            <a:schemeClr val="tx2"/>
+          </a:solidFill>
+          <a:ln w="12700">
+            <a:solidFill>
+              <a:schemeClr val="tx2"/>
+            </a:solidFill>
+            <a:prstDash val="solid"/>
+          </a:ln>
+        </p:spPr>
+      </p:sp>
+      <p:sp>
+        <p:nvSpPr>
+          <p:cNvPr id="13" name="chk-3-badge-text"/>
+          <p:cNvSpPr txBox="1"/>
+          <p:nvPr/>
+        </p:nvSpPr>
+        <p:spPr>
+          <a:xfrm>
+            <a:off x="548640" y="4864608"/>
+            <a:ext cx="502920" cy="502920"/>
+          </a:xfrm>
+          <a:prstGeom prst="rect">
+            <a:avLst/>
+          </a:prstGeom>
+          <a:noFill/>
+          <a:ln/>
+        </p:spPr>
+        <p:txBody>
+          <a:bodyPr wrap="square" lIns="0" tIns="0" rIns="0" bIns="0" rtlCol="0" anchor="ctr"/>
+          <a:lstStyle/>
+          <a:p>
+            <a:pPr algn="ctr" indent="0" marL="0">
+              <a:buNone/>
+            </a:pPr>
+            <a:r>
+              <a:rPr lang="en-US" sz="1600" b="1" dirty="0">
+                <a:solidFill>
+                  <a:schemeClr val="bg1"/>
+                </a:solidFill>
+              </a:rPr>
+              <a:t>4</a:t>
+            </a:r>
+            <a:endParaRPr lang="en-US" sz="1600" dirty="0"/>
+          </a:p>
+        </p:txBody>
+      </p:sp>
+      <p:sp>
+        <p:nvSpPr>
+          <p:cNvPr id="14" name="chk-3-t"/>
+          <p:cNvSpPr txBox="1"/>
+          <p:nvPr/>
+        </p:nvSpPr>
+        <p:spPr>
+          <a:xfrm>
+            <a:off x="1280160" y="4709160"/>
+            <a:ext cx="4754880" cy="822960"/>
+          </a:xfrm>
+          <a:prstGeom prst="rect">
+            <a:avLst/>
+          </a:prstGeom>
+          <a:noFill/>
+          <a:ln/>
+        </p:spPr>
+        <p:txBody>
+          <a:bodyPr wrap="square" lIns="0" tIns="0" rIns="0" bIns="0" rtlCol="0" anchor="ctr"/>
+          <a:lstStyle/>
+          <a:p>
+            <a:pPr indent="0" marL="0">
+              <a:spcAft>
+                <a:spcPts val="200"/>
+              </a:spcAft>
+              <a:buNone/>
+            </a:pPr>
+            <a:r>
+              <a:rPr lang="en-US" sz="1700" dirty="0">
+                <a:solidFill>
+                  <a:schemeClr val="tx1"/>
+                </a:solidFill>
+              </a:rPr>
+              <a:t>Data service, then NgRx slice if shared</a:t>
+            </a:r>
+            <a:endParaRPr lang="en-US" sz="1700" dirty="0"/>
+          </a:p>
+          <a:p>
+            <a:pPr indent="0" marL="0">
+              <a:spcAft>
+                <a:spcPts val="200"/>
+              </a:spcAft>
+              <a:buNone/>
+            </a:pPr>
+            <a:r>
+              <a:rPr lang="en-US" sz="1050" dirty="0">
+                <a:solidFill>
+                  <a:schemeClr val="tx2"/>
+                </a:solidFill>
+                <a:latin typeface="Courier New" pitchFamily="34" charset="0"/>
+                <a:ea typeface="Courier New" pitchFamily="34" charset="-122"/>
+                <a:cs typeface="Courier New" pitchFamily="34" charset="-120"/>
+              </a:rPr>
+              <a:t>TrainingModule/src/app/core/store/&lt;feature&gt;/</a:t>
+            </a:r>
+            <a:endParaRPr lang="en-US" sz="1700" dirty="0"/>
+          </a:p>
+        </p:txBody>
+      </p:sp>
+      <p:sp>
+        <p:nvSpPr>
+          <p:cNvPr id="15" name="chk-4-badge"/>
+          <p:cNvSpPr/>
+          <p:nvPr/>
+        </p:nvSpPr>
+        <p:spPr>
+          <a:xfrm>
+            <a:off x="6172200" y="1572768"/>
+            <a:ext cx="502920" cy="502920"/>
+          </a:xfrm>
+          <a:prstGeom prst="ellipse">
+            <a:avLst/>
+          </a:prstGeom>
+          <a:solidFill>
+            <a:schemeClr val="tx2"/>
+          </a:solidFill>
+          <a:ln w="12700">
+            <a:solidFill>
+              <a:schemeClr val="tx2"/>
+            </a:solidFill>
+            <a:prstDash val="solid"/>
+          </a:ln>
+        </p:spPr>
+      </p:sp>
+      <p:sp>
+        <p:nvSpPr>
+          <p:cNvPr id="16" name="chk-4-badge-text"/>
+          <p:cNvSpPr txBox="1"/>
+          <p:nvPr/>
+        </p:nvSpPr>
+        <p:spPr>
+          <a:xfrm>
+            <a:off x="6172200" y="1572768"/>
+            <a:ext cx="502920" cy="502920"/>
+          </a:xfrm>
+          <a:prstGeom prst="rect">
+            <a:avLst/>
+          </a:prstGeom>
+          <a:noFill/>
+          <a:ln/>
+        </p:spPr>
+        <p:txBody>
+          <a:bodyPr wrap="square" lIns="0" tIns="0" rIns="0" bIns="0" rtlCol="0" anchor="ctr"/>
+          <a:lstStyle/>
+          <a:p>
+            <a:pPr algn="ctr" indent="0" marL="0">
+              <a:buNone/>
+            </a:pPr>
+            <a:r>
+              <a:rPr lang="en-US" sz="1600" b="1" dirty="0">
+                <a:solidFill>
+                  <a:schemeClr val="bg1"/>
+                </a:solidFill>
+              </a:rPr>
+              <a:t>5</a:t>
+            </a:r>
+            <a:endParaRPr lang="en-US" sz="1600" dirty="0"/>
+          </a:p>
+        </p:txBody>
+      </p:sp>
+      <p:sp>
+        <p:nvSpPr>
+          <p:cNvPr id="17" name="chk-4-t"/>
+          <p:cNvSpPr txBox="1"/>
+          <p:nvPr/>
+        </p:nvSpPr>
+        <p:spPr>
+          <a:xfrm>
+            <a:off x="6903720" y="1417320"/>
+            <a:ext cx="4754880" cy="822960"/>
+          </a:xfrm>
+          <a:prstGeom prst="rect">
+            <a:avLst/>
+          </a:prstGeom>
+          <a:noFill/>
+          <a:ln/>
+        </p:spPr>
+        <p:txBody>
+          <a:bodyPr wrap="square" lIns="0" tIns="0" rIns="0" bIns="0" rtlCol="0" anchor="ctr"/>
+          <a:lstStyle/>
+          <a:p>
+            <a:pPr indent="0" marL="0">
+              <a:spcAft>
+                <a:spcPts val="200"/>
+              </a:spcAft>
+              <a:buNone/>
+            </a:pPr>
+            <a:r>
+              <a:rPr lang="en-US" sz="1700" dirty="0">
+                <a:solidFill>
+                  <a:schemeClr val="tx1"/>
+                </a:solidFill>
+              </a:rPr>
+              <a:t>Form pipeline, executor, validators</a:t>
+            </a:r>
+            <a:endParaRPr lang="en-US" sz="1700" dirty="0"/>
+          </a:p>
+          <a:p>
+            <a:pPr indent="0" marL="0">
+              <a:spcAft>
+                <a:spcPts val="200"/>
+              </a:spcAft>
+              <a:buNone/>
+            </a:pPr>
+            <a:r>
+              <a:rPr lang="en-US" sz="1050" dirty="0">
+                <a:solidFill>
+                  <a:schemeClr val="tx2"/>
+                </a:solidFill>
+                <a:latin typeface="Courier New" pitchFamily="34" charset="0"/>
+                <a:ea typeface="Courier New" pitchFamily="34" charset="-122"/>
+                <a:cs typeface="Courier New" pitchFamily="34" charset="-120"/>
+              </a:rPr>
+              <a:t>TrainingModule/src/app/core/ui/form-pipeline.service.ts</a:t>
+            </a:r>
+            <a:endParaRPr lang="en-US" sz="1700" dirty="0"/>
+          </a:p>
+        </p:txBody>
+      </p:sp>
+      <p:sp>
+        <p:nvSpPr>
+          <p:cNvPr id="18" name="chk-5-badge"/>
+          <p:cNvSpPr/>
+          <p:nvPr/>
+        </p:nvSpPr>
+        <p:spPr>
+          <a:xfrm>
+            <a:off x="6172200" y="2670048"/>
+            <a:ext cx="502920" cy="502920"/>
+          </a:xfrm>
+          <a:prstGeom prst="ellipse">
+            <a:avLst/>
+          </a:prstGeom>
+          <a:solidFill>
+            <a:schemeClr val="tx2"/>
+          </a:solidFill>
+          <a:ln w="12700">
+            <a:solidFill>
+              <a:schemeClr val="tx2"/>
+            </a:solidFill>
+            <a:prstDash val="solid"/>
+          </a:ln>
+        </p:spPr>
+      </p:sp>
+      <p:sp>
+        <p:nvSpPr>
+          <p:cNvPr id="19" name="chk-5-badge-text"/>
+          <p:cNvSpPr txBox="1"/>
+          <p:nvPr/>
+        </p:nvSpPr>
+        <p:spPr>
+          <a:xfrm>
+            <a:off x="6172200" y="2670048"/>
+            <a:ext cx="502920" cy="502920"/>
+          </a:xfrm>
+          <a:prstGeom prst="rect">
+            <a:avLst/>
+          </a:prstGeom>
+          <a:noFill/>
+          <a:ln/>
+        </p:spPr>
+        <p:txBody>
+          <a:bodyPr wrap="square" lIns="0" tIns="0" rIns="0" bIns="0" rtlCol="0" anchor="ctr"/>
+          <a:lstStyle/>
+          <a:p>
+            <a:pPr algn="ctr" indent="0" marL="0">
+              <a:buNone/>
+            </a:pPr>
+            <a:r>
+              <a:rPr lang="en-US" sz="1600" b="1" dirty="0">
+                <a:solidFill>
+                  <a:schemeClr val="bg1"/>
+                </a:solidFill>
+              </a:rPr>
+              <a:t>6</a:t>
+            </a:r>
+            <a:endParaRPr lang="en-US" sz="1600" dirty="0"/>
+          </a:p>
+        </p:txBody>
+      </p:sp>
+      <p:sp>
+        <p:nvSpPr>
+          <p:cNvPr id="20" name="chk-5-t"/>
+          <p:cNvSpPr txBox="1"/>
+          <p:nvPr/>
+        </p:nvSpPr>
+        <p:spPr>
+          <a:xfrm>
+            <a:off x="6903720" y="2514600"/>
+            <a:ext cx="4754880" cy="822960"/>
+          </a:xfrm>
+          <a:prstGeom prst="rect">
+            <a:avLst/>
+          </a:prstGeom>
+          <a:noFill/>
+          <a:ln/>
+        </p:spPr>
+        <p:txBody>
+          <a:bodyPr wrap="square" lIns="0" tIns="0" rIns="0" bIns="0" rtlCol="0" anchor="ctr"/>
+          <a:lstStyle/>
+          <a:p>
+            <a:pPr indent="0" marL="0">
+              <a:spcAft>
+                <a:spcPts val="200"/>
+              </a:spcAft>
+              <a:buNone/>
+            </a:pPr>
+            <a:r>
+              <a:rPr lang="en-US" sz="1700" dirty="0">
+                <a:solidFill>
+                  <a:schemeClr val="tx1"/>
+                </a:solidFill>
+              </a:rPr>
+              <a:t>English in templates, Arabic translations</a:t>
+            </a:r>
+            <a:endParaRPr lang="en-US" sz="1700" dirty="0"/>
+          </a:p>
+          <a:p>
+            <a:pPr indent="0" marL="0">
+              <a:spcAft>
+                <a:spcPts val="200"/>
+              </a:spcAft>
+              <a:buNone/>
+            </a:pPr>
+            <a:r>
+              <a:rPr lang="en-US" sz="1050" dirty="0">
+                <a:solidFill>
+                  <a:schemeClr val="tx2"/>
+                </a:solidFill>
+                <a:latin typeface="Courier New" pitchFamily="34" charset="0"/>
+                <a:ea typeface="Courier New" pitchFamily="34" charset="-122"/>
+                <a:cs typeface="Courier New" pitchFamily="34" charset="-120"/>
+              </a:rPr>
+              <a:t>TrainingModule/src/app/core/translations/&lt;area&gt;/</a:t>
+            </a:r>
+            <a:endParaRPr lang="en-US" sz="1700" dirty="0"/>
+          </a:p>
+        </p:txBody>
+      </p:sp>
+      <p:sp>
+        <p:nvSpPr>
+          <p:cNvPr id="21" name="chk-6-badge"/>
+          <p:cNvSpPr/>
+          <p:nvPr/>
+        </p:nvSpPr>
+        <p:spPr>
+          <a:xfrm>
+            <a:off x="6172200" y="3767328"/>
+            <a:ext cx="502920" cy="502920"/>
+          </a:xfrm>
+          <a:prstGeom prst="ellipse">
+            <a:avLst/>
+          </a:prstGeom>
+          <a:solidFill>
+            <a:schemeClr val="tx2"/>
+          </a:solidFill>
+          <a:ln w="12700">
+            <a:solidFill>
+              <a:schemeClr val="tx2"/>
+            </a:solidFill>
+            <a:prstDash val="solid"/>
+          </a:ln>
+        </p:spPr>
+      </p:sp>
+      <p:sp>
+        <p:nvSpPr>
+          <p:cNvPr id="22" name="chk-6-badge-text"/>
+          <p:cNvSpPr txBox="1"/>
+          <p:nvPr/>
+        </p:nvSpPr>
+        <p:spPr>
+          <a:xfrm>
+            <a:off x="6172200" y="3767328"/>
+            <a:ext cx="502920" cy="502920"/>
+          </a:xfrm>
+          <a:prstGeom prst="rect">
+            <a:avLst/>
+          </a:prstGeom>
+          <a:noFill/>
+          <a:ln/>
+        </p:spPr>
+        <p:txBody>
+          <a:bodyPr wrap="square" lIns="0" tIns="0" rIns="0" bIns="0" rtlCol="0" anchor="ctr"/>
+          <a:lstStyle/>
+          <a:p>
+            <a:pPr algn="ctr" indent="0" marL="0">
+              <a:buNone/>
+            </a:pPr>
+            <a:r>
+              <a:rPr lang="en-US" sz="1600" b="1" dirty="0">
+                <a:solidFill>
+                  <a:schemeClr val="bg1"/>
+                </a:solidFill>
+              </a:rPr>
+              <a:t>7</a:t>
+            </a:r>
+            <a:endParaRPr lang="en-US" sz="1600" dirty="0"/>
+          </a:p>
+        </p:txBody>
+      </p:sp>
+      <p:sp>
+        <p:nvSpPr>
+          <p:cNvPr id="23" name="chk-6-t"/>
+          <p:cNvSpPr txBox="1"/>
+          <p:nvPr/>
+        </p:nvSpPr>
+        <p:spPr>
+          <a:xfrm>
+            <a:off x="6903720" y="3611880"/>
+            <a:ext cx="4754880" cy="822960"/>
+          </a:xfrm>
+          <a:prstGeom prst="rect">
+            <a:avLst/>
+          </a:prstGeom>
+          <a:noFill/>
+          <a:ln/>
+        </p:spPr>
+        <p:txBody>
+          <a:bodyPr wrap="square" lIns="0" tIns="0" rIns="0" bIns="0" rtlCol="0" anchor="ctr"/>
+          <a:lstStyle/>
+          <a:p>
+            <a:pPr indent="0" marL="0">
+              <a:spcAft>
+                <a:spcPts val="200"/>
+              </a:spcAft>
+              <a:buNone/>
+            </a:pPr>
+            <a:r>
+              <a:rPr lang="en-US" sz="1700" dirty="0">
+                <a:solidFill>
+                  <a:schemeClr val="tx1"/>
+                </a:solidFill>
+              </a:rPr>
+              <a:t>Mobile layout and RTL checked</a:t>
+            </a:r>
+            <a:endParaRPr lang="en-US" sz="1700" dirty="0"/>
+          </a:p>
+        </p:txBody>
+      </p:sp>
+      <p:sp>
+        <p:nvSpPr>
+          <p:cNvPr id="24" name="chk-7-badge"/>
+          <p:cNvSpPr/>
+          <p:nvPr/>
+        </p:nvSpPr>
+        <p:spPr>
+          <a:xfrm>
+            <a:off x="6172200" y="4864608"/>
+            <a:ext cx="502920" cy="502920"/>
+          </a:xfrm>
+          <a:prstGeom prst="ellipse">
+            <a:avLst/>
+          </a:prstGeom>
+          <a:solidFill>
+            <a:schemeClr val="accent2"/>
+          </a:solidFill>
+          <a:ln w="12700">
+            <a:solidFill>
+              <a:schemeClr val="accent2"/>
+            </a:solidFill>
+            <a:prstDash val="solid"/>
+          </a:ln>
+        </p:spPr>
+      </p:sp>
+      <p:sp>
+        <p:nvSpPr>
+          <p:cNvPr id="25" name="chk-7-badge-text"/>
+          <p:cNvSpPr txBox="1"/>
+          <p:nvPr/>
+        </p:nvSpPr>
+        <p:spPr>
+          <a:xfrm>
+            <a:off x="6172200" y="4864608"/>
+            <a:ext cx="502920" cy="502920"/>
+          </a:xfrm>
+          <a:prstGeom prst="rect">
+            <a:avLst/>
+          </a:prstGeom>
+          <a:noFill/>
+          <a:ln/>
+        </p:spPr>
+        <p:txBody>
+          <a:bodyPr wrap="square" lIns="0" tIns="0" rIns="0" bIns="0" rtlCol="0" anchor="ctr"/>
+          <a:lstStyle/>
+          <a:p>
+            <a:pPr algn="ctr" indent="0" marL="0">
+              <a:buNone/>
+            </a:pPr>
+            <a:r>
+              <a:rPr lang="en-US" sz="1600" b="1" dirty="0">
+                <a:solidFill>
+                  <a:schemeClr val="bg1"/>
+                </a:solidFill>
+              </a:rPr>
+              <a:t>8</a:t>
+            </a:r>
+            <a:endParaRPr lang="en-US" sz="1600" dirty="0"/>
+          </a:p>
+        </p:txBody>
+      </p:sp>
+      <p:sp>
+        <p:nvSpPr>
+          <p:cNvPr id="26" name="chk-7-t"/>
+          <p:cNvSpPr txBox="1"/>
+          <p:nvPr/>
+        </p:nvSpPr>
+        <p:spPr>
+          <a:xfrm>
+            <a:off x="6903720" y="4709160"/>
+            <a:ext cx="4754880" cy="822960"/>
+          </a:xfrm>
+          <a:prstGeom prst="rect">
+            <a:avLst/>
+          </a:prstGeom>
+          <a:noFill/>
+          <a:ln/>
+        </p:spPr>
+        <p:txBody>
+          <a:bodyPr wrap="square" lIns="0" tIns="0" rIns="0" bIns="0" rtlCol="0" anchor="ctr"/>
+          <a:lstStyle/>
+          <a:p>
+            <a:pPr indent="0" marL="0">
+              <a:spcAft>
+                <a:spcPts val="200"/>
+              </a:spcAft>
+              <a:buNone/>
+            </a:pPr>
+            <a:r>
+              <a:rPr lang="en-US" sz="1700" dirty="0">
+                <a:solidFill>
+                  <a:schemeClr val="tx1"/>
+                </a:solidFill>
+              </a:rPr>
+              <a:t>2–3 tests for the new rule</a:t>
+            </a:r>
+            <a:endParaRPr lang="en-US" sz="1700" dirty="0"/>
+          </a:p>
+          <a:p>
+            <a:pPr indent="0" marL="0">
+              <a:spcAft>
+                <a:spcPts val="200"/>
+              </a:spcAft>
+              <a:buNone/>
+            </a:pPr>
+            <a:r>
+              <a:rPr lang="en-US" sz="1050" dirty="0">
+                <a:solidFill>
+                  <a:schemeClr val="tx2"/>
+                </a:solidFill>
+                <a:latin typeface="Courier New" pitchFamily="34" charset="0"/>
+                <a:ea typeface="Courier New" pitchFamily="34" charset="-122"/>
+                <a:cs typeface="Courier New" pitchFamily="34" charset="-120"/>
+              </a:rPr>
+              <a:t>Bidding_Core.Tests/ · &lt;component&gt;.spec.ts</a:t>
+            </a:r>
+            <a:endParaRPr lang="en-US" sz="1700" dirty="0"/>
+          </a:p>
+        </p:txBody>
+      </p:sp>
+      <p:sp>
+        <p:nvSpPr>
+          <p:cNvPr id="25" name="Slide Number Placeholder 0"/>
+          <p:cNvSpPr>
+            <a:spLocks noGrp="1"/>
+          </p:cNvSpPr>
+          <p:nvPr>
+            <p:ph type="sldNum" sz="quarter" idx="4294967295"/>
+          </p:nvPr>
+        </p:nvSpPr>
+        <p:spPr>
+          <a:xfrm>
+            <a:off x="11155680" y="6400800"/>
+            <a:ext cx="457200" cy="274320"/>
+          </a:xfrm>
+          <a:prstGeom prst="rect">
+            <a:avLst/>
+          </a:prstGeom>
+          <a:extLst>
+            <a:ext uri="{C572A759-6A51-4108-AA02-DFA0A04FC94B}">
+              <ma14:wrappingTextBoxFlag xmlns:ma14="http://schemas.microsoft.com/office/mac/drawingml/2011/main" val="0"/>
+            </a:ext>
+          </a:extLst>
+        </p:spPr>
+        <p:txBody>
+          <a:bodyPr/>
+          <a:lstStyle>
+            <a:lvl1pPr>
+              <a:defRPr sz="1000">
+                <a:solidFill>
+                  <a:schemeClr val="accent6"/>
+                </a:solidFill>
+              </a:defRPr>
+            </a:lvl1pPr>
+          </a:lstStyle>
+          <a:p>
+            <a:pPr algn="r"/>
+            <a:fld id="{F7021451-1387-4CA6-816F-3879F97B5CBC}" type="slidenum">
+              <a:rPr b="0" lang="en-US"/>
+              <a:t>15</a:t>
+            </a:fld>
+            <a:endParaRPr lang="en-US"/>
+          </a:p>
+        </p:txBody>
+      </p:sp>
+    </p:spTree>
+  </p:cSld>
+  <p:clrMapOvr>
+    <a:masterClrMapping/>
+  </p:clrMapOvr>
+</p:sld>
+</file>
+
+<file path=ppt/slides/slide16.xml><?xml version="1.0" encoding="utf-8"?>
+<p:sld xmlns:a="http://schemas.openxmlformats.org/drawingml/2006/main" xmlns:r="http://schemas.openxmlformats.org/officeDocument/2006/relationships" xmlns:p="http://schemas.openxmlformats.org/presentationml/2006/main">
+  <p:cSld name="Slide 16">
     <p:spTree>
       <p:nvGrpSpPr>
         <p:cNvPr id="1" name=""/>

</xml_diff>